<commit_message>
Update deck to match UI: screenshots, agent trace, fit check slides
Co-Authored-By: Claude Sonnet 5.5 <noreply@anthropic.com>
</commit_message>
<xml_diff>
--- a/DealScout.pptx
+++ b/DealScout.pptx
@@ -13,9 +13,11 @@
     <p:sldId id="261" r:id="rId7"/>
     <p:sldId id="262" r:id="rId8"/>
     <p:sldId id="263" r:id="rId9"/>
+    <p:sldId id="264" r:id="rId10"/>
+    <p:sldId id="265" r:id="rId11"/>
   </p:sldIdLst>
   <p:notesMasterIdLst>
-    <p:notesMasterId r:id="rId10"/>
+    <p:notesMasterId r:id="rId12"/>
   </p:notesMasterIdLst>
   <p:sldSz cx="9144000" cy="5143500"/>
   <p:notesSz cx="5143500" cy="9144000"/>
@@ -1658,6 +1660,94 @@
 </p:notes>
 </file>
 
+<file path=ppt/notesSlides/notesSlide10.xml><?xml version="1.0" encoding="utf-8"?>
+<p:notes xmlns:a="http://schemas.openxmlformats.org/drawingml/2006/main" xmlns:r="http://schemas.openxmlformats.org/officeDocument/2006/relationships" xmlns:p="http://schemas.openxmlformats.org/presentationml/2006/main">
+  <p:cSld>
+    <p:spTree>
+      <p:nvGrpSpPr>
+        <p:cNvPr id="1" name=""/>
+        <p:cNvGrpSpPr/>
+        <p:nvPr/>
+      </p:nvGrpSpPr>
+      <p:grpSpPr>
+        <a:xfrm>
+          <a:off x="0" y="0"/>
+          <a:ext cx="0" cy="0"/>
+          <a:chOff x="0" y="0"/>
+          <a:chExt cx="0" cy="0"/>
+        </a:xfrm>
+      </p:grpSpPr>
+      <p:sp>
+        <p:nvSpPr>
+          <p:cNvPr id="2" name="Slide Image Placeholder 1"/>
+          <p:cNvSpPr>
+            <a:spLocks noGrp="1" noRot="1" noChangeAspect="1"/>
+          </p:cNvSpPr>
+          <p:nvPr>
+            <p:ph type="sldImg"/>
+          </p:nvPr>
+        </p:nvSpPr>
+        <p:spPr/>
+      </p:sp>
+      <p:sp>
+        <p:nvSpPr>
+          <p:cNvPr id="3" name="Notes Placeholder 2"/>
+          <p:cNvSpPr>
+            <a:spLocks noGrp="1"/>
+          </p:cNvSpPr>
+          <p:nvPr>
+            <p:ph type="body" idx="1"/>
+          </p:nvPr>
+        </p:nvSpPr>
+        <p:spPr/>
+        <p:txBody>
+          <a:bodyPr/>
+          <a:lstStyle/>
+          <a:p>
+            <a:r>
+              <a:rPr lang="en-US" dirty="0"/>
+              <a:t>Thank you. Questions?</a:t>
+            </a:r>
+            <a:endParaRPr lang="en-US" dirty="0"/>
+          </a:p>
+        </p:txBody>
+      </p:sp>
+      <p:sp>
+        <p:nvSpPr>
+          <p:cNvPr id="4" name="Slide Number Placeholder 3"/>
+          <p:cNvSpPr>
+            <a:spLocks noGrp="1"/>
+          </p:cNvSpPr>
+          <p:nvPr>
+            <p:ph type="sldNum" sz="quarter" idx="10"/>
+          </p:nvPr>
+        </p:nvSpPr>
+        <p:spPr/>
+        <p:txBody>
+          <a:bodyPr/>
+          <a:lstStyle/>
+          <a:p>
+            <a:fld id="{F7021451-1387-4CA6-816F-3879F97B5CBC}" type="slidenum">
+              <a:rPr lang="en-US"/>
+              <a:t>10</a:t>
+            </a:fld>
+            <a:endParaRPr lang="en-US"/>
+          </a:p>
+        </p:txBody>
+      </p:sp>
+    </p:spTree>
+    <p:extLst>
+      <p:ext uri="{BB962C8B-B14F-4D97-AF65-F5344CB8AC3E}">
+        <p14:creationId xmlns:p14="http://schemas.microsoft.com/office/powerpoint/2010/main" val="1024086991"/>
+      </p:ext>
+    </p:extLst>
+  </p:cSld>
+  <p:clrMapOvr>
+    <a:masterClrMapping/>
+  </p:clrMapOvr>
+</p:notes>
+</file>
+
 <file path=ppt/notesSlides/notesSlide2.xml><?xml version="1.0" encoding="utf-8"?>
 <p:notes xmlns:a="http://schemas.openxmlformats.org/drawingml/2006/main" xmlns:r="http://schemas.openxmlformats.org/officeDocument/2006/relationships" xmlns:p="http://schemas.openxmlformats.org/presentationml/2006/main">
   <p:cSld>
@@ -1880,7 +1970,7 @@
           <a:p>
             <a:r>
               <a:rPr lang="en-US" dirty="0"/>
-              <a:t>This is the real output of our prototype, running on test data. Live demo: run npm run demo and open out/digest.html.</a:t>
+              <a:t>This is the real UI. Run npm run ui, open localhost:3000, click Scout deals.</a:t>
             </a:r>
             <a:endParaRPr lang="en-US" dirty="0"/>
           </a:p>
@@ -1968,7 +2058,7 @@
           <a:p>
             <a:r>
               <a:rPr lang="en-US" dirty="0"/>
-              <a:t>PreSonus AudioBox on test data. The red line is the 'original price' the store shows. The green line is what it actually sold for. It never came close, so the discount is fake.</a:t>
+              <a:t>Point at the red exclamation mark: the fake discount is caught live. The test-data run is instant, so the UI paces the lines so they can be read.</a:t>
             </a:r>
             <a:endParaRPr lang="en-US" dirty="0"/>
           </a:p>
@@ -2056,7 +2146,7 @@
           <a:p>
             <a:r>
               <a:rPr lang="en-US" dirty="0"/>
-              <a:t>Be upfront: Gemini watch spec and discovery are written; deploy, Firestore and email sending are the next steps.</a:t>
+              <a:t>PreSonus AudioBox on test data. The red line is the 'original price' the store shows. The green line is what it actually sold for. It never came close, so the discount is fake.</a:t>
             </a:r>
             <a:endParaRPr lang="en-US" dirty="0"/>
           </a:p>
@@ -2144,7 +2234,7 @@
           <a:p>
             <a:r>
               <a:rPr lang="en-US" dirty="0"/>
-              <a:t>Real price history takes days to accumulate, which is why the demo uses seeded history.</a:t>
+              <a:t>This is what a price tracker cannot do: it compares against what the buyer actually asked for.</a:t>
             </a:r>
             <a:endParaRPr lang="en-US" dirty="0"/>
           </a:p>
@@ -2232,7 +2322,7 @@
           <a:p>
             <a:r>
               <a:rPr lang="en-US" dirty="0"/>
-              <a:t>Thank you. Questions?</a:t>
+              <a:t>Be upfront: Gemini watch spec and discovery are written; deploy, Firestore and email sending are the next steps.</a:t>
             </a:r>
             <a:endParaRPr lang="en-US" dirty="0"/>
           </a:p>
@@ -2256,6 +2346,94 @@
             <a:fld id="{F7021451-1387-4CA6-816F-3879F97B5CBC}" type="slidenum">
               <a:rPr lang="en-US"/>
               <a:t>8</a:t>
+            </a:fld>
+            <a:endParaRPr lang="en-US"/>
+          </a:p>
+        </p:txBody>
+      </p:sp>
+    </p:spTree>
+    <p:extLst>
+      <p:ext uri="{BB962C8B-B14F-4D97-AF65-F5344CB8AC3E}">
+        <p14:creationId xmlns:p14="http://schemas.microsoft.com/office/powerpoint/2010/main" val="1024086991"/>
+      </p:ext>
+    </p:extLst>
+  </p:cSld>
+  <p:clrMapOvr>
+    <a:masterClrMapping/>
+  </p:clrMapOvr>
+</p:notes>
+</file>
+
+<file path=ppt/notesSlides/notesSlide9.xml><?xml version="1.0" encoding="utf-8"?>
+<p:notes xmlns:a="http://schemas.openxmlformats.org/drawingml/2006/main" xmlns:r="http://schemas.openxmlformats.org/officeDocument/2006/relationships" xmlns:p="http://schemas.openxmlformats.org/presentationml/2006/main">
+  <p:cSld>
+    <p:spTree>
+      <p:nvGrpSpPr>
+        <p:cNvPr id="1" name=""/>
+        <p:cNvGrpSpPr/>
+        <p:nvPr/>
+      </p:nvGrpSpPr>
+      <p:grpSpPr>
+        <a:xfrm>
+          <a:off x="0" y="0"/>
+          <a:ext cx="0" cy="0"/>
+          <a:chOff x="0" y="0"/>
+          <a:chExt cx="0" cy="0"/>
+        </a:xfrm>
+      </p:grpSpPr>
+      <p:sp>
+        <p:nvSpPr>
+          <p:cNvPr id="2" name="Slide Image Placeholder 1"/>
+          <p:cNvSpPr>
+            <a:spLocks noGrp="1" noRot="1" noChangeAspect="1"/>
+          </p:cNvSpPr>
+          <p:nvPr>
+            <p:ph type="sldImg"/>
+          </p:nvPr>
+        </p:nvSpPr>
+        <p:spPr/>
+      </p:sp>
+      <p:sp>
+        <p:nvSpPr>
+          <p:cNvPr id="3" name="Notes Placeholder 2"/>
+          <p:cNvSpPr>
+            <a:spLocks noGrp="1"/>
+          </p:cNvSpPr>
+          <p:nvPr>
+            <p:ph type="body" idx="1"/>
+          </p:nvPr>
+        </p:nvSpPr>
+        <p:spPr/>
+        <p:txBody>
+          <a:bodyPr/>
+          <a:lstStyle/>
+          <a:p>
+            <a:r>
+              <a:rPr lang="en-US" dirty="0"/>
+              <a:t>Real price history takes days to accumulate, which is why the demo uses seeded history.</a:t>
+            </a:r>
+            <a:endParaRPr lang="en-US" dirty="0"/>
+          </a:p>
+        </p:txBody>
+      </p:sp>
+      <p:sp>
+        <p:nvSpPr>
+          <p:cNvPr id="4" name="Slide Number Placeholder 3"/>
+          <p:cNvSpPr>
+            <a:spLocks noGrp="1"/>
+          </p:cNvSpPr>
+          <p:nvPr>
+            <p:ph type="sldNum" sz="quarter" idx="10"/>
+          </p:nvPr>
+        </p:nvSpPr>
+        <p:spPr/>
+        <p:txBody>
+          <a:bodyPr/>
+          <a:lstStyle/>
+          <a:p>
+            <a:fld id="{F7021451-1387-4CA6-816F-3879F97B5CBC}" type="slidenum">
+              <a:rPr lang="en-US"/>
+              <a:t>9</a:t>
             </a:fld>
             <a:endParaRPr lang="en-US"/>
           </a:p>
@@ -3194,6 +3372,190 @@
 </p:sld>
 </file>
 
+<file path=ppt/slides/slide10.xml><?xml version="1.0" encoding="utf-8"?>
+<p:sld xmlns:a="http://schemas.openxmlformats.org/drawingml/2006/main" xmlns:r="http://schemas.openxmlformats.org/officeDocument/2006/relationships" xmlns:p="http://schemas.openxmlformats.org/presentationml/2006/main">
+  <p:cSld name="Slide 10">
+    <p:spTree>
+      <p:nvGrpSpPr>
+        <p:cNvPr id="1" name=""/>
+        <p:cNvGrpSpPr/>
+        <p:nvPr/>
+      </p:nvGrpSpPr>
+      <p:grpSpPr>
+        <a:xfrm>
+          <a:off x="0" y="0"/>
+          <a:ext cx="0" cy="0"/>
+          <a:chOff x="0" y="0"/>
+          <a:chExt cx="0" cy="0"/>
+        </a:xfrm>
+      </p:grpSpPr>
+      <p:sp>
+        <p:nvSpPr>
+          <p:cNvPr id="2" name="Closing line 1"/>
+          <p:cNvSpPr txBox="1"/>
+          <p:nvPr/>
+        </p:nvSpPr>
+        <p:spPr>
+          <a:xfrm>
+            <a:off x="640080" y="1371600"/>
+            <a:ext cx="7863840" cy="822960"/>
+          </a:xfrm>
+          <a:prstGeom prst="rect">
+            <a:avLst/>
+          </a:prstGeom>
+          <a:noFill/>
+          <a:ln/>
+        </p:spPr>
+        <p:txBody>
+          <a:bodyPr wrap="square" lIns="0" tIns="0" rIns="0" bIns="0" rtlCol="0" anchor="ctr"/>
+          <a:lstStyle/>
+          <a:p>
+            <a:pPr indent="0" marL="0">
+              <a:buNone/>
+            </a:pPr>
+            <a:r>
+              <a:rPr lang="en-US" sz="4000" dirty="0">
+                <a:solidFill>
+                  <a:schemeClr val="accent5"/>
+                </a:solidFill>
+                <a:latin typeface="Cambria" pitchFamily="34" charset="0"/>
+                <a:ea typeface="Cambria" pitchFamily="34" charset="-122"/>
+                <a:cs typeface="Cambria" pitchFamily="34" charset="-120"/>
+              </a:rPr>
+              <a:t>Trackers watch products.</a:t>
+            </a:r>
+            <a:endParaRPr lang="en-US" sz="4000" dirty="0"/>
+          </a:p>
+        </p:txBody>
+      </p:sp>
+      <p:sp>
+        <p:nvSpPr>
+          <p:cNvPr id="3" name="Closing line 2"/>
+          <p:cNvSpPr txBox="1"/>
+          <p:nvPr/>
+        </p:nvSpPr>
+        <p:spPr>
+          <a:xfrm>
+            <a:off x="640080" y="2194560"/>
+            <a:ext cx="7863840" cy="822960"/>
+          </a:xfrm>
+          <a:prstGeom prst="rect">
+            <a:avLst/>
+          </a:prstGeom>
+          <a:noFill/>
+          <a:ln/>
+        </p:spPr>
+        <p:txBody>
+          <a:bodyPr wrap="square" lIns="0" tIns="0" rIns="0" bIns="0" rtlCol="0" anchor="ctr"/>
+          <a:lstStyle/>
+          <a:p>
+            <a:pPr indent="0" marL="0">
+              <a:buNone/>
+            </a:pPr>
+            <a:r>
+              <a:rPr lang="en-US" sz="4000" b="1" dirty="0">
+                <a:solidFill>
+                  <a:schemeClr val="bg1"/>
+                </a:solidFill>
+                <a:latin typeface="Cambria" pitchFamily="34" charset="0"/>
+                <a:ea typeface="Cambria" pitchFamily="34" charset="-122"/>
+                <a:cs typeface="Cambria" pitchFamily="34" charset="-120"/>
+              </a:rPr>
+              <a:t>DealScout watches your need.</a:t>
+            </a:r>
+            <a:endParaRPr lang="en-US" sz="4000" dirty="0"/>
+          </a:p>
+        </p:txBody>
+      </p:sp>
+      <p:sp>
+        <p:nvSpPr>
+          <p:cNvPr id="4" name="Closing body"/>
+          <p:cNvSpPr txBox="1"/>
+          <p:nvPr/>
+        </p:nvSpPr>
+        <p:spPr>
+          <a:xfrm>
+            <a:off x="640080" y="3291840"/>
+            <a:ext cx="7315200" cy="457200"/>
+          </a:xfrm>
+          <a:prstGeom prst="rect">
+            <a:avLst/>
+          </a:prstGeom>
+          <a:noFill/>
+          <a:ln/>
+        </p:spPr>
+        <p:txBody>
+          <a:bodyPr wrap="square" lIns="0" tIns="0" rIns="0" bIns="0" rtlCol="0" anchor="ctr"/>
+          <a:lstStyle/>
+          <a:p>
+            <a:pPr indent="0" marL="0">
+              <a:buNone/>
+            </a:pPr>
+            <a:r>
+              <a:rPr lang="en-US" sz="1600" dirty="0">
+                <a:solidFill>
+                  <a:schemeClr val="bg2"/>
+                </a:solidFill>
+              </a:rPr>
+              <a:t>Find the options you didn't know existed. Know whether the deal is real.</a:t>
+            </a:r>
+            <a:endParaRPr lang="en-US" sz="1600" dirty="0"/>
+          </a:p>
+        </p:txBody>
+      </p:sp>
+      <p:sp>
+        <p:nvSpPr>
+          <p:cNvPr id="25" name="Slide Number Placeholder 0"/>
+          <p:cNvSpPr>
+            <a:spLocks noGrp="1"/>
+          </p:cNvSpPr>
+          <p:nvPr>
+            <p:ph type="sldNum" sz="quarter" idx="4294967295"/>
+          </p:nvPr>
+        </p:nvSpPr>
+        <p:spPr>
+          <a:xfrm>
+            <a:off x="8412480" y="4800600"/>
+            <a:ext cx="457200" cy="228600"/>
+          </a:xfrm>
+          <a:prstGeom prst="rect">
+            <a:avLst/>
+          </a:prstGeom>
+          <a:extLst>
+            <a:ext uri="{C572A759-6A51-4108-AA02-DFA0A04FC94B}">
+              <ma14:wrappingTextBoxFlag xmlns:ma14="http://schemas.microsoft.com/office/mac/drawingml/2011/main" val="0"/>
+            </a:ext>
+          </a:extLst>
+        </p:spPr>
+        <p:txBody>
+          <a:bodyPr/>
+          <a:lstStyle>
+            <a:lvl1pPr>
+              <a:defRPr sz="1000">
+                <a:solidFill>
+                  <a:schemeClr val="accent5"/>
+                </a:solidFill>
+              </a:defRPr>
+            </a:lvl1pPr>
+          </a:lstStyle>
+          <a:p>
+            <a:pPr algn="r"/>
+            <a:fld id="{F7021451-1387-4CA6-816F-3879F97B5CBC}" type="slidenum">
+              <a:rPr b="0" lang="en-US"/>
+              <a:t>10</a:t>
+            </a:fld>
+            <a:endParaRPr lang="en-US"/>
+          </a:p>
+        </p:txBody>
+      </p:sp>
+    </p:spTree>
+  </p:cSld>
+  <p:clrMapOvr>
+    <a:masterClrMapping/>
+  </p:clrMapOvr>
+</p:sld>
+</file>
+
 <file path=ppt/slides/slide2.xml><?xml version="1.0" encoding="utf-8"?>
 <p:sld xmlns:a="http://schemas.openxmlformats.org/drawingml/2006/main" xmlns:r="http://schemas.openxmlformats.org/officeDocument/2006/relationships" xmlns:p="http://schemas.openxmlformats.org/presentationml/2006/main">
   <p:cSld name="Slide 2">
@@ -4635,529 +4997,46 @@
                 <a:ea typeface="Cambria" pitchFamily="34" charset="-122"/>
                 <a:cs typeface="Cambria" pitchFamily="34" charset="-120"/>
               </a:rPr>
-              <a:t>What lands in your inbox</a:t>
+              <a:t>Describe the need, get a verdict on every match</a:t>
             </a:r>
             <a:endParaRPr lang="en-US" sz="3000" dirty="0"/>
           </a:p>
         </p:txBody>
       </p:sp>
-      <p:sp>
-        <p:nvSpPr>
-          <p:cNvPr id="3" name="Email card"/>
-          <p:cNvSpPr/>
-          <p:nvPr/>
-        </p:nvSpPr>
-        <p:spPr>
-          <a:xfrm>
-            <a:off x="548640" y="1280160"/>
-            <a:ext cx="5120640" cy="3291840"/>
-          </a:xfrm>
-          <a:prstGeom prst="roundRect">
-            <a:avLst>
-              <a:gd name="adj" fmla="val 2222"/>
-            </a:avLst>
-          </a:prstGeom>
-          <a:solidFill>
-            <a:srgbClr val="F4F7F5"/>
-          </a:solidFill>
-          <a:ln w="12700">
-            <a:solidFill>
-              <a:srgbClr val="F4F7F5"/>
-            </a:solidFill>
-            <a:prstDash val="solid"/>
-          </a:ln>
-        </p:spPr>
-      </p:sp>
-      <p:sp>
-        <p:nvSpPr>
-          <p:cNvPr id="4" name="Email subject"/>
+      <p:pic>
+        <p:nvPicPr>
+          <p:cNvPr id="3" name="UI screenshot" descr="/private/tmp/claude-502/-Users-meenu-Downloads-D2/12731e38-32f4-44ab-831f-f37e8cc97cf7/scratchpad/shots/overview.png">    </p:cNvPr>
+          <p:cNvPicPr>
+            <a:picLocks noChangeAspect="1"/>
+          </p:cNvPicPr>
+          <p:nvPr/>
+        </p:nvPicPr>
+        <p:blipFill>
+          <a:blip r:embed="rId1"/>
+          <a:stretch>
+            <a:fillRect/>
+          </a:stretch>
+        </p:blipFill>
+        <p:spPr>
+          <a:xfrm>
+            <a:off x="548640" y="1325880"/>
+            <a:ext cx="4480560" cy="3520440"/>
+          </a:xfrm>
+          <a:prstGeom prst="rect">
+            <a:avLst/>
+          </a:prstGeom>
+        </p:spPr>
+      </p:pic>
+      <p:sp>
+        <p:nvSpPr>
+          <p:cNvPr id="4" name="UI points"/>
           <p:cNvSpPr txBox="1"/>
           <p:nvPr/>
         </p:nvSpPr>
         <p:spPr>
           <a:xfrm>
-            <a:off x="777240" y="1417320"/>
-            <a:ext cx="4663440" cy="320040"/>
-          </a:xfrm>
-          <a:prstGeom prst="rect">
-            <a:avLst/>
-          </a:prstGeom>
-          <a:noFill/>
-          <a:ln/>
-        </p:spPr>
-        <p:txBody>
-          <a:bodyPr wrap="square" lIns="0" tIns="0" rIns="0" bIns="0" rtlCol="0" anchor="ctr"/>
-          <a:lstStyle/>
-          <a:p>
-            <a:pPr indent="0" marL="0">
-              <a:buNone/>
-            </a:pPr>
-            <a:r>
-              <a:rPr lang="en-US" sz="1400" b="1" dirty="0">
-                <a:solidFill>
-                  <a:schemeClr val="tx1"/>
-                </a:solidFill>
-              </a:rPr>
-              <a:t>DealScout digest: audio interface under ₹15,000</a:t>
-            </a:r>
-            <a:endParaRPr lang="en-US" sz="1400" dirty="0"/>
-          </a:p>
-        </p:txBody>
-      </p:sp>
-      <p:sp>
-        <p:nvSpPr>
-          <p:cNvPr id="5" name="Tag 1"/>
-          <p:cNvSpPr/>
-          <p:nvPr/>
-        </p:nvSpPr>
-        <p:spPr>
-          <a:xfrm>
-            <a:off x="777240" y="1920240"/>
-            <a:ext cx="914400" cy="292608"/>
-          </a:xfrm>
-          <a:prstGeom prst="roundRect">
-            <a:avLst>
-              <a:gd name="adj" fmla="val 18750"/>
-            </a:avLst>
-          </a:prstGeom>
-          <a:solidFill>
-            <a:schemeClr val="accent1"/>
-          </a:solidFill>
-          <a:ln w="12700">
-            <a:solidFill>
-              <a:schemeClr val="accent1"/>
-            </a:solidFill>
-            <a:prstDash val="solid"/>
-          </a:ln>
-        </p:spPr>
-      </p:sp>
-      <p:sp>
-        <p:nvSpPr>
-          <p:cNvPr id="6" name="Tag label 1"/>
-          <p:cNvSpPr txBox="1"/>
-          <p:nvPr/>
-        </p:nvSpPr>
-        <p:spPr>
-          <a:xfrm>
-            <a:off x="777240" y="1920240"/>
-            <a:ext cx="914400" cy="292608"/>
-          </a:xfrm>
-          <a:prstGeom prst="rect">
-            <a:avLst/>
-          </a:prstGeom>
-          <a:noFill/>
-          <a:ln/>
-        </p:spPr>
-        <p:txBody>
-          <a:bodyPr wrap="square" lIns="0" tIns="0" rIns="0" bIns="0" rtlCol="0" anchor="ctr"/>
-          <a:lstStyle/>
-          <a:p>
-            <a:pPr algn="ctr" indent="0" marL="0">
-              <a:buNone/>
-            </a:pPr>
-            <a:r>
-              <a:rPr lang="en-US" sz="1100" b="1" dirty="0">
-                <a:solidFill>
-                  <a:schemeClr val="bg1"/>
-                </a:solidFill>
-              </a:rPr>
-              <a:t>BUY NOW</a:t>
-            </a:r>
-            <a:endParaRPr lang="en-US" sz="1100" dirty="0"/>
-          </a:p>
-        </p:txBody>
-      </p:sp>
-      <p:sp>
-        <p:nvSpPr>
-          <p:cNvPr id="7" name="Product 1"/>
-          <p:cNvSpPr txBox="1"/>
-          <p:nvPr/>
-        </p:nvSpPr>
-        <p:spPr>
-          <a:xfrm>
-            <a:off x="1828800" y="1920240"/>
-            <a:ext cx="3657600" cy="292608"/>
-          </a:xfrm>
-          <a:prstGeom prst="rect">
-            <a:avLst/>
-          </a:prstGeom>
-          <a:noFill/>
-          <a:ln/>
-        </p:spPr>
-        <p:txBody>
-          <a:bodyPr wrap="square" lIns="0" tIns="0" rIns="0" bIns="0" rtlCol="0" anchor="ctr"/>
-          <a:lstStyle/>
-          <a:p>
-            <a:pPr indent="0" marL="0">
-              <a:buNone/>
-            </a:pPr>
-            <a:r>
-              <a:rPr lang="en-US" sz="1400" b="1" dirty="0">
-                <a:solidFill>
-                  <a:schemeClr val="tx1"/>
-                </a:solidFill>
-              </a:rPr>
-              <a:t>Behringer UMC204HD · ₹9,499</a:t>
-            </a:r>
-            <a:endParaRPr lang="en-US" sz="1400" dirty="0"/>
-          </a:p>
-        </p:txBody>
-      </p:sp>
-      <p:sp>
-        <p:nvSpPr>
-          <p:cNvPr id="8" name="Reason 1"/>
-          <p:cNvSpPr txBox="1"/>
-          <p:nvPr/>
-        </p:nvSpPr>
-        <p:spPr>
-          <a:xfrm>
-            <a:off x="1828800" y="2267712"/>
-            <a:ext cx="3657600" cy="365760"/>
-          </a:xfrm>
-          <a:prstGeom prst="rect">
-            <a:avLst/>
-          </a:prstGeom>
-          <a:noFill/>
-          <a:ln/>
-        </p:spPr>
-        <p:txBody>
-          <a:bodyPr wrap="square" lIns="0" tIns="0" rIns="0" bIns="0" rtlCol="0" anchor="t"/>
-          <a:lstStyle/>
-          <a:p>
-            <a:pPr indent="0" marL="0">
-              <a:buNone/>
-            </a:pPr>
-            <a:r>
-              <a:rPr lang="en-US" sz="1200" dirty="0">
-                <a:solidFill>
-                  <a:schemeClr val="tx2"/>
-                </a:solidFill>
-              </a:rPr>
-              <a:t>Lowest price in 60 days</a:t>
-            </a:r>
-            <a:endParaRPr lang="en-US" sz="1200" dirty="0"/>
-          </a:p>
-        </p:txBody>
-      </p:sp>
-      <p:sp>
-        <p:nvSpPr>
-          <p:cNvPr id="9" name="Tag 2"/>
-          <p:cNvSpPr/>
-          <p:nvPr/>
-        </p:nvSpPr>
-        <p:spPr>
-          <a:xfrm>
-            <a:off x="777240" y="2788920"/>
-            <a:ext cx="914400" cy="292608"/>
-          </a:xfrm>
-          <a:prstGeom prst="roundRect">
-            <a:avLst>
-              <a:gd name="adj" fmla="val 18750"/>
-            </a:avLst>
-          </a:prstGeom>
-          <a:solidFill>
-            <a:schemeClr val="accent1"/>
-          </a:solidFill>
-          <a:ln w="12700">
-            <a:solidFill>
-              <a:schemeClr val="accent1"/>
-            </a:solidFill>
-            <a:prstDash val="solid"/>
-          </a:ln>
-        </p:spPr>
-      </p:sp>
-      <p:sp>
-        <p:nvSpPr>
-          <p:cNvPr id="10" name="Tag label 2"/>
-          <p:cNvSpPr txBox="1"/>
-          <p:nvPr/>
-        </p:nvSpPr>
-        <p:spPr>
-          <a:xfrm>
-            <a:off x="777240" y="2788920"/>
-            <a:ext cx="914400" cy="292608"/>
-          </a:xfrm>
-          <a:prstGeom prst="rect">
-            <a:avLst/>
-          </a:prstGeom>
-          <a:noFill/>
-          <a:ln/>
-        </p:spPr>
-        <p:txBody>
-          <a:bodyPr wrap="square" lIns="0" tIns="0" rIns="0" bIns="0" rtlCol="0" anchor="ctr"/>
-          <a:lstStyle/>
-          <a:p>
-            <a:pPr algn="ctr" indent="0" marL="0">
-              <a:buNone/>
-            </a:pPr>
-            <a:r>
-              <a:rPr lang="en-US" sz="1100" b="1" dirty="0">
-                <a:solidFill>
-                  <a:schemeClr val="bg1"/>
-                </a:solidFill>
-              </a:rPr>
-              <a:t>BUY NOW</a:t>
-            </a:r>
-            <a:endParaRPr lang="en-US" sz="1100" dirty="0"/>
-          </a:p>
-        </p:txBody>
-      </p:sp>
-      <p:sp>
-        <p:nvSpPr>
-          <p:cNvPr id="11" name="Product 2"/>
-          <p:cNvSpPr txBox="1"/>
-          <p:nvPr/>
-        </p:nvSpPr>
-        <p:spPr>
-          <a:xfrm>
-            <a:off x="1828800" y="2788920"/>
-            <a:ext cx="3657600" cy="292608"/>
-          </a:xfrm>
-          <a:prstGeom prst="rect">
-            <a:avLst/>
-          </a:prstGeom>
-          <a:noFill/>
-          <a:ln/>
-        </p:spPr>
-        <p:txBody>
-          <a:bodyPr wrap="square" lIns="0" tIns="0" rIns="0" bIns="0" rtlCol="0" anchor="ctr"/>
-          <a:lstStyle/>
-          <a:p>
-            <a:pPr indent="0" marL="0">
-              <a:buNone/>
-            </a:pPr>
-            <a:r>
-              <a:rPr lang="en-US" sz="1400" b="1" dirty="0">
-                <a:solidFill>
-                  <a:schemeClr val="tx1"/>
-                </a:solidFill>
-              </a:rPr>
-              <a:t>Focusrite Scarlett 2i2 · ₹11,999</a:t>
-            </a:r>
-            <a:endParaRPr lang="en-US" sz="1400" dirty="0"/>
-          </a:p>
-        </p:txBody>
-      </p:sp>
-      <p:sp>
-        <p:nvSpPr>
-          <p:cNvPr id="12" name="Reason 2"/>
-          <p:cNvSpPr txBox="1"/>
-          <p:nvPr/>
-        </p:nvSpPr>
-        <p:spPr>
-          <a:xfrm>
-            <a:off x="1828800" y="3136392"/>
-            <a:ext cx="3657600" cy="365760"/>
-          </a:xfrm>
-          <a:prstGeom prst="rect">
-            <a:avLst/>
-          </a:prstGeom>
-          <a:noFill/>
-          <a:ln/>
-        </p:spPr>
-        <p:txBody>
-          <a:bodyPr wrap="square" lIns="0" tIns="0" rIns="0" bIns="0" rtlCol="0" anchor="t"/>
-          <a:lstStyle/>
-          <a:p>
-            <a:pPr indent="0" marL="0">
-              <a:buNone/>
-            </a:pPr>
-            <a:r>
-              <a:rPr lang="en-US" sz="1200" dirty="0">
-                <a:solidFill>
-                  <a:schemeClr val="tx2"/>
-                </a:solidFill>
-              </a:rPr>
-              <a:t>Real low, but the 33% banner is inflated</a:t>
-            </a:r>
-            <a:endParaRPr lang="en-US" sz="1200" dirty="0"/>
-          </a:p>
-        </p:txBody>
-      </p:sp>
-      <p:sp>
-        <p:nvSpPr>
-          <p:cNvPr id="13" name="Tag 3"/>
-          <p:cNvSpPr/>
-          <p:nvPr/>
-        </p:nvSpPr>
-        <p:spPr>
-          <a:xfrm>
-            <a:off x="777240" y="3657600"/>
-            <a:ext cx="914400" cy="292608"/>
-          </a:xfrm>
-          <a:prstGeom prst="roundRect">
-            <a:avLst>
-              <a:gd name="adj" fmla="val 18750"/>
-            </a:avLst>
-          </a:prstGeom>
-          <a:solidFill>
-            <a:schemeClr val="accent2"/>
-          </a:solidFill>
-          <a:ln w="12700">
-            <a:solidFill>
-              <a:schemeClr val="accent2"/>
-            </a:solidFill>
-            <a:prstDash val="solid"/>
-          </a:ln>
-        </p:spPr>
-      </p:sp>
-      <p:sp>
-        <p:nvSpPr>
-          <p:cNvPr id="14" name="Tag label 3"/>
-          <p:cNvSpPr txBox="1"/>
-          <p:nvPr/>
-        </p:nvSpPr>
-        <p:spPr>
-          <a:xfrm>
-            <a:off x="777240" y="3657600"/>
-            <a:ext cx="914400" cy="292608"/>
-          </a:xfrm>
-          <a:prstGeom prst="rect">
-            <a:avLst/>
-          </a:prstGeom>
-          <a:noFill/>
-          <a:ln/>
-        </p:spPr>
-        <p:txBody>
-          <a:bodyPr wrap="square" lIns="0" tIns="0" rIns="0" bIns="0" rtlCol="0" anchor="ctr"/>
-          <a:lstStyle/>
-          <a:p>
-            <a:pPr algn="ctr" indent="0" marL="0">
-              <a:buNone/>
-            </a:pPr>
-            <a:r>
-              <a:rPr lang="en-US" sz="1100" b="1" dirty="0">
-                <a:solidFill>
-                  <a:schemeClr val="bg1"/>
-                </a:solidFill>
-              </a:rPr>
-              <a:t>WAIT</a:t>
-            </a:r>
-            <a:endParaRPr lang="en-US" sz="1100" dirty="0"/>
-          </a:p>
-        </p:txBody>
-      </p:sp>
-      <p:sp>
-        <p:nvSpPr>
-          <p:cNvPr id="15" name="Product 3"/>
-          <p:cNvSpPr txBox="1"/>
-          <p:nvPr/>
-        </p:nvSpPr>
-        <p:spPr>
-          <a:xfrm>
-            <a:off x="1828800" y="3657600"/>
-            <a:ext cx="3657600" cy="292608"/>
-          </a:xfrm>
-          <a:prstGeom prst="rect">
-            <a:avLst/>
-          </a:prstGeom>
-          <a:noFill/>
-          <a:ln/>
-        </p:spPr>
-        <p:txBody>
-          <a:bodyPr wrap="square" lIns="0" tIns="0" rIns="0" bIns="0" rtlCol="0" anchor="ctr"/>
-          <a:lstStyle/>
-          <a:p>
-            <a:pPr indent="0" marL="0">
-              <a:buNone/>
-            </a:pPr>
-            <a:r>
-              <a:rPr lang="en-US" sz="1400" b="1" dirty="0">
-                <a:solidFill>
-                  <a:schemeClr val="tx1"/>
-                </a:solidFill>
-              </a:rPr>
-              <a:t>PreSonus AudioBox · ₹8,499</a:t>
-            </a:r>
-            <a:endParaRPr lang="en-US" sz="1400" dirty="0"/>
-          </a:p>
-        </p:txBody>
-      </p:sp>
-      <p:sp>
-        <p:nvSpPr>
-          <p:cNvPr id="16" name="Reason 3"/>
-          <p:cNvSpPr txBox="1"/>
-          <p:nvPr/>
-        </p:nvSpPr>
-        <p:spPr>
-          <a:xfrm>
-            <a:off x="1828800" y="4005072"/>
-            <a:ext cx="3657600" cy="365760"/>
-          </a:xfrm>
-          <a:prstGeom prst="rect">
-            <a:avLst/>
-          </a:prstGeom>
-          <a:noFill/>
-          <a:ln/>
-        </p:spPr>
-        <p:txBody>
-          <a:bodyPr wrap="square" lIns="0" tIns="0" rIns="0" bIns="0" rtlCol="0" anchor="t"/>
-          <a:lstStyle/>
-          <a:p>
-            <a:pPr indent="0" marL="0">
-              <a:buNone/>
-            </a:pPr>
-            <a:r>
-              <a:rPr lang="en-US" sz="1200" dirty="0">
-                <a:solidFill>
-                  <a:schemeClr val="tx2"/>
-                </a:solidFill>
-              </a:rPr>
-              <a:t>Claims 35% off. Never sold above ₹8,699.</a:t>
-            </a:r>
-            <a:endParaRPr lang="en-US" sz="1200" dirty="0"/>
-          </a:p>
-        </p:txBody>
-      </p:sp>
-      <p:sp>
-        <p:nvSpPr>
-          <p:cNvPr id="17" name="Side heading"/>
-          <p:cNvSpPr txBox="1"/>
-          <p:nvPr/>
-        </p:nvSpPr>
-        <p:spPr>
-          <a:xfrm>
-            <a:off x="6126480" y="1371600"/>
-            <a:ext cx="2468880" cy="822960"/>
-          </a:xfrm>
-          <a:prstGeom prst="rect">
-            <a:avLst/>
-          </a:prstGeom>
-          <a:noFill/>
-          <a:ln/>
-        </p:spPr>
-        <p:txBody>
-          <a:bodyPr wrap="square" lIns="0" tIns="0" rIns="0" bIns="0" rtlCol="0" anchor="t"/>
-          <a:lstStyle/>
-          <a:p>
-            <a:pPr indent="0" marL="0">
-              <a:buNone/>
-            </a:pPr>
-            <a:r>
-              <a:rPr lang="en-US" sz="2400" b="1" dirty="0">
-                <a:solidFill>
-                  <a:schemeClr val="tx1"/>
-                </a:solidFill>
-                <a:latin typeface="Cambria" pitchFamily="34" charset="0"/>
-                <a:ea typeface="Cambria" pitchFamily="34" charset="-122"/>
-                <a:cs typeface="Cambria" pitchFamily="34" charset="-120"/>
-              </a:rPr>
-              <a:t>Short, with a reason for every call</a:t>
-            </a:r>
-            <a:endParaRPr lang="en-US" sz="2400" dirty="0"/>
-          </a:p>
-        </p:txBody>
-      </p:sp>
-      <p:sp>
-        <p:nvSpPr>
-          <p:cNvPr id="18" name="Side list"/>
-          <p:cNvSpPr txBox="1"/>
-          <p:nvPr/>
-        </p:nvSpPr>
-        <p:spPr>
-          <a:xfrm>
-            <a:off x="6126480" y="2331720"/>
-            <a:ext cx="2468880" cy="1463040"/>
+            <a:off x="5394960" y="1463040"/>
+            <a:ext cx="3200400" cy="2377440"/>
           </a:xfrm>
           <a:prstGeom prst="rect">
             <a:avLst/>
@@ -5171,96 +5050,96 @@
           <a:p>
             <a:pPr marL="342900" indent="-342900">
               <a:spcAft>
-                <a:spcPts val="600"/>
+                <a:spcPts val="1000"/>
               </a:spcAft>
               <a:buSzPct val="100000"/>
               <a:buChar char="•"/>
             </a:pPr>
             <a:r>
-              <a:rPr lang="en-US" sz="1400" dirty="0">
-                <a:solidFill>
-                  <a:schemeClr val="tx2"/>
-                </a:solidFill>
-              </a:rPr>
-              <a:t>What's at its lowest</a:t>
-            </a:r>
-            <a:endParaRPr lang="en-US" sz="1400" dirty="0"/>
+              <a:rPr lang="en-US" sz="1600" dirty="0">
+                <a:solidFill>
+                  <a:schemeClr val="tx1"/>
+                </a:solidFill>
+              </a:rPr>
+              <a:t>Plain-English request and budget</a:t>
+            </a:r>
+            <a:endParaRPr lang="en-US" sz="1600" dirty="0"/>
           </a:p>
           <a:p>
             <a:pPr marL="342900" indent="-342900">
               <a:spcAft>
-                <a:spcPts val="600"/>
+                <a:spcPts val="1000"/>
               </a:spcAft>
               <a:buSzPct val="100000"/>
               <a:buChar char="•"/>
             </a:pPr>
             <a:r>
-              <a:rPr lang="en-US" sz="1400" dirty="0">
-                <a:solidFill>
-                  <a:schemeClr val="tx2"/>
-                </a:solidFill>
-              </a:rPr>
-              <a:t>What to buy now</a:t>
-            </a:r>
-            <a:endParaRPr lang="en-US" sz="1400" dirty="0"/>
+              <a:rPr lang="en-US" sz="1600" dirty="0">
+                <a:solidFill>
+                  <a:schemeClr val="tx1"/>
+                </a:solidFill>
+              </a:rPr>
+              <a:t>Gemini builds the watch spec: category, budget, must-haves</a:t>
+            </a:r>
+            <a:endParaRPr lang="en-US" sz="1600" dirty="0"/>
           </a:p>
           <a:p>
             <a:pPr marL="342900" indent="-342900">
               <a:spcAft>
-                <a:spcPts val="600"/>
+                <a:spcPts val="1000"/>
               </a:spcAft>
               <a:buSzPct val="100000"/>
               <a:buChar char="•"/>
             </a:pPr>
             <a:r>
-              <a:rPr lang="en-US" sz="1400" dirty="0">
-                <a:solidFill>
-                  <a:schemeClr val="tx2"/>
-                </a:solidFill>
-              </a:rPr>
-              <a:t>What to wait on</a:t>
-            </a:r>
-            <a:endParaRPr lang="en-US" sz="1400" dirty="0"/>
+              <a:rPr lang="en-US" sz="1600" dirty="0">
+                <a:solidFill>
+                  <a:schemeClr val="tx1"/>
+                </a:solidFill>
+              </a:rPr>
+              <a:t>Every match gets Buy now or Wait, with reasons</a:t>
+            </a:r>
+            <a:endParaRPr lang="en-US" sz="1600" dirty="0"/>
           </a:p>
           <a:p>
             <a:pPr marL="342900" indent="-342900">
               <a:spcAft>
-                <a:spcPts val="600"/>
+                <a:spcPts val="1000"/>
               </a:spcAft>
               <a:buSzPct val="100000"/>
               <a:buChar char="•"/>
             </a:pPr>
             <a:r>
-              <a:rPr lang="en-US" sz="1400" dirty="0">
-                <a:solidFill>
-                  <a:schemeClr val="tx2"/>
-                </a:solidFill>
-              </a:rPr>
-              <a:t>Which discounts are fake</a:t>
-            </a:r>
-            <a:endParaRPr lang="en-US" sz="1400" dirty="0"/>
-          </a:p>
-        </p:txBody>
-      </p:sp>
-      <p:sp>
-        <p:nvSpPr>
-          <p:cNvPr id="19" name="Caption"/>
+              <a:rPr lang="en-US" sz="1600" dirty="0">
+                <a:solidFill>
+                  <a:schemeClr val="tx1"/>
+                </a:solidFill>
+              </a:rPr>
+              <a:t>Fake discounts are counted and flagged</a:t>
+            </a:r>
+            <a:endParaRPr lang="en-US" sz="1600" dirty="0"/>
+          </a:p>
+        </p:txBody>
+      </p:sp>
+      <p:sp>
+        <p:nvSpPr>
+          <p:cNvPr id="5" name="UI caption"/>
           <p:cNvSpPr txBox="1"/>
           <p:nvPr/>
         </p:nvSpPr>
         <p:spPr>
           <a:xfrm>
-            <a:off x="6126480" y="4251960"/>
-            <a:ext cx="2468880" cy="274320"/>
-          </a:xfrm>
-          <a:prstGeom prst="rect">
-            <a:avLst/>
-          </a:prstGeom>
-          <a:noFill/>
-          <a:ln/>
-        </p:spPr>
-        <p:txBody>
-          <a:bodyPr wrap="square" lIns="0" tIns="0" rIns="0" bIns="0" rtlCol="0" anchor="ctr"/>
+            <a:off x="5394960" y="4343400"/>
+            <a:ext cx="3200400" cy="457200"/>
+          </a:xfrm>
+          <a:prstGeom prst="rect">
+            <a:avLst/>
+          </a:prstGeom>
+          <a:noFill/>
+          <a:ln/>
+        </p:spPr>
+        <p:txBody>
+          <a:bodyPr wrap="square" lIns="0" tIns="0" rIns="0" bIns="0" rtlCol="0" anchor="t"/>
           <a:lstStyle/>
           <a:p>
             <a:pPr indent="0" marL="0">
@@ -5272,7 +5151,7 @@
                   <a:schemeClr val="accent4"/>
                 </a:solidFill>
               </a:rPr>
-              <a:t>Prototype output on test data</a:t>
+              <a:t>Screenshot of the working prototype, on test data</a:t>
             </a:r>
             <a:endParaRPr lang="en-US" sz="1100" dirty="0"/>
           </a:p>
@@ -5383,250 +5262,69 @@
                 <a:ea typeface="Cambria" pitchFamily="34" charset="-122"/>
                 <a:cs typeface="Cambria" pitchFamily="34" charset="-120"/>
               </a:rPr>
-              <a:t>A 35% discount on a price that never moved</a:t>
+              <a:t>Watch the agent work</a:t>
             </a:r>
             <a:endParaRPr lang="en-US" sz="3000" dirty="0"/>
           </a:p>
         </p:txBody>
       </p:sp>
-      <p:graphicFrame>
-        <p:nvGraphicFramePr>
-          <p:cNvPr id="3" name="Chart 0" descr=""/>
-          <p:cNvGraphicFramePr/>
-          <p:nvPr/>
-        </p:nvGraphicFramePr>
-        <p:xfrm>
-          <a:off x="457200" y="1280160"/>
-          <a:ext cx="5394960" cy="3383280"/>
-        </p:xfrm>
-        <a:graphic xmlns:a="http://schemas.openxmlformats.org/drawingml/2006/main">
-          <a:graphicData uri="http://schemas.openxmlformats.org/drawingml/2006/chart">
-            <c:chart xmlns:c="http://schemas.openxmlformats.org/drawingml/2006/chart" r:id="rId1"/>
-          </a:graphicData>
-        </a:graphic>
-      </p:graphicFrame>
-      <p:sp>
-        <p:nvSpPr>
-          <p:cNvPr id="4" name="Fact label 1"/>
+      <p:pic>
+        <p:nvPicPr>
+          <p:cNvPr id="3" name="Trace screenshot" descr="/private/tmp/claude-502/-Users-meenu-Downloads-D2/12731e38-32f4-44ab-831f-f37e8cc97cf7/scratchpad/shots/trace.png">    </p:cNvPr>
+          <p:cNvPicPr>
+            <a:picLocks noChangeAspect="1"/>
+          </p:cNvPicPr>
+          <p:nvPr/>
+        </p:nvPicPr>
+        <p:blipFill>
+          <a:blip r:embed="rId1"/>
+          <a:stretch>
+            <a:fillRect/>
+          </a:stretch>
+        </p:blipFill>
+        <p:spPr>
+          <a:xfrm>
+            <a:off x="548640" y="1325880"/>
+            <a:ext cx="8046720" cy="3235147"/>
+          </a:xfrm>
+          <a:prstGeom prst="rect">
+            <a:avLst/>
+          </a:prstGeom>
+        </p:spPr>
+      </p:pic>
+      <p:sp>
+        <p:nvSpPr>
+          <p:cNvPr id="4" name="Trace caption"/>
           <p:cNvSpPr txBox="1"/>
           <p:nvPr/>
         </p:nvSpPr>
         <p:spPr>
           <a:xfrm>
-            <a:off x="6217920" y="1463040"/>
-            <a:ext cx="2377440" cy="228600"/>
-          </a:xfrm>
-          <a:prstGeom prst="rect">
-            <a:avLst/>
-          </a:prstGeom>
-          <a:noFill/>
-          <a:ln/>
-        </p:spPr>
-        <p:txBody>
-          <a:bodyPr wrap="square" lIns="0" tIns="0" rIns="0" bIns="0" rtlCol="0" anchor="ctr"/>
+            <a:off x="548640" y="4572000"/>
+            <a:ext cx="8046720" cy="365760"/>
+          </a:xfrm>
+          <a:prstGeom prst="rect">
+            <a:avLst/>
+          </a:prstGeom>
+          <a:noFill/>
+          <a:ln/>
+        </p:spPr>
+        <p:txBody>
+          <a:bodyPr wrap="square" lIns="0" tIns="0" rIns="0" bIns="0" rtlCol="0" anchor="t"/>
           <a:lstStyle/>
           <a:p>
             <a:pPr indent="0" marL="0">
               <a:buNone/>
             </a:pPr>
             <a:r>
-              <a:rPr lang="en-US" sz="1100" b="1" spc="200" kern="0" dirty="0">
-                <a:solidFill>
-                  <a:schemeClr val="accent4"/>
-                </a:solidFill>
-              </a:rPr>
-              <a:t>STORE CLAIMS</a:t>
-            </a:r>
-            <a:endParaRPr lang="en-US" sz="1100" dirty="0"/>
-          </a:p>
-        </p:txBody>
-      </p:sp>
-      <p:sp>
-        <p:nvSpPr>
-          <p:cNvPr id="5" name="Fact value 1"/>
-          <p:cNvSpPr txBox="1"/>
-          <p:nvPr/>
-        </p:nvSpPr>
-        <p:spPr>
-          <a:xfrm>
-            <a:off x="6217920" y="1719072"/>
-            <a:ext cx="2377440" cy="640080"/>
-          </a:xfrm>
-          <a:prstGeom prst="rect">
-            <a:avLst/>
-          </a:prstGeom>
-          <a:noFill/>
-          <a:ln/>
-        </p:spPr>
-        <p:txBody>
-          <a:bodyPr wrap="square" lIns="0" tIns="0" rIns="0" bIns="0" rtlCol="0" anchor="t"/>
-          <a:lstStyle/>
-          <a:p>
-            <a:pPr indent="0" marL="0">
-              <a:buNone/>
-            </a:pPr>
-            <a:r>
-              <a:rPr lang="en-US" sz="1800" b="1" dirty="0">
-                <a:solidFill>
-                  <a:schemeClr val="accent3"/>
-                </a:solidFill>
-                <a:latin typeface="Cambria" pitchFamily="34" charset="0"/>
-                <a:ea typeface="Cambria" pitchFamily="34" charset="-122"/>
-                <a:cs typeface="Cambria" pitchFamily="34" charset="-120"/>
-              </a:rPr>
-              <a:t>35% off ₹12,999</a:t>
-            </a:r>
-            <a:endParaRPr lang="en-US" sz="1800" dirty="0"/>
-          </a:p>
-        </p:txBody>
-      </p:sp>
-      <p:sp>
-        <p:nvSpPr>
-          <p:cNvPr id="6" name="Fact label 2"/>
-          <p:cNvSpPr txBox="1"/>
-          <p:nvPr/>
-        </p:nvSpPr>
-        <p:spPr>
-          <a:xfrm>
-            <a:off x="6217920" y="2514600"/>
-            <a:ext cx="2377440" cy="228600"/>
-          </a:xfrm>
-          <a:prstGeom prst="rect">
-            <a:avLst/>
-          </a:prstGeom>
-          <a:noFill/>
-          <a:ln/>
-        </p:spPr>
-        <p:txBody>
-          <a:bodyPr wrap="square" lIns="0" tIns="0" rIns="0" bIns="0" rtlCol="0" anchor="ctr"/>
-          <a:lstStyle/>
-          <a:p>
-            <a:pPr indent="0" marL="0">
-              <a:buNone/>
-            </a:pPr>
-            <a:r>
-              <a:rPr lang="en-US" sz="1100" b="1" spc="200" kern="0" dirty="0">
-                <a:solidFill>
-                  <a:schemeClr val="accent4"/>
-                </a:solidFill>
-              </a:rPr>
-              <a:t>REALITY</a:t>
-            </a:r>
-            <a:endParaRPr lang="en-US" sz="1100" dirty="0"/>
-          </a:p>
-        </p:txBody>
-      </p:sp>
-      <p:sp>
-        <p:nvSpPr>
-          <p:cNvPr id="7" name="Fact value 2"/>
-          <p:cNvSpPr txBox="1"/>
-          <p:nvPr/>
-        </p:nvSpPr>
-        <p:spPr>
-          <a:xfrm>
-            <a:off x="6217920" y="2770632"/>
-            <a:ext cx="2377440" cy="640080"/>
-          </a:xfrm>
-          <a:prstGeom prst="rect">
-            <a:avLst/>
-          </a:prstGeom>
-          <a:noFill/>
-          <a:ln/>
-        </p:spPr>
-        <p:txBody>
-          <a:bodyPr wrap="square" lIns="0" tIns="0" rIns="0" bIns="0" rtlCol="0" anchor="t"/>
-          <a:lstStyle/>
-          <a:p>
-            <a:pPr indent="0" marL="0">
-              <a:buNone/>
-            </a:pPr>
-            <a:r>
-              <a:rPr lang="en-US" sz="1800" b="1" dirty="0">
-                <a:solidFill>
-                  <a:schemeClr val="tx1"/>
-                </a:solidFill>
-                <a:latin typeface="Cambria" pitchFamily="34" charset="0"/>
-                <a:ea typeface="Cambria" pitchFamily="34" charset="-122"/>
-                <a:cs typeface="Cambria" pitchFamily="34" charset="-120"/>
-              </a:rPr>
-              <a:t>₹8,199 to ₹8,699 for 60 days</a:t>
-            </a:r>
-            <a:endParaRPr lang="en-US" sz="1800" dirty="0"/>
-          </a:p>
-        </p:txBody>
-      </p:sp>
-      <p:sp>
-        <p:nvSpPr>
-          <p:cNvPr id="8" name="Fact label 3"/>
-          <p:cNvSpPr txBox="1"/>
-          <p:nvPr/>
-        </p:nvSpPr>
-        <p:spPr>
-          <a:xfrm>
-            <a:off x="6217920" y="3566160"/>
-            <a:ext cx="2377440" cy="228600"/>
-          </a:xfrm>
-          <a:prstGeom prst="rect">
-            <a:avLst/>
-          </a:prstGeom>
-          <a:noFill/>
-          <a:ln/>
-        </p:spPr>
-        <p:txBody>
-          <a:bodyPr wrap="square" lIns="0" tIns="0" rIns="0" bIns="0" rtlCol="0" anchor="ctr"/>
-          <a:lstStyle/>
-          <a:p>
-            <a:pPr indent="0" marL="0">
-              <a:buNone/>
-            </a:pPr>
-            <a:r>
-              <a:rPr lang="en-US" sz="1100" b="1" spc="200" kern="0" dirty="0">
-                <a:solidFill>
-                  <a:schemeClr val="accent4"/>
-                </a:solidFill>
-              </a:rPr>
-              <a:t>DEALSCOUT SAYS</a:t>
-            </a:r>
-            <a:endParaRPr lang="en-US" sz="1100" dirty="0"/>
-          </a:p>
-        </p:txBody>
-      </p:sp>
-      <p:sp>
-        <p:nvSpPr>
-          <p:cNvPr id="9" name="Fact value 3"/>
-          <p:cNvSpPr txBox="1"/>
-          <p:nvPr/>
-        </p:nvSpPr>
-        <p:spPr>
-          <a:xfrm>
-            <a:off x="6217920" y="3822192"/>
-            <a:ext cx="2377440" cy="640080"/>
-          </a:xfrm>
-          <a:prstGeom prst="rect">
-            <a:avLst/>
-          </a:prstGeom>
-          <a:noFill/>
-          <a:ln/>
-        </p:spPr>
-        <p:txBody>
-          <a:bodyPr wrap="square" lIns="0" tIns="0" rIns="0" bIns="0" rtlCol="0" anchor="t"/>
-          <a:lstStyle/>
-          <a:p>
-            <a:pPr indent="0" marL="0">
-              <a:buNone/>
-            </a:pPr>
-            <a:r>
-              <a:rPr lang="en-US" sz="1800" b="1" dirty="0">
-                <a:solidFill>
-                  <a:schemeClr val="accent1"/>
-                </a:solidFill>
-                <a:latin typeface="Cambria" pitchFamily="34" charset="0"/>
-                <a:ea typeface="Cambria" pitchFamily="34" charset="-122"/>
-                <a:cs typeface="Cambria" pitchFamily="34" charset="-120"/>
-              </a:rPr>
-              <a:t>Wait. Not a real deal.</a:t>
-            </a:r>
-            <a:endParaRPr lang="en-US" sz="1800" dirty="0"/>
+              <a:rPr lang="en-US" sz="1400" dirty="0">
+                <a:solidFill>
+                  <a:schemeClr val="tx2"/>
+                </a:solidFill>
+              </a:rPr>
+              <a:t>Every line is a real step. It rules out products, checks price history and catches fake discounts as it goes.</a:t>
+            </a:r>
+            <a:endParaRPr lang="en-US" sz="1400" dirty="0"/>
           </a:p>
         </p:txBody>
       </p:sp>
@@ -5735,49 +5433,38 @@
                 <a:ea typeface="Cambria" pitchFamily="34" charset="-122"/>
                 <a:cs typeface="Cambria" pitchFamily="34" charset="-120"/>
               </a:rPr>
-              <a:t>Built on Gemini and Google Cloud</a:t>
+              <a:t>A 35% discount on a price that never moved</a:t>
             </a:r>
             <a:endParaRPr lang="en-US" sz="3000" dirty="0"/>
           </a:p>
         </p:txBody>
       </p:sp>
-      <p:sp>
-        <p:nvSpPr>
-          <p:cNvPr id="3" name="Box Cloud Scheduler"/>
-          <p:cNvSpPr/>
-          <p:nvPr/>
-        </p:nvSpPr>
-        <p:spPr>
-          <a:xfrm>
-            <a:off x="548640" y="1600200"/>
-            <a:ext cx="1463040" cy="1828800"/>
-          </a:xfrm>
-          <a:prstGeom prst="roundRect">
-            <a:avLst>
-              <a:gd name="adj" fmla="val 5000"/>
-            </a:avLst>
-          </a:prstGeom>
-          <a:solidFill>
-            <a:schemeClr val="bg2"/>
-          </a:solidFill>
-          <a:ln w="12700">
-            <a:solidFill>
-              <a:schemeClr val="bg2"/>
-            </a:solidFill>
-            <a:prstDash val="solid"/>
-          </a:ln>
-        </p:spPr>
-      </p:sp>
-      <p:sp>
-        <p:nvSpPr>
-          <p:cNvPr id="4" name="Box title Cloud Scheduler"/>
+      <p:graphicFrame>
+        <p:nvGraphicFramePr>
+          <p:cNvPr id="3" name="Chart 0" descr=""/>
+          <p:cNvGraphicFramePr/>
+          <p:nvPr/>
+        </p:nvGraphicFramePr>
+        <p:xfrm>
+          <a:off x="457200" y="1280160"/>
+          <a:ext cx="5394960" cy="3383280"/>
+        </p:xfrm>
+        <a:graphic xmlns:a="http://schemas.openxmlformats.org/drawingml/2006/main">
+          <a:graphicData uri="http://schemas.openxmlformats.org/drawingml/2006/chart">
+            <c:chart xmlns:c="http://schemas.openxmlformats.org/drawingml/2006/chart" r:id="rId1"/>
+          </a:graphicData>
+        </a:graphic>
+      </p:graphicFrame>
+      <p:sp>
+        <p:nvSpPr>
+          <p:cNvPr id="4" name="Fact label 1"/>
           <p:cNvSpPr txBox="1"/>
           <p:nvPr/>
         </p:nvSpPr>
         <p:spPr>
           <a:xfrm>
-            <a:off x="685800" y="1783080"/>
-            <a:ext cx="1188720" cy="320040"/>
+            <a:off x="6217920" y="1463040"/>
+            <a:ext cx="2377440" cy="228600"/>
           </a:xfrm>
           <a:prstGeom prst="rect">
             <a:avLst/>
@@ -5793,27 +5480,27 @@
               <a:buNone/>
             </a:pPr>
             <a:r>
-              <a:rPr lang="en-US" sz="1500" b="1" dirty="0">
-                <a:solidFill>
-                  <a:schemeClr val="tx1"/>
-                </a:solidFill>
-              </a:rPr>
-              <a:t>Cloud Scheduler</a:t>
-            </a:r>
-            <a:endParaRPr lang="en-US" sz="1500" dirty="0"/>
-          </a:p>
-        </p:txBody>
-      </p:sp>
-      <p:sp>
-        <p:nvSpPr>
-          <p:cNvPr id="5" name="Box body Cloud Scheduler"/>
+              <a:rPr lang="en-US" sz="1100" b="1" spc="200" kern="0" dirty="0">
+                <a:solidFill>
+                  <a:schemeClr val="accent4"/>
+                </a:solidFill>
+              </a:rPr>
+              <a:t>STORE CLAIMS</a:t>
+            </a:r>
+            <a:endParaRPr lang="en-US" sz="1100" dirty="0"/>
+          </a:p>
+        </p:txBody>
+      </p:sp>
+      <p:sp>
+        <p:nvSpPr>
+          <p:cNvPr id="5" name="Fact value 1"/>
           <p:cNvSpPr txBox="1"/>
           <p:nvPr/>
         </p:nvSpPr>
         <p:spPr>
           <a:xfrm>
-            <a:off x="685800" y="2194560"/>
-            <a:ext cx="1188720" cy="777240"/>
+            <a:off x="6217920" y="1719072"/>
+            <a:ext cx="2377440" cy="640080"/>
           </a:xfrm>
           <a:prstGeom prst="rect">
             <a:avLst/>
@@ -5829,27 +5516,30 @@
               <a:buNone/>
             </a:pPr>
             <a:r>
-              <a:rPr lang="en-US" sz="1200" dirty="0">
-                <a:solidFill>
-                  <a:schemeClr val="tx2"/>
-                </a:solidFill>
-              </a:rPr>
-              <a:t>Triggers the daily run</a:t>
-            </a:r>
-            <a:endParaRPr lang="en-US" sz="1200" dirty="0"/>
-          </a:p>
-        </p:txBody>
-      </p:sp>
-      <p:sp>
-        <p:nvSpPr>
-          <p:cNvPr id="6" name="Box status Cloud Scheduler"/>
+              <a:rPr lang="en-US" sz="1800" b="1" dirty="0">
+                <a:solidFill>
+                  <a:schemeClr val="accent3"/>
+                </a:solidFill>
+                <a:latin typeface="Cambria" pitchFamily="34" charset="0"/>
+                <a:ea typeface="Cambria" pitchFamily="34" charset="-122"/>
+                <a:cs typeface="Cambria" pitchFamily="34" charset="-120"/>
+              </a:rPr>
+              <a:t>35% off ₹12,999</a:t>
+            </a:r>
+            <a:endParaRPr lang="en-US" sz="1800" dirty="0"/>
+          </a:p>
+        </p:txBody>
+      </p:sp>
+      <p:sp>
+        <p:nvSpPr>
+          <p:cNvPr id="6" name="Fact label 2"/>
           <p:cNvSpPr txBox="1"/>
           <p:nvPr/>
         </p:nvSpPr>
         <p:spPr>
           <a:xfrm>
-            <a:off x="685800" y="3063240"/>
-            <a:ext cx="1188720" cy="228600"/>
+            <a:off x="6217920" y="2514600"/>
+            <a:ext cx="2377440" cy="228600"/>
           </a:xfrm>
           <a:prstGeom prst="rect">
             <a:avLst/>
@@ -5867,10 +5557,10 @@
             <a:r>
               <a:rPr lang="en-US" sz="1100" b="1" spc="200" kern="0" dirty="0">
                 <a:solidFill>
-                  <a:schemeClr val="accent2"/>
-                </a:solidFill>
-              </a:rPr>
-              <a:t>NEXT</a:t>
+                  <a:schemeClr val="accent4"/>
+                </a:solidFill>
+              </a:rPr>
+              <a:t>REALITY</a:t>
             </a:r>
             <a:endParaRPr lang="en-US" sz="1100" dirty="0"/>
           </a:p>
@@ -5878,757 +5568,115 @@
       </p:sp>
       <p:sp>
         <p:nvSpPr>
-          <p:cNvPr id="7" name="Arrow 1"/>
+          <p:cNvPr id="7" name="Fact value 2"/>
           <p:cNvSpPr txBox="1"/>
           <p:nvPr/>
         </p:nvSpPr>
         <p:spPr>
           <a:xfrm>
-            <a:off x="2011680" y="2240280"/>
-            <a:ext cx="164592" cy="365760"/>
-          </a:xfrm>
-          <a:prstGeom prst="rect">
-            <a:avLst/>
-          </a:prstGeom>
-          <a:noFill/>
-          <a:ln/>
-        </p:spPr>
-        <p:txBody>
-          <a:bodyPr wrap="square" lIns="0" tIns="0" rIns="0" bIns="0" rtlCol="0" anchor="ctr"/>
-          <a:lstStyle/>
-          <a:p>
-            <a:pPr algn="ctr" indent="0" marL="0">
-              <a:buNone/>
-            </a:pPr>
-            <a:r>
-              <a:rPr lang="en-US" sz="1800" dirty="0">
-                <a:solidFill>
-                  <a:schemeClr val="accent4"/>
-                </a:solidFill>
-              </a:rPr>
-              <a:t>→</a:t>
-            </a:r>
-            <a:endParaRPr lang="en-US" sz="1800" dirty="0"/>
-          </a:p>
-        </p:txBody>
-      </p:sp>
-      <p:sp>
-        <p:nvSpPr>
-          <p:cNvPr id="8" name="Box Cloud Run"/>
-          <p:cNvSpPr/>
-          <p:nvPr/>
-        </p:nvSpPr>
-        <p:spPr>
-          <a:xfrm>
-            <a:off x="2176272" y="1600200"/>
-            <a:ext cx="1463040" cy="1828800"/>
-          </a:xfrm>
-          <a:prstGeom prst="roundRect">
-            <a:avLst>
-              <a:gd name="adj" fmla="val 5000"/>
-            </a:avLst>
-          </a:prstGeom>
-          <a:solidFill>
-            <a:schemeClr val="bg2"/>
-          </a:solidFill>
-          <a:ln w="12700">
-            <a:solidFill>
-              <a:schemeClr val="bg2"/>
-            </a:solidFill>
-            <a:prstDash val="solid"/>
-          </a:ln>
-        </p:spPr>
-      </p:sp>
-      <p:sp>
-        <p:nvSpPr>
-          <p:cNvPr id="9" name="Box title Cloud Run"/>
-          <p:cNvSpPr txBox="1"/>
-          <p:nvPr/>
-        </p:nvSpPr>
-        <p:spPr>
-          <a:xfrm>
-            <a:off x="2313432" y="1783080"/>
-            <a:ext cx="1188720" cy="320040"/>
-          </a:xfrm>
-          <a:prstGeom prst="rect">
-            <a:avLst/>
-          </a:prstGeom>
-          <a:noFill/>
-          <a:ln/>
-        </p:spPr>
-        <p:txBody>
-          <a:bodyPr wrap="square" lIns="0" tIns="0" rIns="0" bIns="0" rtlCol="0" anchor="ctr"/>
+            <a:off x="6217920" y="2770632"/>
+            <a:ext cx="2377440" cy="640080"/>
+          </a:xfrm>
+          <a:prstGeom prst="rect">
+            <a:avLst/>
+          </a:prstGeom>
+          <a:noFill/>
+          <a:ln/>
+        </p:spPr>
+        <p:txBody>
+          <a:bodyPr wrap="square" lIns="0" tIns="0" rIns="0" bIns="0" rtlCol="0" anchor="t"/>
           <a:lstStyle/>
           <a:p>
             <a:pPr indent="0" marL="0">
               <a:buNone/>
             </a:pPr>
             <a:r>
-              <a:rPr lang="en-US" sz="1500" b="1" dirty="0">
+              <a:rPr lang="en-US" sz="1800" b="1" dirty="0">
                 <a:solidFill>
                   <a:schemeClr val="tx1"/>
                 </a:solidFill>
-              </a:rPr>
-              <a:t>Cloud Run</a:t>
-            </a:r>
-            <a:endParaRPr lang="en-US" sz="1500" dirty="0"/>
-          </a:p>
-        </p:txBody>
-      </p:sp>
-      <p:sp>
-        <p:nvSpPr>
-          <p:cNvPr id="10" name="Box body Cloud Run"/>
+                <a:latin typeface="Cambria" pitchFamily="34" charset="0"/>
+                <a:ea typeface="Cambria" pitchFamily="34" charset="-122"/>
+                <a:cs typeface="Cambria" pitchFamily="34" charset="-120"/>
+              </a:rPr>
+              <a:t>₹8,199 to ₹8,699 for 60 days</a:t>
+            </a:r>
+            <a:endParaRPr lang="en-US" sz="1800" dirty="0"/>
+          </a:p>
+        </p:txBody>
+      </p:sp>
+      <p:sp>
+        <p:nvSpPr>
+          <p:cNvPr id="8" name="Fact label 3"/>
           <p:cNvSpPr txBox="1"/>
           <p:nvPr/>
         </p:nvSpPr>
         <p:spPr>
           <a:xfrm>
-            <a:off x="2313432" y="2194560"/>
-            <a:ext cx="1188720" cy="777240"/>
-          </a:xfrm>
-          <a:prstGeom prst="rect">
-            <a:avLst/>
-          </a:prstGeom>
-          <a:noFill/>
-          <a:ln/>
-        </p:spPr>
-        <p:txBody>
-          <a:bodyPr wrap="square" lIns="0" tIns="0" rIns="0" bIns="0" rtlCol="0" anchor="t"/>
+            <a:off x="6217920" y="3566160"/>
+            <a:ext cx="2377440" cy="228600"/>
+          </a:xfrm>
+          <a:prstGeom prst="rect">
+            <a:avLst/>
+          </a:prstGeom>
+          <a:noFill/>
+          <a:ln/>
+        </p:spPr>
+        <p:txBody>
+          <a:bodyPr wrap="square" lIns="0" tIns="0" rIns="0" bIns="0" rtlCol="0" anchor="ctr"/>
           <a:lstStyle/>
           <a:p>
             <a:pPr indent="0" marL="0">
               <a:buNone/>
             </a:pPr>
             <a:r>
-              <a:rPr lang="en-US" sz="1200" dirty="0">
-                <a:solidFill>
-                  <a:schemeClr val="tx2"/>
-                </a:solidFill>
-              </a:rPr>
-              <a:t>Runs the scout service</a:t>
-            </a:r>
-            <a:endParaRPr lang="en-US" sz="1200" dirty="0"/>
-          </a:p>
-        </p:txBody>
-      </p:sp>
-      <p:sp>
-        <p:nvSpPr>
-          <p:cNvPr id="11" name="Box status Cloud Run"/>
+              <a:rPr lang="en-US" sz="1100" b="1" spc="200" kern="0" dirty="0">
+                <a:solidFill>
+                  <a:schemeClr val="accent4"/>
+                </a:solidFill>
+              </a:rPr>
+              <a:t>DEALSCOUT SAYS</a:t>
+            </a:r>
+            <a:endParaRPr lang="en-US" sz="1100" dirty="0"/>
+          </a:p>
+        </p:txBody>
+      </p:sp>
+      <p:sp>
+        <p:nvSpPr>
+          <p:cNvPr id="9" name="Fact value 3"/>
           <p:cNvSpPr txBox="1"/>
           <p:nvPr/>
         </p:nvSpPr>
         <p:spPr>
           <a:xfrm>
-            <a:off x="2313432" y="3063240"/>
-            <a:ext cx="1188720" cy="228600"/>
-          </a:xfrm>
-          <a:prstGeom prst="rect">
-            <a:avLst/>
-          </a:prstGeom>
-          <a:noFill/>
-          <a:ln/>
-        </p:spPr>
-        <p:txBody>
-          <a:bodyPr wrap="square" lIns="0" tIns="0" rIns="0" bIns="0" rtlCol="0" anchor="ctr"/>
+            <a:off x="6217920" y="3822192"/>
+            <a:ext cx="2377440" cy="640080"/>
+          </a:xfrm>
+          <a:prstGeom prst="rect">
+            <a:avLst/>
+          </a:prstGeom>
+          <a:noFill/>
+          <a:ln/>
+        </p:spPr>
+        <p:txBody>
+          <a:bodyPr wrap="square" lIns="0" tIns="0" rIns="0" bIns="0" rtlCol="0" anchor="t"/>
           <a:lstStyle/>
           <a:p>
             <a:pPr indent="0" marL="0">
               <a:buNone/>
             </a:pPr>
             <a:r>
-              <a:rPr lang="en-US" sz="1100" b="1" spc="200" kern="0" dirty="0">
-                <a:solidFill>
-                  <a:schemeClr val="accent2"/>
-                </a:solidFill>
-              </a:rPr>
-              <a:t>NEXT</a:t>
-            </a:r>
-            <a:endParaRPr lang="en-US" sz="1100" dirty="0"/>
-          </a:p>
-        </p:txBody>
-      </p:sp>
-      <p:sp>
-        <p:nvSpPr>
-          <p:cNvPr id="12" name="Arrow 2"/>
-          <p:cNvSpPr txBox="1"/>
-          <p:nvPr/>
-        </p:nvSpPr>
-        <p:spPr>
-          <a:xfrm>
-            <a:off x="3639312" y="2240280"/>
-            <a:ext cx="164592" cy="365760"/>
-          </a:xfrm>
-          <a:prstGeom prst="rect">
-            <a:avLst/>
-          </a:prstGeom>
-          <a:noFill/>
-          <a:ln/>
-        </p:spPr>
-        <p:txBody>
-          <a:bodyPr wrap="square" lIns="0" tIns="0" rIns="0" bIns="0" rtlCol="0" anchor="ctr"/>
-          <a:lstStyle/>
-          <a:p>
-            <a:pPr algn="ctr" indent="0" marL="0">
-              <a:buNone/>
-            </a:pPr>
-            <a:r>
-              <a:rPr lang="en-US" sz="1800" dirty="0">
-                <a:solidFill>
-                  <a:schemeClr val="accent4"/>
-                </a:solidFill>
-              </a:rPr>
-              <a:t>→</a:t>
+              <a:rPr lang="en-US" sz="1800" b="1" dirty="0">
+                <a:solidFill>
+                  <a:schemeClr val="accent1"/>
+                </a:solidFill>
+                <a:latin typeface="Cambria" pitchFamily="34" charset="0"/>
+                <a:ea typeface="Cambria" pitchFamily="34" charset="-122"/>
+                <a:cs typeface="Cambria" pitchFamily="34" charset="-120"/>
+              </a:rPr>
+              <a:t>Wait. Not a real deal.</a:t>
             </a:r>
             <a:endParaRPr lang="en-US" sz="1800" dirty="0"/>
-          </a:p>
-        </p:txBody>
-      </p:sp>
-      <p:sp>
-        <p:nvSpPr>
-          <p:cNvPr id="13" name="Box Gemini"/>
-          <p:cNvSpPr/>
-          <p:nvPr/>
-        </p:nvSpPr>
-        <p:spPr>
-          <a:xfrm>
-            <a:off x="3803904" y="1600200"/>
-            <a:ext cx="1463040" cy="1828800"/>
-          </a:xfrm>
-          <a:prstGeom prst="roundRect">
-            <a:avLst>
-              <a:gd name="adj" fmla="val 5000"/>
-            </a:avLst>
-          </a:prstGeom>
-          <a:solidFill>
-            <a:schemeClr val="accent1"/>
-          </a:solidFill>
-          <a:ln w="12700">
-            <a:solidFill>
-              <a:schemeClr val="accent1"/>
-            </a:solidFill>
-            <a:prstDash val="solid"/>
-          </a:ln>
-        </p:spPr>
-      </p:sp>
-      <p:sp>
-        <p:nvSpPr>
-          <p:cNvPr id="14" name="Box title Gemini"/>
-          <p:cNvSpPr txBox="1"/>
-          <p:nvPr/>
-        </p:nvSpPr>
-        <p:spPr>
-          <a:xfrm>
-            <a:off x="3941064" y="1783080"/>
-            <a:ext cx="1188720" cy="320040"/>
-          </a:xfrm>
-          <a:prstGeom prst="rect">
-            <a:avLst/>
-          </a:prstGeom>
-          <a:noFill/>
-          <a:ln/>
-        </p:spPr>
-        <p:txBody>
-          <a:bodyPr wrap="square" lIns="0" tIns="0" rIns="0" bIns="0" rtlCol="0" anchor="ctr"/>
-          <a:lstStyle/>
-          <a:p>
-            <a:pPr indent="0" marL="0">
-              <a:buNone/>
-            </a:pPr>
-            <a:r>
-              <a:rPr lang="en-US" sz="1500" b="1" dirty="0">
-                <a:solidFill>
-                  <a:schemeClr val="bg1"/>
-                </a:solidFill>
-              </a:rPr>
-              <a:t>Gemini</a:t>
-            </a:r>
-            <a:endParaRPr lang="en-US" sz="1500" dirty="0"/>
-          </a:p>
-        </p:txBody>
-      </p:sp>
-      <p:sp>
-        <p:nvSpPr>
-          <p:cNvPr id="15" name="Box body Gemini"/>
-          <p:cNvSpPr txBox="1"/>
-          <p:nvPr/>
-        </p:nvSpPr>
-        <p:spPr>
-          <a:xfrm>
-            <a:off x="3941064" y="2194560"/>
-            <a:ext cx="1188720" cy="777240"/>
-          </a:xfrm>
-          <a:prstGeom prst="rect">
-            <a:avLst/>
-          </a:prstGeom>
-          <a:noFill/>
-          <a:ln/>
-        </p:spPr>
-        <p:txBody>
-          <a:bodyPr wrap="square" lIns="0" tIns="0" rIns="0" bIns="0" rtlCol="0" anchor="t"/>
-          <a:lstStyle/>
-          <a:p>
-            <a:pPr indent="0" marL="0">
-              <a:buNone/>
-            </a:pPr>
-            <a:r>
-              <a:rPr lang="en-US" sz="1200" dirty="0">
-                <a:solidFill>
-                  <a:schemeClr val="bg1"/>
-                </a:solidFill>
-              </a:rPr>
-              <a:t>Structured output + Google Search grounding</a:t>
-            </a:r>
-            <a:endParaRPr lang="en-US" sz="1200" dirty="0"/>
-          </a:p>
-        </p:txBody>
-      </p:sp>
-      <p:sp>
-        <p:nvSpPr>
-          <p:cNvPr id="16" name="Box status Gemini"/>
-          <p:cNvSpPr txBox="1"/>
-          <p:nvPr/>
-        </p:nvSpPr>
-        <p:spPr>
-          <a:xfrm>
-            <a:off x="3941064" y="3063240"/>
-            <a:ext cx="1188720" cy="228600"/>
-          </a:xfrm>
-          <a:prstGeom prst="rect">
-            <a:avLst/>
-          </a:prstGeom>
-          <a:noFill/>
-          <a:ln/>
-        </p:spPr>
-        <p:txBody>
-          <a:bodyPr wrap="square" lIns="0" tIns="0" rIns="0" bIns="0" rtlCol="0" anchor="ctr"/>
-          <a:lstStyle/>
-          <a:p>
-            <a:pPr indent="0" marL="0">
-              <a:buNone/>
-            </a:pPr>
-            <a:r>
-              <a:rPr lang="en-US" sz="1100" b="1" spc="200" kern="0" dirty="0">
-                <a:solidFill>
-                  <a:schemeClr val="accent6"/>
-                </a:solidFill>
-              </a:rPr>
-              <a:t>BUILT</a:t>
-            </a:r>
-            <a:endParaRPr lang="en-US" sz="1100" dirty="0"/>
-          </a:p>
-        </p:txBody>
-      </p:sp>
-      <p:sp>
-        <p:nvSpPr>
-          <p:cNvPr id="17" name="Arrow 3"/>
-          <p:cNvSpPr txBox="1"/>
-          <p:nvPr/>
-        </p:nvSpPr>
-        <p:spPr>
-          <a:xfrm>
-            <a:off x="5266944" y="2240280"/>
-            <a:ext cx="164592" cy="365760"/>
-          </a:xfrm>
-          <a:prstGeom prst="rect">
-            <a:avLst/>
-          </a:prstGeom>
-          <a:noFill/>
-          <a:ln/>
-        </p:spPr>
-        <p:txBody>
-          <a:bodyPr wrap="square" lIns="0" tIns="0" rIns="0" bIns="0" rtlCol="0" anchor="ctr"/>
-          <a:lstStyle/>
-          <a:p>
-            <a:pPr algn="ctr" indent="0" marL="0">
-              <a:buNone/>
-            </a:pPr>
-            <a:r>
-              <a:rPr lang="en-US" sz="1800" dirty="0">
-                <a:solidFill>
-                  <a:schemeClr val="accent4"/>
-                </a:solidFill>
-              </a:rPr>
-              <a:t>→</a:t>
-            </a:r>
-            <a:endParaRPr lang="en-US" sz="1800" dirty="0"/>
-          </a:p>
-        </p:txBody>
-      </p:sp>
-      <p:sp>
-        <p:nvSpPr>
-          <p:cNvPr id="18" name="Box Firestore"/>
-          <p:cNvSpPr/>
-          <p:nvPr/>
-        </p:nvSpPr>
-        <p:spPr>
-          <a:xfrm>
-            <a:off x="5431536" y="1600200"/>
-            <a:ext cx="1463040" cy="1828800"/>
-          </a:xfrm>
-          <a:prstGeom prst="roundRect">
-            <a:avLst>
-              <a:gd name="adj" fmla="val 5000"/>
-            </a:avLst>
-          </a:prstGeom>
-          <a:solidFill>
-            <a:schemeClr val="bg2"/>
-          </a:solidFill>
-          <a:ln w="12700">
-            <a:solidFill>
-              <a:schemeClr val="bg2"/>
-            </a:solidFill>
-            <a:prstDash val="solid"/>
-          </a:ln>
-        </p:spPr>
-      </p:sp>
-      <p:sp>
-        <p:nvSpPr>
-          <p:cNvPr id="19" name="Box title Firestore"/>
-          <p:cNvSpPr txBox="1"/>
-          <p:nvPr/>
-        </p:nvSpPr>
-        <p:spPr>
-          <a:xfrm>
-            <a:off x="5568696" y="1783080"/>
-            <a:ext cx="1188720" cy="320040"/>
-          </a:xfrm>
-          <a:prstGeom prst="rect">
-            <a:avLst/>
-          </a:prstGeom>
-          <a:noFill/>
-          <a:ln/>
-        </p:spPr>
-        <p:txBody>
-          <a:bodyPr wrap="square" lIns="0" tIns="0" rIns="0" bIns="0" rtlCol="0" anchor="ctr"/>
-          <a:lstStyle/>
-          <a:p>
-            <a:pPr indent="0" marL="0">
-              <a:buNone/>
-            </a:pPr>
-            <a:r>
-              <a:rPr lang="en-US" sz="1500" b="1" dirty="0">
-                <a:solidFill>
-                  <a:schemeClr val="tx1"/>
-                </a:solidFill>
-              </a:rPr>
-              <a:t>Firestore</a:t>
-            </a:r>
-            <a:endParaRPr lang="en-US" sz="1500" dirty="0"/>
-          </a:p>
-        </p:txBody>
-      </p:sp>
-      <p:sp>
-        <p:nvSpPr>
-          <p:cNvPr id="20" name="Box body Firestore"/>
-          <p:cNvSpPr txBox="1"/>
-          <p:nvPr/>
-        </p:nvSpPr>
-        <p:spPr>
-          <a:xfrm>
-            <a:off x="5568696" y="2194560"/>
-            <a:ext cx="1188720" cy="777240"/>
-          </a:xfrm>
-          <a:prstGeom prst="rect">
-            <a:avLst/>
-          </a:prstGeom>
-          <a:noFill/>
-          <a:ln/>
-        </p:spPr>
-        <p:txBody>
-          <a:bodyPr wrap="square" lIns="0" tIns="0" rIns="0" bIns="0" rtlCol="0" anchor="t"/>
-          <a:lstStyle/>
-          <a:p>
-            <a:pPr indent="0" marL="0">
-              <a:buNone/>
-            </a:pPr>
-            <a:r>
-              <a:rPr lang="en-US" sz="1200" dirty="0">
-                <a:solidFill>
-                  <a:schemeClr val="tx2"/>
-                </a:solidFill>
-              </a:rPr>
-              <a:t>Daily price history</a:t>
-            </a:r>
-            <a:endParaRPr lang="en-US" sz="1200" dirty="0"/>
-          </a:p>
-        </p:txBody>
-      </p:sp>
-      <p:sp>
-        <p:nvSpPr>
-          <p:cNvPr id="21" name="Box status Firestore"/>
-          <p:cNvSpPr txBox="1"/>
-          <p:nvPr/>
-        </p:nvSpPr>
-        <p:spPr>
-          <a:xfrm>
-            <a:off x="5568696" y="3063240"/>
-            <a:ext cx="1188720" cy="228600"/>
-          </a:xfrm>
-          <a:prstGeom prst="rect">
-            <a:avLst/>
-          </a:prstGeom>
-          <a:noFill/>
-          <a:ln/>
-        </p:spPr>
-        <p:txBody>
-          <a:bodyPr wrap="square" lIns="0" tIns="0" rIns="0" bIns="0" rtlCol="0" anchor="ctr"/>
-          <a:lstStyle/>
-          <a:p>
-            <a:pPr indent="0" marL="0">
-              <a:buNone/>
-            </a:pPr>
-            <a:r>
-              <a:rPr lang="en-US" sz="1100" b="1" spc="200" kern="0" dirty="0">
-                <a:solidFill>
-                  <a:schemeClr val="accent2"/>
-                </a:solidFill>
-              </a:rPr>
-              <a:t>NEXT</a:t>
-            </a:r>
-            <a:endParaRPr lang="en-US" sz="1100" dirty="0"/>
-          </a:p>
-        </p:txBody>
-      </p:sp>
-      <p:sp>
-        <p:nvSpPr>
-          <p:cNvPr id="22" name="Arrow 4"/>
-          <p:cNvSpPr txBox="1"/>
-          <p:nvPr/>
-        </p:nvSpPr>
-        <p:spPr>
-          <a:xfrm>
-            <a:off x="6894576" y="2240280"/>
-            <a:ext cx="164592" cy="365760"/>
-          </a:xfrm>
-          <a:prstGeom prst="rect">
-            <a:avLst/>
-          </a:prstGeom>
-          <a:noFill/>
-          <a:ln/>
-        </p:spPr>
-        <p:txBody>
-          <a:bodyPr wrap="square" lIns="0" tIns="0" rIns="0" bIns="0" rtlCol="0" anchor="ctr"/>
-          <a:lstStyle/>
-          <a:p>
-            <a:pPr algn="ctr" indent="0" marL="0">
-              <a:buNone/>
-            </a:pPr>
-            <a:r>
-              <a:rPr lang="en-US" sz="1800" dirty="0">
-                <a:solidFill>
-                  <a:schemeClr val="accent4"/>
-                </a:solidFill>
-              </a:rPr>
-              <a:t>→</a:t>
-            </a:r>
-            <a:endParaRPr lang="en-US" sz="1800" dirty="0"/>
-          </a:p>
-        </p:txBody>
-      </p:sp>
-      <p:sp>
-        <p:nvSpPr>
-          <p:cNvPr id="23" name="Box Email"/>
-          <p:cNvSpPr/>
-          <p:nvPr/>
-        </p:nvSpPr>
-        <p:spPr>
-          <a:xfrm>
-            <a:off x="7059168" y="1600200"/>
-            <a:ext cx="1463040" cy="1828800"/>
-          </a:xfrm>
-          <a:prstGeom prst="roundRect">
-            <a:avLst>
-              <a:gd name="adj" fmla="val 5000"/>
-            </a:avLst>
-          </a:prstGeom>
-          <a:solidFill>
-            <a:schemeClr val="bg2"/>
-          </a:solidFill>
-          <a:ln w="12700">
-            <a:solidFill>
-              <a:schemeClr val="bg2"/>
-            </a:solidFill>
-            <a:prstDash val="solid"/>
-          </a:ln>
-        </p:spPr>
-      </p:sp>
-      <p:sp>
-        <p:nvSpPr>
-          <p:cNvPr id="24" name="Box title Email"/>
-          <p:cNvSpPr txBox="1"/>
-          <p:nvPr/>
-        </p:nvSpPr>
-        <p:spPr>
-          <a:xfrm>
-            <a:off x="7196328" y="1783080"/>
-            <a:ext cx="1188720" cy="320040"/>
-          </a:xfrm>
-          <a:prstGeom prst="rect">
-            <a:avLst/>
-          </a:prstGeom>
-          <a:noFill/>
-          <a:ln/>
-        </p:spPr>
-        <p:txBody>
-          <a:bodyPr wrap="square" lIns="0" tIns="0" rIns="0" bIns="0" rtlCol="0" anchor="ctr"/>
-          <a:lstStyle/>
-          <a:p>
-            <a:pPr indent="0" marL="0">
-              <a:buNone/>
-            </a:pPr>
-            <a:r>
-              <a:rPr lang="en-US" sz="1500" b="1" dirty="0">
-                <a:solidFill>
-                  <a:schemeClr val="tx1"/>
-                </a:solidFill>
-              </a:rPr>
-              <a:t>Email</a:t>
-            </a:r>
-            <a:endParaRPr lang="en-US" sz="1500" dirty="0"/>
-          </a:p>
-        </p:txBody>
-      </p:sp>
-      <p:sp>
-        <p:nvSpPr>
-          <p:cNvPr id="25" name="Box body Email"/>
-          <p:cNvSpPr txBox="1"/>
-          <p:nvPr/>
-        </p:nvSpPr>
-        <p:spPr>
-          <a:xfrm>
-            <a:off x="7196328" y="2194560"/>
-            <a:ext cx="1188720" cy="777240"/>
-          </a:xfrm>
-          <a:prstGeom prst="rect">
-            <a:avLst/>
-          </a:prstGeom>
-          <a:noFill/>
-          <a:ln/>
-        </p:spPr>
-        <p:txBody>
-          <a:bodyPr wrap="square" lIns="0" tIns="0" rIns="0" bIns="0" rtlCol="0" anchor="t"/>
-          <a:lstStyle/>
-          <a:p>
-            <a:pPr indent="0" marL="0">
-              <a:buNone/>
-            </a:pPr>
-            <a:r>
-              <a:rPr lang="en-US" sz="1200" dirty="0">
-                <a:solidFill>
-                  <a:schemeClr val="tx2"/>
-                </a:solidFill>
-              </a:rPr>
-              <a:t>Firebase email digest</a:t>
-            </a:r>
-            <a:endParaRPr lang="en-US" sz="1200" dirty="0"/>
-          </a:p>
-        </p:txBody>
-      </p:sp>
-      <p:sp>
-        <p:nvSpPr>
-          <p:cNvPr id="26" name="Box status Email"/>
-          <p:cNvSpPr txBox="1"/>
-          <p:nvPr/>
-        </p:nvSpPr>
-        <p:spPr>
-          <a:xfrm>
-            <a:off x="7196328" y="3063240"/>
-            <a:ext cx="1188720" cy="228600"/>
-          </a:xfrm>
-          <a:prstGeom prst="rect">
-            <a:avLst/>
-          </a:prstGeom>
-          <a:noFill/>
-          <a:ln/>
-        </p:spPr>
-        <p:txBody>
-          <a:bodyPr wrap="square" lIns="0" tIns="0" rIns="0" bIns="0" rtlCol="0" anchor="ctr"/>
-          <a:lstStyle/>
-          <a:p>
-            <a:pPr indent="0" marL="0">
-              <a:buNone/>
-            </a:pPr>
-            <a:r>
-              <a:rPr lang="en-US" sz="1100" b="1" spc="200" kern="0" dirty="0">
-                <a:solidFill>
-                  <a:schemeClr val="accent2"/>
-                </a:solidFill>
-              </a:rPr>
-              <a:t>NEXT</a:t>
-            </a:r>
-            <a:endParaRPr lang="en-US" sz="1100" dirty="0"/>
-          </a:p>
-        </p:txBody>
-      </p:sp>
-      <p:sp>
-        <p:nvSpPr>
-          <p:cNvPr id="27" name="Interface note"/>
-          <p:cNvSpPr txBox="1"/>
-          <p:nvPr/>
-        </p:nvSpPr>
-        <p:spPr>
-          <a:xfrm>
-            <a:off x="548640" y="3794760"/>
-            <a:ext cx="8046720" cy="365760"/>
-          </a:xfrm>
-          <a:prstGeom prst="rect">
-            <a:avLst/>
-          </a:prstGeom>
-          <a:noFill/>
-          <a:ln/>
-        </p:spPr>
-        <p:txBody>
-          <a:bodyPr wrap="square" lIns="0" tIns="0" rIns="0" bIns="0" rtlCol="0" anchor="ctr"/>
-          <a:lstStyle/>
-          <a:p>
-            <a:pPr indent="0" marL="0">
-              <a:buNone/>
-            </a:pPr>
-            <a:r>
-              <a:rPr lang="en-US" sz="1600" b="1" dirty="0">
-                <a:solidFill>
-                  <a:schemeClr val="tx1"/>
-                </a:solidFill>
-              </a:rPr>
-              <a:t>One PriceSource interface: Google Search today, retailer APIs as we scale.</a:t>
-            </a:r>
-            <a:endParaRPr lang="en-US" sz="1600" dirty="0"/>
-          </a:p>
-        </p:txBody>
-      </p:sp>
-      <p:sp>
-        <p:nvSpPr>
-          <p:cNvPr id="28" name="Prototype note"/>
-          <p:cNvSpPr txBox="1"/>
-          <p:nvPr/>
-        </p:nvSpPr>
-        <p:spPr>
-          <a:xfrm>
-            <a:off x="548640" y="4206240"/>
-            <a:ext cx="8046720" cy="320040"/>
-          </a:xfrm>
-          <a:prstGeom prst="rect">
-            <a:avLst/>
-          </a:prstGeom>
-          <a:noFill/>
-          <a:ln/>
-        </p:spPr>
-        <p:txBody>
-          <a:bodyPr wrap="square" lIns="0" tIns="0" rIns="0" bIns="0" rtlCol="0" anchor="ctr"/>
-          <a:lstStyle/>
-          <a:p>
-            <a:pPr indent="0" marL="0">
-              <a:buNone/>
-            </a:pPr>
-            <a:r>
-              <a:rPr lang="en-US" sz="1300" dirty="0">
-                <a:solidFill>
-                  <a:schemeClr val="accent4"/>
-                </a:solidFill>
-              </a:rPr>
-              <a:t>In the prototype, prices are saved to a local file and the digest is written as HTML.</a:t>
-            </a:r>
-            <a:endParaRPr lang="en-US" sz="1300" dirty="0"/>
           </a:p>
         </p:txBody>
       </p:sp>
@@ -6737,359 +5785,69 @@
                 <a:ea typeface="Cambria" pitchFamily="34" charset="-122"/>
                 <a:cs typeface="Cambria" pitchFamily="34" charset="-120"/>
               </a:rPr>
-              <a:t>Working today, and what comes next</a:t>
+              <a:t>It checks the fit, not only the price</a:t>
             </a:r>
             <a:endParaRPr lang="en-US" sz="3000" dirty="0"/>
           </a:p>
         </p:txBody>
       </p:sp>
-      <p:sp>
-        <p:nvSpPr>
-          <p:cNvPr id="3" name="Today card"/>
-          <p:cNvSpPr/>
-          <p:nvPr/>
-        </p:nvSpPr>
-        <p:spPr>
-          <a:xfrm>
-            <a:off x="548640" y="1371600"/>
-            <a:ext cx="3931920" cy="3108960"/>
-          </a:xfrm>
-          <a:prstGeom prst="roundRect">
-            <a:avLst>
-              <a:gd name="adj" fmla="val 2353"/>
-            </a:avLst>
-          </a:prstGeom>
-          <a:solidFill>
-            <a:schemeClr val="bg2"/>
-          </a:solidFill>
-          <a:ln w="12700">
-            <a:solidFill>
-              <a:schemeClr val="bg2"/>
-            </a:solidFill>
-            <a:prstDash val="solid"/>
-          </a:ln>
-        </p:spPr>
-      </p:sp>
-      <p:sp>
-        <p:nvSpPr>
-          <p:cNvPr id="4" name="Today heading"/>
+      <p:pic>
+        <p:nvPicPr>
+          <p:cNvPr id="3" name="Fit screenshot" descr="/private/tmp/claude-502/-Users-meenu-Downloads-D2/12731e38-32f4-44ab-831f-f37e8cc97cf7/scratchpad/shots/fit.png">    </p:cNvPr>
+          <p:cNvPicPr>
+            <a:picLocks noChangeAspect="1"/>
+          </p:cNvPicPr>
+          <p:nvPr/>
+        </p:nvPicPr>
+        <p:blipFill>
+          <a:blip r:embed="rId1"/>
+          <a:stretch>
+            <a:fillRect/>
+          </a:stretch>
+        </p:blipFill>
+        <p:spPr>
+          <a:xfrm>
+            <a:off x="548640" y="1325880"/>
+            <a:ext cx="8046720" cy="2697480"/>
+          </a:xfrm>
+          <a:prstGeom prst="rect">
+            <a:avLst/>
+          </a:prstGeom>
+        </p:spPr>
+      </p:pic>
+      <p:sp>
+        <p:nvSpPr>
+          <p:cNvPr id="4" name="Fit caption"/>
           <p:cNvSpPr txBox="1"/>
           <p:nvPr/>
         </p:nvSpPr>
         <p:spPr>
           <a:xfrm>
-            <a:off x="822960" y="1554480"/>
-            <a:ext cx="3383280" cy="274320"/>
-          </a:xfrm>
-          <a:prstGeom prst="rect">
-            <a:avLst/>
-          </a:prstGeom>
-          <a:noFill/>
-          <a:ln/>
-        </p:spPr>
-        <p:txBody>
-          <a:bodyPr wrap="square" lIns="0" tIns="0" rIns="0" bIns="0" rtlCol="0" anchor="ctr"/>
+            <a:off x="548640" y="4206240"/>
+            <a:ext cx="8046720" cy="548640"/>
+          </a:xfrm>
+          <a:prstGeom prst="rect">
+            <a:avLst/>
+          </a:prstGeom>
+          <a:noFill/>
+          <a:ln/>
+        </p:spPr>
+        <p:txBody>
+          <a:bodyPr wrap="square" lIns="0" tIns="0" rIns="0" bIns="0" rtlCol="0" anchor="t"/>
           <a:lstStyle/>
           <a:p>
             <a:pPr indent="0" marL="0">
               <a:buNone/>
             </a:pPr>
             <a:r>
-              <a:rPr lang="en-US" sz="1200" b="1" spc="200" kern="0" dirty="0">
-                <a:solidFill>
-                  <a:schemeClr val="accent1"/>
-                </a:solidFill>
-              </a:rPr>
-              <a:t>WORKING TODAY</a:t>
-            </a:r>
-            <a:endParaRPr lang="en-US" sz="1200" dirty="0"/>
-          </a:p>
-        </p:txBody>
-      </p:sp>
-      <p:sp>
-        <p:nvSpPr>
-          <p:cNvPr id="5" name="Today list"/>
-          <p:cNvSpPr txBox="1"/>
-          <p:nvPr/>
-        </p:nvSpPr>
-        <p:spPr>
-          <a:xfrm>
-            <a:off x="822960" y="1920240"/>
-            <a:ext cx="3383280" cy="2011680"/>
-          </a:xfrm>
-          <a:prstGeom prst="rect">
-            <a:avLst/>
-          </a:prstGeom>
-          <a:noFill/>
-          <a:ln/>
-        </p:spPr>
-        <p:txBody>
-          <a:bodyPr wrap="square" lIns="0" tIns="0" rIns="0" bIns="0" rtlCol="0" anchor="t"/>
-          <a:lstStyle/>
-          <a:p>
-            <a:pPr marL="342900" indent="-342900">
-              <a:spcAft>
-                <a:spcPts val="800"/>
-              </a:spcAft>
-              <a:buSzPct val="100000"/>
-              <a:buChar char="•"/>
-            </a:pPr>
-            <a:r>
-              <a:rPr lang="en-US" sz="1400" dirty="0">
+              <a:rPr lang="en-US" sz="1600" dirty="0">
                 <a:solidFill>
                   <a:schemeClr val="tx1"/>
                 </a:solidFill>
               </a:rPr>
-              <a:t>Fake-discount and verdict logic, covered by 12 tests</a:t>
-            </a:r>
-            <a:endParaRPr lang="en-US" sz="1400" dirty="0"/>
-          </a:p>
-          <a:p>
-            <a:pPr marL="342900" indent="-342900">
-              <a:spcAft>
-                <a:spcPts val="800"/>
-              </a:spcAft>
-              <a:buSzPct val="100000"/>
-              <a:buChar char="•"/>
-            </a:pPr>
-            <a:r>
-              <a:rPr lang="en-US" sz="1400" dirty="0">
-                <a:solidFill>
-                  <a:schemeClr val="tx1"/>
-                </a:solidFill>
-              </a:rPr>
-              <a:t>Gemini watch spec from plain English</a:t>
-            </a:r>
-            <a:endParaRPr lang="en-US" sz="1400" dirty="0"/>
-          </a:p>
-          <a:p>
-            <a:pPr marL="342900" indent="-342900">
-              <a:spcAft>
-                <a:spcPts val="800"/>
-              </a:spcAft>
-              <a:buSzPct val="100000"/>
-              <a:buChar char="•"/>
-            </a:pPr>
-            <a:r>
-              <a:rPr lang="en-US" sz="1400" dirty="0">
-                <a:solidFill>
-                  <a:schemeClr val="tx1"/>
-                </a:solidFill>
-              </a:rPr>
-              <a:t>Google Search product discovery</a:t>
-            </a:r>
-            <a:endParaRPr lang="en-US" sz="1400" dirty="0"/>
-          </a:p>
-          <a:p>
-            <a:pPr marL="342900" indent="-342900">
-              <a:spcAft>
-                <a:spcPts val="800"/>
-              </a:spcAft>
-              <a:buSzPct val="100000"/>
-              <a:buChar char="•"/>
-            </a:pPr>
-            <a:r>
-              <a:rPr lang="en-US" sz="1400" dirty="0">
-                <a:solidFill>
-                  <a:schemeClr val="tx1"/>
-                </a:solidFill>
-              </a:rPr>
-              <a:t>Digest as text and HTML</a:t>
-            </a:r>
-            <a:endParaRPr lang="en-US" sz="1400" dirty="0"/>
-          </a:p>
-        </p:txBody>
-      </p:sp>
-      <p:sp>
-        <p:nvSpPr>
-          <p:cNvPr id="6" name="Test data note"/>
-          <p:cNvSpPr txBox="1"/>
-          <p:nvPr/>
-        </p:nvSpPr>
-        <p:spPr>
-          <a:xfrm>
-            <a:off x="822960" y="4023360"/>
-            <a:ext cx="3383280" cy="320040"/>
-          </a:xfrm>
-          <a:prstGeom prst="rect">
-            <a:avLst/>
-          </a:prstGeom>
-          <a:noFill/>
-          <a:ln/>
-        </p:spPr>
-        <p:txBody>
-          <a:bodyPr wrap="square" lIns="0" tIns="0" rIns="0" bIns="0" rtlCol="0" anchor="ctr"/>
-          <a:lstStyle/>
-          <a:p>
-            <a:pPr indent="0" marL="0">
-              <a:buNone/>
-            </a:pPr>
-            <a:r>
-              <a:rPr lang="en-US" sz="1200" i="1" dirty="0">
-                <a:solidFill>
-                  <a:schemeClr val="accent4"/>
-                </a:solidFill>
-              </a:rPr>
-              <a:t>Demo products and history are test data.</a:t>
-            </a:r>
-            <a:endParaRPr lang="en-US" sz="1200" dirty="0"/>
-          </a:p>
-        </p:txBody>
-      </p:sp>
-      <p:sp>
-        <p:nvSpPr>
-          <p:cNvPr id="7" name="Next card"/>
-          <p:cNvSpPr/>
-          <p:nvPr/>
-        </p:nvSpPr>
-        <p:spPr>
-          <a:xfrm>
-            <a:off x="4663440" y="1371600"/>
-            <a:ext cx="3931920" cy="3108960"/>
-          </a:xfrm>
-          <a:prstGeom prst="roundRect">
-            <a:avLst>
-              <a:gd name="adj" fmla="val 2353"/>
-            </a:avLst>
-          </a:prstGeom>
-          <a:solidFill>
-            <a:schemeClr val="tx1"/>
-          </a:solidFill>
-          <a:ln w="12700">
-            <a:solidFill>
-              <a:schemeClr val="tx1"/>
-            </a:solidFill>
-            <a:prstDash val="solid"/>
-          </a:ln>
-        </p:spPr>
-      </p:sp>
-      <p:sp>
-        <p:nvSpPr>
-          <p:cNvPr id="8" name="Next heading"/>
-          <p:cNvSpPr txBox="1"/>
-          <p:nvPr/>
-        </p:nvSpPr>
-        <p:spPr>
-          <a:xfrm>
-            <a:off x="4937760" y="1554480"/>
-            <a:ext cx="3383280" cy="274320"/>
-          </a:xfrm>
-          <a:prstGeom prst="rect">
-            <a:avLst/>
-          </a:prstGeom>
-          <a:noFill/>
-          <a:ln/>
-        </p:spPr>
-        <p:txBody>
-          <a:bodyPr wrap="square" lIns="0" tIns="0" rIns="0" bIns="0" rtlCol="0" anchor="ctr"/>
-          <a:lstStyle/>
-          <a:p>
-            <a:pPr indent="0" marL="0">
-              <a:buNone/>
-            </a:pPr>
-            <a:r>
-              <a:rPr lang="en-US" sz="1200" b="1" spc="200" kern="0" dirty="0">
-                <a:solidFill>
-                  <a:schemeClr val="accent6"/>
-                </a:solidFill>
-              </a:rPr>
-              <a:t>NEXT</a:t>
-            </a:r>
-            <a:endParaRPr lang="en-US" sz="1200" dirty="0"/>
-          </a:p>
-        </p:txBody>
-      </p:sp>
-      <p:sp>
-        <p:nvSpPr>
-          <p:cNvPr id="9" name="Next list"/>
-          <p:cNvSpPr txBox="1"/>
-          <p:nvPr/>
-        </p:nvSpPr>
-        <p:spPr>
-          <a:xfrm>
-            <a:off x="4937760" y="1920240"/>
-            <a:ext cx="3383280" cy="2286000"/>
-          </a:xfrm>
-          <a:prstGeom prst="rect">
-            <a:avLst/>
-          </a:prstGeom>
-          <a:noFill/>
-          <a:ln/>
-        </p:spPr>
-        <p:txBody>
-          <a:bodyPr wrap="square" lIns="0" tIns="0" rIns="0" bIns="0" rtlCol="0" anchor="t"/>
-          <a:lstStyle/>
-          <a:p>
-            <a:pPr marL="342900" indent="-342900">
-              <a:spcAft>
-                <a:spcPts val="800"/>
-              </a:spcAft>
-              <a:buSzPct val="100000"/>
-              <a:buChar char="•"/>
-            </a:pPr>
-            <a:r>
-              <a:rPr lang="en-US" sz="1400" dirty="0">
-                <a:solidFill>
-                  <a:schemeClr val="bg1"/>
-                </a:solidFill>
-              </a:rPr>
-              <a:t>Deploy on Cloud Run with a daily Scheduler job</a:t>
-            </a:r>
-            <a:endParaRPr lang="en-US" sz="1400" dirty="0"/>
-          </a:p>
-          <a:p>
-            <a:pPr marL="342900" indent="-342900">
-              <a:spcAft>
-                <a:spcPts val="800"/>
-              </a:spcAft>
-              <a:buSzPct val="100000"/>
-              <a:buChar char="•"/>
-            </a:pPr>
-            <a:r>
-              <a:rPr lang="en-US" sz="1400" dirty="0">
-                <a:solidFill>
-                  <a:schemeClr val="bg1"/>
-                </a:solidFill>
-              </a:rPr>
-              <a:t>Store real price history in Firestore</a:t>
-            </a:r>
-            <a:endParaRPr lang="en-US" sz="1400" dirty="0"/>
-          </a:p>
-          <a:p>
-            <a:pPr marL="342900" indent="-342900">
-              <a:spcAft>
-                <a:spcPts val="800"/>
-              </a:spcAft>
-              <a:buSzPct val="100000"/>
-              <a:buChar char="•"/>
-            </a:pPr>
-            <a:r>
-              <a:rPr lang="en-US" sz="1400" dirty="0">
-                <a:solidFill>
-                  <a:schemeClr val="bg1"/>
-                </a:solidFill>
-              </a:rPr>
-              <a:t>Send the digest by email</a:t>
-            </a:r>
-            <a:endParaRPr lang="en-US" sz="1400" dirty="0"/>
-          </a:p>
-          <a:p>
-            <a:pPr marL="342900" indent="-342900">
-              <a:spcAft>
-                <a:spcPts val="800"/>
-              </a:spcAft>
-              <a:buSzPct val="100000"/>
-              <a:buChar char="•"/>
-            </a:pPr>
-            <a:r>
-              <a:rPr lang="en-US" sz="1400" dirty="0">
-                <a:solidFill>
-                  <a:schemeClr val="bg1"/>
-                </a:solidFill>
-              </a:rPr>
-              <a:t>Retailer APIs, more categories</a:t>
-            </a:r>
-            <a:endParaRPr lang="en-US" sz="1400" dirty="0"/>
+              <a:t>Asked for 2 inputs, this one has 4. DealScout shows the extra cost against the cheapest model that already covers the need.</a:t>
+            </a:r>
+            <a:endParaRPr lang="en-US" sz="1600" dirty="0"/>
           </a:p>
         </p:txBody>
       </p:sp>
@@ -7165,53 +5923,82 @@
       </p:grpSpPr>
       <p:sp>
         <p:nvSpPr>
-          <p:cNvPr id="2" name="Closing line 1"/>
-          <p:cNvSpPr txBox="1"/>
-          <p:nvPr/>
-        </p:nvSpPr>
-        <p:spPr>
-          <a:xfrm>
-            <a:off x="640080" y="1371600"/>
-            <a:ext cx="7863840" cy="822960"/>
-          </a:xfrm>
-          <a:prstGeom prst="rect">
-            <a:avLst/>
-          </a:prstGeom>
-          <a:noFill/>
-          <a:ln/>
-        </p:spPr>
-        <p:txBody>
-          <a:bodyPr wrap="square" lIns="0" tIns="0" rIns="0" bIns="0" rtlCol="0" anchor="ctr"/>
+          <p:cNvPr id="2" name="Text 0"/>
+          <p:cNvSpPr/>
+          <p:nvPr>
+            <p:ph idx="100" type="title" hasCustomPrompt="1"/>
+          </p:nvPr>
+        </p:nvSpPr>
+        <p:spPr>
+          <a:xfrm>
+            <a:off x="548640" y="365760"/>
+            <a:ext cx="8046720" cy="868680"/>
+          </a:xfrm>
+          <a:prstGeom prst="rect">
+            <a:avLst/>
+          </a:prstGeom>
+          <a:noFill/>
+          <a:ln/>
+        </p:spPr>
+        <p:txBody>
+          <a:bodyPr wrap="square" lIns="0" tIns="0" rIns="0" bIns="0" rtlCol="0" anchor="t"/>
           <a:lstStyle/>
           <a:p>
             <a:pPr indent="0" marL="0">
               <a:buNone/>
             </a:pPr>
             <a:r>
-              <a:rPr lang="en-US" sz="4000" dirty="0">
-                <a:solidFill>
-                  <a:schemeClr val="accent5"/>
+              <a:rPr lang="en-US" sz="3000" b="1" dirty="0">
+                <a:solidFill>
+                  <a:schemeClr val="tx1"/>
                 </a:solidFill>
                 <a:latin typeface="Cambria" pitchFamily="34" charset="0"/>
                 <a:ea typeface="Cambria" pitchFamily="34" charset="-122"/>
                 <a:cs typeface="Cambria" pitchFamily="34" charset="-120"/>
               </a:rPr>
-              <a:t>Trackers watch products.</a:t>
-            </a:r>
-            <a:endParaRPr lang="en-US" sz="4000" dirty="0"/>
-          </a:p>
-        </p:txBody>
-      </p:sp>
-      <p:sp>
-        <p:nvSpPr>
-          <p:cNvPr id="3" name="Closing line 2"/>
+              <a:t>Built on Gemini and Google Cloud</a:t>
+            </a:r>
+            <a:endParaRPr lang="en-US" sz="3000" dirty="0"/>
+          </a:p>
+        </p:txBody>
+      </p:sp>
+      <p:sp>
+        <p:nvSpPr>
+          <p:cNvPr id="3" name="Box Cloud Scheduler"/>
+          <p:cNvSpPr/>
+          <p:nvPr/>
+        </p:nvSpPr>
+        <p:spPr>
+          <a:xfrm>
+            <a:off x="548640" y="1600200"/>
+            <a:ext cx="1463040" cy="1828800"/>
+          </a:xfrm>
+          <a:prstGeom prst="roundRect">
+            <a:avLst>
+              <a:gd name="adj" fmla="val 5000"/>
+            </a:avLst>
+          </a:prstGeom>
+          <a:solidFill>
+            <a:schemeClr val="bg2"/>
+          </a:solidFill>
+          <a:ln w="12700">
+            <a:solidFill>
+              <a:schemeClr val="bg2"/>
+            </a:solidFill>
+            <a:prstDash val="solid"/>
+          </a:ln>
+        </p:spPr>
+      </p:sp>
+      <p:sp>
+        <p:nvSpPr>
+          <p:cNvPr id="4" name="Box title Cloud Scheduler"/>
           <p:cNvSpPr txBox="1"/>
           <p:nvPr/>
         </p:nvSpPr>
         <p:spPr>
           <a:xfrm>
-            <a:off x="640080" y="2194560"/>
-            <a:ext cx="7863840" cy="822960"/>
+            <a:off x="685800" y="1783080"/>
+            <a:ext cx="1188720" cy="320040"/>
           </a:xfrm>
           <a:prstGeom prst="rect">
             <a:avLst/>
@@ -7227,53 +6014,842 @@
               <a:buNone/>
             </a:pPr>
             <a:r>
-              <a:rPr lang="en-US" sz="4000" b="1" dirty="0">
-                <a:solidFill>
-                  <a:schemeClr val="bg1"/>
-                </a:solidFill>
-                <a:latin typeface="Cambria" pitchFamily="34" charset="0"/>
-                <a:ea typeface="Cambria" pitchFamily="34" charset="-122"/>
-                <a:cs typeface="Cambria" pitchFamily="34" charset="-120"/>
-              </a:rPr>
-              <a:t>DealScout watches your need.</a:t>
-            </a:r>
-            <a:endParaRPr lang="en-US" sz="4000" dirty="0"/>
-          </a:p>
-        </p:txBody>
-      </p:sp>
-      <p:sp>
-        <p:nvSpPr>
-          <p:cNvPr id="4" name="Closing body"/>
+              <a:rPr lang="en-US" sz="1500" b="1" dirty="0">
+                <a:solidFill>
+                  <a:schemeClr val="tx1"/>
+                </a:solidFill>
+              </a:rPr>
+              <a:t>Cloud Scheduler</a:t>
+            </a:r>
+            <a:endParaRPr lang="en-US" sz="1500" dirty="0"/>
+          </a:p>
+        </p:txBody>
+      </p:sp>
+      <p:sp>
+        <p:nvSpPr>
+          <p:cNvPr id="5" name="Box body Cloud Scheduler"/>
           <p:cNvSpPr txBox="1"/>
           <p:nvPr/>
         </p:nvSpPr>
         <p:spPr>
           <a:xfrm>
-            <a:off x="640080" y="3291840"/>
-            <a:ext cx="7315200" cy="457200"/>
-          </a:xfrm>
-          <a:prstGeom prst="rect">
-            <a:avLst/>
-          </a:prstGeom>
-          <a:noFill/>
-          <a:ln/>
-        </p:spPr>
-        <p:txBody>
-          <a:bodyPr wrap="square" lIns="0" tIns="0" rIns="0" bIns="0" rtlCol="0" anchor="ctr"/>
+            <a:off x="685800" y="2194560"/>
+            <a:ext cx="1188720" cy="777240"/>
+          </a:xfrm>
+          <a:prstGeom prst="rect">
+            <a:avLst/>
+          </a:prstGeom>
+          <a:noFill/>
+          <a:ln/>
+        </p:spPr>
+        <p:txBody>
+          <a:bodyPr wrap="square" lIns="0" tIns="0" rIns="0" bIns="0" rtlCol="0" anchor="t"/>
           <a:lstStyle/>
           <a:p>
             <a:pPr indent="0" marL="0">
               <a:buNone/>
             </a:pPr>
             <a:r>
-              <a:rPr lang="en-US" sz="1600" dirty="0">
-                <a:solidFill>
-                  <a:schemeClr val="bg2"/>
-                </a:solidFill>
-              </a:rPr>
-              <a:t>Find the options you didn't know existed. Know whether the deal is real.</a:t>
+              <a:rPr lang="en-US" sz="1200" dirty="0">
+                <a:solidFill>
+                  <a:schemeClr val="tx2"/>
+                </a:solidFill>
+              </a:rPr>
+              <a:t>Triggers the daily run</a:t>
+            </a:r>
+            <a:endParaRPr lang="en-US" sz="1200" dirty="0"/>
+          </a:p>
+        </p:txBody>
+      </p:sp>
+      <p:sp>
+        <p:nvSpPr>
+          <p:cNvPr id="6" name="Box status Cloud Scheduler"/>
+          <p:cNvSpPr txBox="1"/>
+          <p:nvPr/>
+        </p:nvSpPr>
+        <p:spPr>
+          <a:xfrm>
+            <a:off x="685800" y="3063240"/>
+            <a:ext cx="1188720" cy="228600"/>
+          </a:xfrm>
+          <a:prstGeom prst="rect">
+            <a:avLst/>
+          </a:prstGeom>
+          <a:noFill/>
+          <a:ln/>
+        </p:spPr>
+        <p:txBody>
+          <a:bodyPr wrap="square" lIns="0" tIns="0" rIns="0" bIns="0" rtlCol="0" anchor="ctr"/>
+          <a:lstStyle/>
+          <a:p>
+            <a:pPr indent="0" marL="0">
+              <a:buNone/>
+            </a:pPr>
+            <a:r>
+              <a:rPr lang="en-US" sz="1100" b="1" spc="200" kern="0" dirty="0">
+                <a:solidFill>
+                  <a:schemeClr val="accent2"/>
+                </a:solidFill>
+              </a:rPr>
+              <a:t>NEXT</a:t>
+            </a:r>
+            <a:endParaRPr lang="en-US" sz="1100" dirty="0"/>
+          </a:p>
+        </p:txBody>
+      </p:sp>
+      <p:sp>
+        <p:nvSpPr>
+          <p:cNvPr id="7" name="Arrow 1"/>
+          <p:cNvSpPr txBox="1"/>
+          <p:nvPr/>
+        </p:nvSpPr>
+        <p:spPr>
+          <a:xfrm>
+            <a:off x="2011680" y="2240280"/>
+            <a:ext cx="164592" cy="365760"/>
+          </a:xfrm>
+          <a:prstGeom prst="rect">
+            <a:avLst/>
+          </a:prstGeom>
+          <a:noFill/>
+          <a:ln/>
+        </p:spPr>
+        <p:txBody>
+          <a:bodyPr wrap="square" lIns="0" tIns="0" rIns="0" bIns="0" rtlCol="0" anchor="ctr"/>
+          <a:lstStyle/>
+          <a:p>
+            <a:pPr algn="ctr" indent="0" marL="0">
+              <a:buNone/>
+            </a:pPr>
+            <a:r>
+              <a:rPr lang="en-US" sz="1800" dirty="0">
+                <a:solidFill>
+                  <a:schemeClr val="accent4"/>
+                </a:solidFill>
+              </a:rPr>
+              <a:t>→</a:t>
+            </a:r>
+            <a:endParaRPr lang="en-US" sz="1800" dirty="0"/>
+          </a:p>
+        </p:txBody>
+      </p:sp>
+      <p:sp>
+        <p:nvSpPr>
+          <p:cNvPr id="8" name="Box Cloud Run"/>
+          <p:cNvSpPr/>
+          <p:nvPr/>
+        </p:nvSpPr>
+        <p:spPr>
+          <a:xfrm>
+            <a:off x="2176272" y="1600200"/>
+            <a:ext cx="1463040" cy="1828800"/>
+          </a:xfrm>
+          <a:prstGeom prst="roundRect">
+            <a:avLst>
+              <a:gd name="adj" fmla="val 5000"/>
+            </a:avLst>
+          </a:prstGeom>
+          <a:solidFill>
+            <a:schemeClr val="bg2"/>
+          </a:solidFill>
+          <a:ln w="12700">
+            <a:solidFill>
+              <a:schemeClr val="bg2"/>
+            </a:solidFill>
+            <a:prstDash val="solid"/>
+          </a:ln>
+        </p:spPr>
+      </p:sp>
+      <p:sp>
+        <p:nvSpPr>
+          <p:cNvPr id="9" name="Box title Cloud Run"/>
+          <p:cNvSpPr txBox="1"/>
+          <p:nvPr/>
+        </p:nvSpPr>
+        <p:spPr>
+          <a:xfrm>
+            <a:off x="2313432" y="1783080"/>
+            <a:ext cx="1188720" cy="320040"/>
+          </a:xfrm>
+          <a:prstGeom prst="rect">
+            <a:avLst/>
+          </a:prstGeom>
+          <a:noFill/>
+          <a:ln/>
+        </p:spPr>
+        <p:txBody>
+          <a:bodyPr wrap="square" lIns="0" tIns="0" rIns="0" bIns="0" rtlCol="0" anchor="ctr"/>
+          <a:lstStyle/>
+          <a:p>
+            <a:pPr indent="0" marL="0">
+              <a:buNone/>
+            </a:pPr>
+            <a:r>
+              <a:rPr lang="en-US" sz="1500" b="1" dirty="0">
+                <a:solidFill>
+                  <a:schemeClr val="tx1"/>
+                </a:solidFill>
+              </a:rPr>
+              <a:t>Cloud Run</a:t>
+            </a:r>
+            <a:endParaRPr lang="en-US" sz="1500" dirty="0"/>
+          </a:p>
+        </p:txBody>
+      </p:sp>
+      <p:sp>
+        <p:nvSpPr>
+          <p:cNvPr id="10" name="Box body Cloud Run"/>
+          <p:cNvSpPr txBox="1"/>
+          <p:nvPr/>
+        </p:nvSpPr>
+        <p:spPr>
+          <a:xfrm>
+            <a:off x="2313432" y="2194560"/>
+            <a:ext cx="1188720" cy="777240"/>
+          </a:xfrm>
+          <a:prstGeom prst="rect">
+            <a:avLst/>
+          </a:prstGeom>
+          <a:noFill/>
+          <a:ln/>
+        </p:spPr>
+        <p:txBody>
+          <a:bodyPr wrap="square" lIns="0" tIns="0" rIns="0" bIns="0" rtlCol="0" anchor="t"/>
+          <a:lstStyle/>
+          <a:p>
+            <a:pPr indent="0" marL="0">
+              <a:buNone/>
+            </a:pPr>
+            <a:r>
+              <a:rPr lang="en-US" sz="1200" dirty="0">
+                <a:solidFill>
+                  <a:schemeClr val="tx2"/>
+                </a:solidFill>
+              </a:rPr>
+              <a:t>Runs the scout service</a:t>
+            </a:r>
+            <a:endParaRPr lang="en-US" sz="1200" dirty="0"/>
+          </a:p>
+        </p:txBody>
+      </p:sp>
+      <p:sp>
+        <p:nvSpPr>
+          <p:cNvPr id="11" name="Box status Cloud Run"/>
+          <p:cNvSpPr txBox="1"/>
+          <p:nvPr/>
+        </p:nvSpPr>
+        <p:spPr>
+          <a:xfrm>
+            <a:off x="2313432" y="3063240"/>
+            <a:ext cx="1188720" cy="228600"/>
+          </a:xfrm>
+          <a:prstGeom prst="rect">
+            <a:avLst/>
+          </a:prstGeom>
+          <a:noFill/>
+          <a:ln/>
+        </p:spPr>
+        <p:txBody>
+          <a:bodyPr wrap="square" lIns="0" tIns="0" rIns="0" bIns="0" rtlCol="0" anchor="ctr"/>
+          <a:lstStyle/>
+          <a:p>
+            <a:pPr indent="0" marL="0">
+              <a:buNone/>
+            </a:pPr>
+            <a:r>
+              <a:rPr lang="en-US" sz="1100" b="1" spc="200" kern="0" dirty="0">
+                <a:solidFill>
+                  <a:schemeClr val="accent2"/>
+                </a:solidFill>
+              </a:rPr>
+              <a:t>NEXT</a:t>
+            </a:r>
+            <a:endParaRPr lang="en-US" sz="1100" dirty="0"/>
+          </a:p>
+        </p:txBody>
+      </p:sp>
+      <p:sp>
+        <p:nvSpPr>
+          <p:cNvPr id="12" name="Arrow 2"/>
+          <p:cNvSpPr txBox="1"/>
+          <p:nvPr/>
+        </p:nvSpPr>
+        <p:spPr>
+          <a:xfrm>
+            <a:off x="3639312" y="2240280"/>
+            <a:ext cx="164592" cy="365760"/>
+          </a:xfrm>
+          <a:prstGeom prst="rect">
+            <a:avLst/>
+          </a:prstGeom>
+          <a:noFill/>
+          <a:ln/>
+        </p:spPr>
+        <p:txBody>
+          <a:bodyPr wrap="square" lIns="0" tIns="0" rIns="0" bIns="0" rtlCol="0" anchor="ctr"/>
+          <a:lstStyle/>
+          <a:p>
+            <a:pPr algn="ctr" indent="0" marL="0">
+              <a:buNone/>
+            </a:pPr>
+            <a:r>
+              <a:rPr lang="en-US" sz="1800" dirty="0">
+                <a:solidFill>
+                  <a:schemeClr val="accent4"/>
+                </a:solidFill>
+              </a:rPr>
+              <a:t>→</a:t>
+            </a:r>
+            <a:endParaRPr lang="en-US" sz="1800" dirty="0"/>
+          </a:p>
+        </p:txBody>
+      </p:sp>
+      <p:sp>
+        <p:nvSpPr>
+          <p:cNvPr id="13" name="Box Gemini"/>
+          <p:cNvSpPr/>
+          <p:nvPr/>
+        </p:nvSpPr>
+        <p:spPr>
+          <a:xfrm>
+            <a:off x="3803904" y="1600200"/>
+            <a:ext cx="1463040" cy="1828800"/>
+          </a:xfrm>
+          <a:prstGeom prst="roundRect">
+            <a:avLst>
+              <a:gd name="adj" fmla="val 5000"/>
+            </a:avLst>
+          </a:prstGeom>
+          <a:solidFill>
+            <a:schemeClr val="accent1"/>
+          </a:solidFill>
+          <a:ln w="12700">
+            <a:solidFill>
+              <a:schemeClr val="accent1"/>
+            </a:solidFill>
+            <a:prstDash val="solid"/>
+          </a:ln>
+        </p:spPr>
+      </p:sp>
+      <p:sp>
+        <p:nvSpPr>
+          <p:cNvPr id="14" name="Box title Gemini"/>
+          <p:cNvSpPr txBox="1"/>
+          <p:nvPr/>
+        </p:nvSpPr>
+        <p:spPr>
+          <a:xfrm>
+            <a:off x="3941064" y="1783080"/>
+            <a:ext cx="1188720" cy="320040"/>
+          </a:xfrm>
+          <a:prstGeom prst="rect">
+            <a:avLst/>
+          </a:prstGeom>
+          <a:noFill/>
+          <a:ln/>
+        </p:spPr>
+        <p:txBody>
+          <a:bodyPr wrap="square" lIns="0" tIns="0" rIns="0" bIns="0" rtlCol="0" anchor="ctr"/>
+          <a:lstStyle/>
+          <a:p>
+            <a:pPr indent="0" marL="0">
+              <a:buNone/>
+            </a:pPr>
+            <a:r>
+              <a:rPr lang="en-US" sz="1500" b="1" dirty="0">
+                <a:solidFill>
+                  <a:schemeClr val="bg1"/>
+                </a:solidFill>
+              </a:rPr>
+              <a:t>Gemini</a:t>
+            </a:r>
+            <a:endParaRPr lang="en-US" sz="1500" dirty="0"/>
+          </a:p>
+        </p:txBody>
+      </p:sp>
+      <p:sp>
+        <p:nvSpPr>
+          <p:cNvPr id="15" name="Box body Gemini"/>
+          <p:cNvSpPr txBox="1"/>
+          <p:nvPr/>
+        </p:nvSpPr>
+        <p:spPr>
+          <a:xfrm>
+            <a:off x="3941064" y="2194560"/>
+            <a:ext cx="1188720" cy="777240"/>
+          </a:xfrm>
+          <a:prstGeom prst="rect">
+            <a:avLst/>
+          </a:prstGeom>
+          <a:noFill/>
+          <a:ln/>
+        </p:spPr>
+        <p:txBody>
+          <a:bodyPr wrap="square" lIns="0" tIns="0" rIns="0" bIns="0" rtlCol="0" anchor="t"/>
+          <a:lstStyle/>
+          <a:p>
+            <a:pPr indent="0" marL="0">
+              <a:buNone/>
+            </a:pPr>
+            <a:r>
+              <a:rPr lang="en-US" sz="1200" dirty="0">
+                <a:solidFill>
+                  <a:schemeClr val="bg1"/>
+                </a:solidFill>
+              </a:rPr>
+              <a:t>Structured output + Google Search grounding</a:t>
+            </a:r>
+            <a:endParaRPr lang="en-US" sz="1200" dirty="0"/>
+          </a:p>
+        </p:txBody>
+      </p:sp>
+      <p:sp>
+        <p:nvSpPr>
+          <p:cNvPr id="16" name="Box status Gemini"/>
+          <p:cNvSpPr txBox="1"/>
+          <p:nvPr/>
+        </p:nvSpPr>
+        <p:spPr>
+          <a:xfrm>
+            <a:off x="3941064" y="3063240"/>
+            <a:ext cx="1188720" cy="228600"/>
+          </a:xfrm>
+          <a:prstGeom prst="rect">
+            <a:avLst/>
+          </a:prstGeom>
+          <a:noFill/>
+          <a:ln/>
+        </p:spPr>
+        <p:txBody>
+          <a:bodyPr wrap="square" lIns="0" tIns="0" rIns="0" bIns="0" rtlCol="0" anchor="ctr"/>
+          <a:lstStyle/>
+          <a:p>
+            <a:pPr indent="0" marL="0">
+              <a:buNone/>
+            </a:pPr>
+            <a:r>
+              <a:rPr lang="en-US" sz="1100" b="1" spc="200" kern="0" dirty="0">
+                <a:solidFill>
+                  <a:schemeClr val="accent6"/>
+                </a:solidFill>
+              </a:rPr>
+              <a:t>BUILT</a:t>
+            </a:r>
+            <a:endParaRPr lang="en-US" sz="1100" dirty="0"/>
+          </a:p>
+        </p:txBody>
+      </p:sp>
+      <p:sp>
+        <p:nvSpPr>
+          <p:cNvPr id="17" name="Arrow 3"/>
+          <p:cNvSpPr txBox="1"/>
+          <p:nvPr/>
+        </p:nvSpPr>
+        <p:spPr>
+          <a:xfrm>
+            <a:off x="5266944" y="2240280"/>
+            <a:ext cx="164592" cy="365760"/>
+          </a:xfrm>
+          <a:prstGeom prst="rect">
+            <a:avLst/>
+          </a:prstGeom>
+          <a:noFill/>
+          <a:ln/>
+        </p:spPr>
+        <p:txBody>
+          <a:bodyPr wrap="square" lIns="0" tIns="0" rIns="0" bIns="0" rtlCol="0" anchor="ctr"/>
+          <a:lstStyle/>
+          <a:p>
+            <a:pPr algn="ctr" indent="0" marL="0">
+              <a:buNone/>
+            </a:pPr>
+            <a:r>
+              <a:rPr lang="en-US" sz="1800" dirty="0">
+                <a:solidFill>
+                  <a:schemeClr val="accent4"/>
+                </a:solidFill>
+              </a:rPr>
+              <a:t>→</a:t>
+            </a:r>
+            <a:endParaRPr lang="en-US" sz="1800" dirty="0"/>
+          </a:p>
+        </p:txBody>
+      </p:sp>
+      <p:sp>
+        <p:nvSpPr>
+          <p:cNvPr id="18" name="Box Firestore"/>
+          <p:cNvSpPr/>
+          <p:nvPr/>
+        </p:nvSpPr>
+        <p:spPr>
+          <a:xfrm>
+            <a:off x="5431536" y="1600200"/>
+            <a:ext cx="1463040" cy="1828800"/>
+          </a:xfrm>
+          <a:prstGeom prst="roundRect">
+            <a:avLst>
+              <a:gd name="adj" fmla="val 5000"/>
+            </a:avLst>
+          </a:prstGeom>
+          <a:solidFill>
+            <a:schemeClr val="bg2"/>
+          </a:solidFill>
+          <a:ln w="12700">
+            <a:solidFill>
+              <a:schemeClr val="bg2"/>
+            </a:solidFill>
+            <a:prstDash val="solid"/>
+          </a:ln>
+        </p:spPr>
+      </p:sp>
+      <p:sp>
+        <p:nvSpPr>
+          <p:cNvPr id="19" name="Box title Firestore"/>
+          <p:cNvSpPr txBox="1"/>
+          <p:nvPr/>
+        </p:nvSpPr>
+        <p:spPr>
+          <a:xfrm>
+            <a:off x="5568696" y="1783080"/>
+            <a:ext cx="1188720" cy="320040"/>
+          </a:xfrm>
+          <a:prstGeom prst="rect">
+            <a:avLst/>
+          </a:prstGeom>
+          <a:noFill/>
+          <a:ln/>
+        </p:spPr>
+        <p:txBody>
+          <a:bodyPr wrap="square" lIns="0" tIns="0" rIns="0" bIns="0" rtlCol="0" anchor="ctr"/>
+          <a:lstStyle/>
+          <a:p>
+            <a:pPr indent="0" marL="0">
+              <a:buNone/>
+            </a:pPr>
+            <a:r>
+              <a:rPr lang="en-US" sz="1500" b="1" dirty="0">
+                <a:solidFill>
+                  <a:schemeClr val="tx1"/>
+                </a:solidFill>
+              </a:rPr>
+              <a:t>Firestore</a:t>
+            </a:r>
+            <a:endParaRPr lang="en-US" sz="1500" dirty="0"/>
+          </a:p>
+        </p:txBody>
+      </p:sp>
+      <p:sp>
+        <p:nvSpPr>
+          <p:cNvPr id="20" name="Box body Firestore"/>
+          <p:cNvSpPr txBox="1"/>
+          <p:nvPr/>
+        </p:nvSpPr>
+        <p:spPr>
+          <a:xfrm>
+            <a:off x="5568696" y="2194560"/>
+            <a:ext cx="1188720" cy="777240"/>
+          </a:xfrm>
+          <a:prstGeom prst="rect">
+            <a:avLst/>
+          </a:prstGeom>
+          <a:noFill/>
+          <a:ln/>
+        </p:spPr>
+        <p:txBody>
+          <a:bodyPr wrap="square" lIns="0" tIns="0" rIns="0" bIns="0" rtlCol="0" anchor="t"/>
+          <a:lstStyle/>
+          <a:p>
+            <a:pPr indent="0" marL="0">
+              <a:buNone/>
+            </a:pPr>
+            <a:r>
+              <a:rPr lang="en-US" sz="1200" dirty="0">
+                <a:solidFill>
+                  <a:schemeClr val="tx2"/>
+                </a:solidFill>
+              </a:rPr>
+              <a:t>Daily price history</a:t>
+            </a:r>
+            <a:endParaRPr lang="en-US" sz="1200" dirty="0"/>
+          </a:p>
+        </p:txBody>
+      </p:sp>
+      <p:sp>
+        <p:nvSpPr>
+          <p:cNvPr id="21" name="Box status Firestore"/>
+          <p:cNvSpPr txBox="1"/>
+          <p:nvPr/>
+        </p:nvSpPr>
+        <p:spPr>
+          <a:xfrm>
+            <a:off x="5568696" y="3063240"/>
+            <a:ext cx="1188720" cy="228600"/>
+          </a:xfrm>
+          <a:prstGeom prst="rect">
+            <a:avLst/>
+          </a:prstGeom>
+          <a:noFill/>
+          <a:ln/>
+        </p:spPr>
+        <p:txBody>
+          <a:bodyPr wrap="square" lIns="0" tIns="0" rIns="0" bIns="0" rtlCol="0" anchor="ctr"/>
+          <a:lstStyle/>
+          <a:p>
+            <a:pPr indent="0" marL="0">
+              <a:buNone/>
+            </a:pPr>
+            <a:r>
+              <a:rPr lang="en-US" sz="1100" b="1" spc="200" kern="0" dirty="0">
+                <a:solidFill>
+                  <a:schemeClr val="accent2"/>
+                </a:solidFill>
+              </a:rPr>
+              <a:t>NEXT</a:t>
+            </a:r>
+            <a:endParaRPr lang="en-US" sz="1100" dirty="0"/>
+          </a:p>
+        </p:txBody>
+      </p:sp>
+      <p:sp>
+        <p:nvSpPr>
+          <p:cNvPr id="22" name="Arrow 4"/>
+          <p:cNvSpPr txBox="1"/>
+          <p:nvPr/>
+        </p:nvSpPr>
+        <p:spPr>
+          <a:xfrm>
+            <a:off x="6894576" y="2240280"/>
+            <a:ext cx="164592" cy="365760"/>
+          </a:xfrm>
+          <a:prstGeom prst="rect">
+            <a:avLst/>
+          </a:prstGeom>
+          <a:noFill/>
+          <a:ln/>
+        </p:spPr>
+        <p:txBody>
+          <a:bodyPr wrap="square" lIns="0" tIns="0" rIns="0" bIns="0" rtlCol="0" anchor="ctr"/>
+          <a:lstStyle/>
+          <a:p>
+            <a:pPr algn="ctr" indent="0" marL="0">
+              <a:buNone/>
+            </a:pPr>
+            <a:r>
+              <a:rPr lang="en-US" sz="1800" dirty="0">
+                <a:solidFill>
+                  <a:schemeClr val="accent4"/>
+                </a:solidFill>
+              </a:rPr>
+              <a:t>→</a:t>
+            </a:r>
+            <a:endParaRPr lang="en-US" sz="1800" dirty="0"/>
+          </a:p>
+        </p:txBody>
+      </p:sp>
+      <p:sp>
+        <p:nvSpPr>
+          <p:cNvPr id="23" name="Box Email"/>
+          <p:cNvSpPr/>
+          <p:nvPr/>
+        </p:nvSpPr>
+        <p:spPr>
+          <a:xfrm>
+            <a:off x="7059168" y="1600200"/>
+            <a:ext cx="1463040" cy="1828800"/>
+          </a:xfrm>
+          <a:prstGeom prst="roundRect">
+            <a:avLst>
+              <a:gd name="adj" fmla="val 5000"/>
+            </a:avLst>
+          </a:prstGeom>
+          <a:solidFill>
+            <a:schemeClr val="bg2"/>
+          </a:solidFill>
+          <a:ln w="12700">
+            <a:solidFill>
+              <a:schemeClr val="bg2"/>
+            </a:solidFill>
+            <a:prstDash val="solid"/>
+          </a:ln>
+        </p:spPr>
+      </p:sp>
+      <p:sp>
+        <p:nvSpPr>
+          <p:cNvPr id="24" name="Box title Email"/>
+          <p:cNvSpPr txBox="1"/>
+          <p:nvPr/>
+        </p:nvSpPr>
+        <p:spPr>
+          <a:xfrm>
+            <a:off x="7196328" y="1783080"/>
+            <a:ext cx="1188720" cy="320040"/>
+          </a:xfrm>
+          <a:prstGeom prst="rect">
+            <a:avLst/>
+          </a:prstGeom>
+          <a:noFill/>
+          <a:ln/>
+        </p:spPr>
+        <p:txBody>
+          <a:bodyPr wrap="square" lIns="0" tIns="0" rIns="0" bIns="0" rtlCol="0" anchor="ctr"/>
+          <a:lstStyle/>
+          <a:p>
+            <a:pPr indent="0" marL="0">
+              <a:buNone/>
+            </a:pPr>
+            <a:r>
+              <a:rPr lang="en-US" sz="1500" b="1" dirty="0">
+                <a:solidFill>
+                  <a:schemeClr val="tx1"/>
+                </a:solidFill>
+              </a:rPr>
+              <a:t>Email</a:t>
+            </a:r>
+            <a:endParaRPr lang="en-US" sz="1500" dirty="0"/>
+          </a:p>
+        </p:txBody>
+      </p:sp>
+      <p:sp>
+        <p:nvSpPr>
+          <p:cNvPr id="25" name="Box body Email"/>
+          <p:cNvSpPr txBox="1"/>
+          <p:nvPr/>
+        </p:nvSpPr>
+        <p:spPr>
+          <a:xfrm>
+            <a:off x="7196328" y="2194560"/>
+            <a:ext cx="1188720" cy="777240"/>
+          </a:xfrm>
+          <a:prstGeom prst="rect">
+            <a:avLst/>
+          </a:prstGeom>
+          <a:noFill/>
+          <a:ln/>
+        </p:spPr>
+        <p:txBody>
+          <a:bodyPr wrap="square" lIns="0" tIns="0" rIns="0" bIns="0" rtlCol="0" anchor="t"/>
+          <a:lstStyle/>
+          <a:p>
+            <a:pPr indent="0" marL="0">
+              <a:buNone/>
+            </a:pPr>
+            <a:r>
+              <a:rPr lang="en-US" sz="1200" dirty="0">
+                <a:solidFill>
+                  <a:schemeClr val="tx2"/>
+                </a:solidFill>
+              </a:rPr>
+              <a:t>Firebase email digest</a:t>
+            </a:r>
+            <a:endParaRPr lang="en-US" sz="1200" dirty="0"/>
+          </a:p>
+        </p:txBody>
+      </p:sp>
+      <p:sp>
+        <p:nvSpPr>
+          <p:cNvPr id="26" name="Box status Email"/>
+          <p:cNvSpPr txBox="1"/>
+          <p:nvPr/>
+        </p:nvSpPr>
+        <p:spPr>
+          <a:xfrm>
+            <a:off x="7196328" y="3063240"/>
+            <a:ext cx="1188720" cy="228600"/>
+          </a:xfrm>
+          <a:prstGeom prst="rect">
+            <a:avLst/>
+          </a:prstGeom>
+          <a:noFill/>
+          <a:ln/>
+        </p:spPr>
+        <p:txBody>
+          <a:bodyPr wrap="square" lIns="0" tIns="0" rIns="0" bIns="0" rtlCol="0" anchor="ctr"/>
+          <a:lstStyle/>
+          <a:p>
+            <a:pPr indent="0" marL="0">
+              <a:buNone/>
+            </a:pPr>
+            <a:r>
+              <a:rPr lang="en-US" sz="1100" b="1" spc="200" kern="0" dirty="0">
+                <a:solidFill>
+                  <a:schemeClr val="accent2"/>
+                </a:solidFill>
+              </a:rPr>
+              <a:t>NEXT</a:t>
+            </a:r>
+            <a:endParaRPr lang="en-US" sz="1100" dirty="0"/>
+          </a:p>
+        </p:txBody>
+      </p:sp>
+      <p:sp>
+        <p:nvSpPr>
+          <p:cNvPr id="27" name="Interface note"/>
+          <p:cNvSpPr txBox="1"/>
+          <p:nvPr/>
+        </p:nvSpPr>
+        <p:spPr>
+          <a:xfrm>
+            <a:off x="548640" y="3794760"/>
+            <a:ext cx="8046720" cy="365760"/>
+          </a:xfrm>
+          <a:prstGeom prst="rect">
+            <a:avLst/>
+          </a:prstGeom>
+          <a:noFill/>
+          <a:ln/>
+        </p:spPr>
+        <p:txBody>
+          <a:bodyPr wrap="square" lIns="0" tIns="0" rIns="0" bIns="0" rtlCol="0" anchor="ctr"/>
+          <a:lstStyle/>
+          <a:p>
+            <a:pPr indent="0" marL="0">
+              <a:buNone/>
+            </a:pPr>
+            <a:r>
+              <a:rPr lang="en-US" sz="1600" b="1" dirty="0">
+                <a:solidFill>
+                  <a:schemeClr val="tx1"/>
+                </a:solidFill>
+              </a:rPr>
+              <a:t>One PriceSource interface: Google Search today, retailer APIs as we scale.</a:t>
             </a:r>
             <a:endParaRPr lang="en-US" sz="1600" dirty="0"/>
+          </a:p>
+        </p:txBody>
+      </p:sp>
+      <p:sp>
+        <p:nvSpPr>
+          <p:cNvPr id="28" name="Prototype note"/>
+          <p:cNvSpPr txBox="1"/>
+          <p:nvPr/>
+        </p:nvSpPr>
+        <p:spPr>
+          <a:xfrm>
+            <a:off x="548640" y="4206240"/>
+            <a:ext cx="8046720" cy="320040"/>
+          </a:xfrm>
+          <a:prstGeom prst="rect">
+            <a:avLst/>
+          </a:prstGeom>
+          <a:noFill/>
+          <a:ln/>
+        </p:spPr>
+        <p:txBody>
+          <a:bodyPr wrap="square" lIns="0" tIns="0" rIns="0" bIns="0" rtlCol="0" anchor="ctr"/>
+          <a:lstStyle/>
+          <a:p>
+            <a:pPr indent="0" marL="0">
+              <a:buNone/>
+            </a:pPr>
+            <a:r>
+              <a:rPr lang="en-US" sz="1300" dirty="0">
+                <a:solidFill>
+                  <a:schemeClr val="accent4"/>
+                </a:solidFill>
+              </a:rPr>
+              <a:t>In the prototype, prices are saved to a local file and the digest is written as HTML.</a:t>
+            </a:r>
+            <a:endParaRPr lang="en-US" sz="1300" dirty="0"/>
           </a:p>
         </p:txBody>
       </p:sp>
@@ -7307,7 +6883,7 @@
             <a:lvl1pPr>
               <a:defRPr sz="1000">
                 <a:solidFill>
-                  <a:schemeClr val="accent5"/>
+                  <a:schemeClr val="accent4"/>
                 </a:solidFill>
               </a:defRPr>
             </a:lvl1pPr>
@@ -7317,6 +6893,485 @@
             <a:fld id="{F7021451-1387-4CA6-816F-3879F97B5CBC}" type="slidenum">
               <a:rPr b="0" lang="en-US"/>
               <a:t>8</a:t>
+            </a:fld>
+            <a:endParaRPr lang="en-US"/>
+          </a:p>
+        </p:txBody>
+      </p:sp>
+    </p:spTree>
+  </p:cSld>
+  <p:clrMapOvr>
+    <a:masterClrMapping/>
+  </p:clrMapOvr>
+</p:sld>
+</file>
+
+<file path=ppt/slides/slide9.xml><?xml version="1.0" encoding="utf-8"?>
+<p:sld xmlns:a="http://schemas.openxmlformats.org/drawingml/2006/main" xmlns:r="http://schemas.openxmlformats.org/officeDocument/2006/relationships" xmlns:p="http://schemas.openxmlformats.org/presentationml/2006/main">
+  <p:cSld name="Slide 9">
+    <p:spTree>
+      <p:nvGrpSpPr>
+        <p:cNvPr id="1" name=""/>
+        <p:cNvGrpSpPr/>
+        <p:nvPr/>
+      </p:nvGrpSpPr>
+      <p:grpSpPr>
+        <a:xfrm>
+          <a:off x="0" y="0"/>
+          <a:ext cx="0" cy="0"/>
+          <a:chOff x="0" y="0"/>
+          <a:chExt cx="0" cy="0"/>
+        </a:xfrm>
+      </p:grpSpPr>
+      <p:sp>
+        <p:nvSpPr>
+          <p:cNvPr id="2" name="Text 0"/>
+          <p:cNvSpPr/>
+          <p:nvPr>
+            <p:ph idx="100" type="title" hasCustomPrompt="1"/>
+          </p:nvPr>
+        </p:nvSpPr>
+        <p:spPr>
+          <a:xfrm>
+            <a:off x="548640" y="365760"/>
+            <a:ext cx="8046720" cy="868680"/>
+          </a:xfrm>
+          <a:prstGeom prst="rect">
+            <a:avLst/>
+          </a:prstGeom>
+          <a:noFill/>
+          <a:ln/>
+        </p:spPr>
+        <p:txBody>
+          <a:bodyPr wrap="square" lIns="0" tIns="0" rIns="0" bIns="0" rtlCol="0" anchor="t"/>
+          <a:lstStyle/>
+          <a:p>
+            <a:pPr indent="0" marL="0">
+              <a:buNone/>
+            </a:pPr>
+            <a:r>
+              <a:rPr lang="en-US" sz="3000" b="1" dirty="0">
+                <a:solidFill>
+                  <a:schemeClr val="tx1"/>
+                </a:solidFill>
+                <a:latin typeface="Cambria" pitchFamily="34" charset="0"/>
+                <a:ea typeface="Cambria" pitchFamily="34" charset="-122"/>
+                <a:cs typeface="Cambria" pitchFamily="34" charset="-120"/>
+              </a:rPr>
+              <a:t>Working today, and what comes next</a:t>
+            </a:r>
+            <a:endParaRPr lang="en-US" sz="3000" dirty="0"/>
+          </a:p>
+        </p:txBody>
+      </p:sp>
+      <p:sp>
+        <p:nvSpPr>
+          <p:cNvPr id="3" name="Today card"/>
+          <p:cNvSpPr/>
+          <p:nvPr/>
+        </p:nvSpPr>
+        <p:spPr>
+          <a:xfrm>
+            <a:off x="548640" y="1371600"/>
+            <a:ext cx="3931920" cy="3108960"/>
+          </a:xfrm>
+          <a:prstGeom prst="roundRect">
+            <a:avLst>
+              <a:gd name="adj" fmla="val 2353"/>
+            </a:avLst>
+          </a:prstGeom>
+          <a:solidFill>
+            <a:schemeClr val="bg2"/>
+          </a:solidFill>
+          <a:ln w="12700">
+            <a:solidFill>
+              <a:schemeClr val="bg2"/>
+            </a:solidFill>
+            <a:prstDash val="solid"/>
+          </a:ln>
+        </p:spPr>
+      </p:sp>
+      <p:sp>
+        <p:nvSpPr>
+          <p:cNvPr id="4" name="Today heading"/>
+          <p:cNvSpPr txBox="1"/>
+          <p:nvPr/>
+        </p:nvSpPr>
+        <p:spPr>
+          <a:xfrm>
+            <a:off x="822960" y="1554480"/>
+            <a:ext cx="3383280" cy="274320"/>
+          </a:xfrm>
+          <a:prstGeom prst="rect">
+            <a:avLst/>
+          </a:prstGeom>
+          <a:noFill/>
+          <a:ln/>
+        </p:spPr>
+        <p:txBody>
+          <a:bodyPr wrap="square" lIns="0" tIns="0" rIns="0" bIns="0" rtlCol="0" anchor="ctr"/>
+          <a:lstStyle/>
+          <a:p>
+            <a:pPr indent="0" marL="0">
+              <a:buNone/>
+            </a:pPr>
+            <a:r>
+              <a:rPr lang="en-US" sz="1200" b="1" spc="200" kern="0" dirty="0">
+                <a:solidFill>
+                  <a:schemeClr val="accent1"/>
+                </a:solidFill>
+              </a:rPr>
+              <a:t>WORKING TODAY</a:t>
+            </a:r>
+            <a:endParaRPr lang="en-US" sz="1200" dirty="0"/>
+          </a:p>
+        </p:txBody>
+      </p:sp>
+      <p:sp>
+        <p:nvSpPr>
+          <p:cNvPr id="5" name="Today list"/>
+          <p:cNvSpPr txBox="1"/>
+          <p:nvPr/>
+        </p:nvSpPr>
+        <p:spPr>
+          <a:xfrm>
+            <a:off x="822960" y="1920240"/>
+            <a:ext cx="3383280" cy="2011680"/>
+          </a:xfrm>
+          <a:prstGeom prst="rect">
+            <a:avLst/>
+          </a:prstGeom>
+          <a:noFill/>
+          <a:ln/>
+        </p:spPr>
+        <p:txBody>
+          <a:bodyPr wrap="square" lIns="0" tIns="0" rIns="0" bIns="0" rtlCol="0" anchor="t"/>
+          <a:lstStyle/>
+          <a:p>
+            <a:pPr marL="342900" indent="-342900">
+              <a:spcAft>
+                <a:spcPts val="800"/>
+              </a:spcAft>
+              <a:buSzPct val="100000"/>
+              <a:buChar char="•"/>
+            </a:pPr>
+            <a:r>
+              <a:rPr lang="en-US" sz="1400" dirty="0">
+                <a:solidFill>
+                  <a:schemeClr val="tx1"/>
+                </a:solidFill>
+              </a:rPr>
+              <a:t>Fake-discount and verdict logic, 15 tests</a:t>
+            </a:r>
+            <a:endParaRPr lang="en-US" sz="1400" dirty="0"/>
+          </a:p>
+          <a:p>
+            <a:pPr marL="342900" indent="-342900">
+              <a:spcAft>
+                <a:spcPts val="800"/>
+              </a:spcAft>
+              <a:buSzPct val="100000"/>
+              <a:buChar char="•"/>
+            </a:pPr>
+            <a:r>
+              <a:rPr lang="en-US" sz="1400" dirty="0">
+                <a:solidFill>
+                  <a:schemeClr val="tx1"/>
+                </a:solidFill>
+              </a:rPr>
+              <a:t>Gemini watch spec from plain English</a:t>
+            </a:r>
+            <a:endParaRPr lang="en-US" sz="1400" dirty="0"/>
+          </a:p>
+          <a:p>
+            <a:pPr marL="342900" indent="-342900">
+              <a:spcAft>
+                <a:spcPts val="800"/>
+              </a:spcAft>
+              <a:buSzPct val="100000"/>
+              <a:buChar char="•"/>
+            </a:pPr>
+            <a:r>
+              <a:rPr lang="en-US" sz="1400" dirty="0">
+                <a:solidFill>
+                  <a:schemeClr val="tx1"/>
+                </a:solidFill>
+              </a:rPr>
+              <a:t>Live agent trace and need-aware fit check</a:t>
+            </a:r>
+            <a:endParaRPr lang="en-US" sz="1400" dirty="0"/>
+          </a:p>
+          <a:p>
+            <a:pPr marL="342900" indent="-342900">
+              <a:spcAft>
+                <a:spcPts val="800"/>
+              </a:spcAft>
+              <a:buSzPct val="100000"/>
+              <a:buChar char="•"/>
+            </a:pPr>
+            <a:r>
+              <a:rPr lang="en-US" sz="1400" dirty="0">
+                <a:solidFill>
+                  <a:schemeClr val="tx1"/>
+                </a:solidFill>
+              </a:rPr>
+              <a:t>Google Search discovery (not yet run live)</a:t>
+            </a:r>
+            <a:endParaRPr lang="en-US" sz="1400" dirty="0"/>
+          </a:p>
+          <a:p>
+            <a:pPr marL="342900" indent="-342900">
+              <a:spcAft>
+                <a:spcPts val="800"/>
+              </a:spcAft>
+              <a:buSzPct val="100000"/>
+              <a:buChar char="•"/>
+            </a:pPr>
+            <a:r>
+              <a:rPr lang="en-US" sz="1400" dirty="0">
+                <a:solidFill>
+                  <a:schemeClr val="tx1"/>
+                </a:solidFill>
+              </a:rPr>
+              <a:t>Web UI, plus digest as text and HTML</a:t>
+            </a:r>
+            <a:endParaRPr lang="en-US" sz="1400" dirty="0"/>
+          </a:p>
+        </p:txBody>
+      </p:sp>
+      <p:sp>
+        <p:nvSpPr>
+          <p:cNvPr id="6" name="Test data note"/>
+          <p:cNvSpPr txBox="1"/>
+          <p:nvPr/>
+        </p:nvSpPr>
+        <p:spPr>
+          <a:xfrm>
+            <a:off x="822960" y="4023360"/>
+            <a:ext cx="3383280" cy="320040"/>
+          </a:xfrm>
+          <a:prstGeom prst="rect">
+            <a:avLst/>
+          </a:prstGeom>
+          <a:noFill/>
+          <a:ln/>
+        </p:spPr>
+        <p:txBody>
+          <a:bodyPr wrap="square" lIns="0" tIns="0" rIns="0" bIns="0" rtlCol="0" anchor="ctr"/>
+          <a:lstStyle/>
+          <a:p>
+            <a:pPr indent="0" marL="0">
+              <a:buNone/>
+            </a:pPr>
+            <a:r>
+              <a:rPr lang="en-US" sz="1200" i="1" dirty="0">
+                <a:solidFill>
+                  <a:schemeClr val="accent4"/>
+                </a:solidFill>
+              </a:rPr>
+              <a:t>Demo products and history are test data.</a:t>
+            </a:r>
+            <a:endParaRPr lang="en-US" sz="1200" dirty="0"/>
+          </a:p>
+        </p:txBody>
+      </p:sp>
+      <p:sp>
+        <p:nvSpPr>
+          <p:cNvPr id="7" name="Next card"/>
+          <p:cNvSpPr/>
+          <p:nvPr/>
+        </p:nvSpPr>
+        <p:spPr>
+          <a:xfrm>
+            <a:off x="4663440" y="1371600"/>
+            <a:ext cx="3931920" cy="3108960"/>
+          </a:xfrm>
+          <a:prstGeom prst="roundRect">
+            <a:avLst>
+              <a:gd name="adj" fmla="val 2353"/>
+            </a:avLst>
+          </a:prstGeom>
+          <a:solidFill>
+            <a:schemeClr val="tx1"/>
+          </a:solidFill>
+          <a:ln w="12700">
+            <a:solidFill>
+              <a:schemeClr val="tx1"/>
+            </a:solidFill>
+            <a:prstDash val="solid"/>
+          </a:ln>
+        </p:spPr>
+      </p:sp>
+      <p:sp>
+        <p:nvSpPr>
+          <p:cNvPr id="8" name="Next heading"/>
+          <p:cNvSpPr txBox="1"/>
+          <p:nvPr/>
+        </p:nvSpPr>
+        <p:spPr>
+          <a:xfrm>
+            <a:off x="4937760" y="1554480"/>
+            <a:ext cx="3383280" cy="274320"/>
+          </a:xfrm>
+          <a:prstGeom prst="rect">
+            <a:avLst/>
+          </a:prstGeom>
+          <a:noFill/>
+          <a:ln/>
+        </p:spPr>
+        <p:txBody>
+          <a:bodyPr wrap="square" lIns="0" tIns="0" rIns="0" bIns="0" rtlCol="0" anchor="ctr"/>
+          <a:lstStyle/>
+          <a:p>
+            <a:pPr indent="0" marL="0">
+              <a:buNone/>
+            </a:pPr>
+            <a:r>
+              <a:rPr lang="en-US" sz="1200" b="1" spc="200" kern="0" dirty="0">
+                <a:solidFill>
+                  <a:schemeClr val="accent6"/>
+                </a:solidFill>
+              </a:rPr>
+              <a:t>NEXT</a:t>
+            </a:r>
+            <a:endParaRPr lang="en-US" sz="1200" dirty="0"/>
+          </a:p>
+        </p:txBody>
+      </p:sp>
+      <p:sp>
+        <p:nvSpPr>
+          <p:cNvPr id="9" name="Next list"/>
+          <p:cNvSpPr txBox="1"/>
+          <p:nvPr/>
+        </p:nvSpPr>
+        <p:spPr>
+          <a:xfrm>
+            <a:off x="4937760" y="1920240"/>
+            <a:ext cx="3383280" cy="2286000"/>
+          </a:xfrm>
+          <a:prstGeom prst="rect">
+            <a:avLst/>
+          </a:prstGeom>
+          <a:noFill/>
+          <a:ln/>
+        </p:spPr>
+        <p:txBody>
+          <a:bodyPr wrap="square" lIns="0" tIns="0" rIns="0" bIns="0" rtlCol="0" anchor="t"/>
+          <a:lstStyle/>
+          <a:p>
+            <a:pPr marL="342900" indent="-342900">
+              <a:spcAft>
+                <a:spcPts val="800"/>
+              </a:spcAft>
+              <a:buSzPct val="100000"/>
+              <a:buChar char="•"/>
+            </a:pPr>
+            <a:r>
+              <a:rPr lang="en-US" sz="1400" dirty="0">
+                <a:solidFill>
+                  <a:schemeClr val="bg1"/>
+                </a:solidFill>
+              </a:rPr>
+              <a:t>Deploy on Cloud Run with a daily Scheduler job</a:t>
+            </a:r>
+            <a:endParaRPr lang="en-US" sz="1400" dirty="0"/>
+          </a:p>
+          <a:p>
+            <a:pPr marL="342900" indent="-342900">
+              <a:spcAft>
+                <a:spcPts val="800"/>
+              </a:spcAft>
+              <a:buSzPct val="100000"/>
+              <a:buChar char="•"/>
+            </a:pPr>
+            <a:r>
+              <a:rPr lang="en-US" sz="1400" dirty="0">
+                <a:solidFill>
+                  <a:schemeClr val="bg1"/>
+                </a:solidFill>
+              </a:rPr>
+              <a:t>Store real price history in Firestore</a:t>
+            </a:r>
+            <a:endParaRPr lang="en-US" sz="1400" dirty="0"/>
+          </a:p>
+          <a:p>
+            <a:pPr marL="342900" indent="-342900">
+              <a:spcAft>
+                <a:spcPts val="800"/>
+              </a:spcAft>
+              <a:buSzPct val="100000"/>
+              <a:buChar char="•"/>
+            </a:pPr>
+            <a:r>
+              <a:rPr lang="en-US" sz="1400" dirty="0">
+                <a:solidFill>
+                  <a:schemeClr val="bg1"/>
+                </a:solidFill>
+              </a:rPr>
+              <a:t>Send the digest by email</a:t>
+            </a:r>
+            <a:endParaRPr lang="en-US" sz="1400" dirty="0"/>
+          </a:p>
+          <a:p>
+            <a:pPr marL="342900" indent="-342900">
+              <a:spcAft>
+                <a:spcPts val="800"/>
+              </a:spcAft>
+              <a:buSzPct val="100000"/>
+              <a:buChar char="•"/>
+            </a:pPr>
+            <a:r>
+              <a:rPr lang="en-US" sz="1400" dirty="0">
+                <a:solidFill>
+                  <a:schemeClr val="bg1"/>
+                </a:solidFill>
+              </a:rPr>
+              <a:t>Retailer APIs, more categories</a:t>
+            </a:r>
+            <a:endParaRPr lang="en-US" sz="1400" dirty="0"/>
+          </a:p>
+        </p:txBody>
+      </p:sp>
+      <p:sp>
+        <p:nvSpPr>
+          <p:cNvPr id="25" name="Slide Number Placeholder 0"/>
+          <p:cNvSpPr>
+            <a:spLocks noGrp="1"/>
+          </p:cNvSpPr>
+          <p:nvPr>
+            <p:ph type="sldNum" sz="quarter" idx="4294967295"/>
+          </p:nvPr>
+        </p:nvSpPr>
+        <p:spPr>
+          <a:xfrm>
+            <a:off x="8412480" y="4800600"/>
+            <a:ext cx="457200" cy="228600"/>
+          </a:xfrm>
+          <a:prstGeom prst="rect">
+            <a:avLst/>
+          </a:prstGeom>
+          <a:extLst>
+            <a:ext uri="{C572A759-6A51-4108-AA02-DFA0A04FC94B}">
+              <ma14:wrappingTextBoxFlag xmlns:ma14="http://schemas.microsoft.com/office/mac/drawingml/2011/main" val="0"/>
+            </a:ext>
+          </a:extLst>
+        </p:spPr>
+        <p:txBody>
+          <a:bodyPr/>
+          <a:lstStyle>
+            <a:lvl1pPr>
+              <a:defRPr sz="1000">
+                <a:solidFill>
+                  <a:schemeClr val="accent4"/>
+                </a:solidFill>
+              </a:defRPr>
+            </a:lvl1pPr>
+          </a:lstStyle>
+          <a:p>
+            <a:pPr algn="r"/>
+            <a:fld id="{F7021451-1387-4CA6-816F-3879F97B5CBC}" type="slidenum">
+              <a:rPr b="0" lang="en-US"/>
+              <a:t>9</a:t>
             </a:fld>
             <a:endParaRPr lang="en-US"/>
           </a:p>

</xml_diff>

<commit_message>
Update deck and pitch for buying-advisor kit mode
Co-Authored-By: Claude Sonnet 5.5 <noreply@anthropic.com>
</commit_message>
<xml_diff>
--- a/DealScout.pptx
+++ b/DealScout.pptx
@@ -15,9 +15,10 @@
     <p:sldId id="263" r:id="rId9"/>
     <p:sldId id="264" r:id="rId10"/>
     <p:sldId id="265" r:id="rId11"/>
+    <p:sldId id="266" r:id="rId12"/>
   </p:sldIdLst>
   <p:notesMasterIdLst>
-    <p:notesMasterId r:id="rId12"/>
+    <p:notesMasterId r:id="rId13"/>
   </p:notesMasterIdLst>
   <p:sldSz cx="9144000" cy="5143500"/>
   <p:notesSz cx="5143500" cy="9144000"/>
@@ -1706,7 +1707,7 @@
           <a:p>
             <a:r>
               <a:rPr lang="en-US" dirty="0"/>
-              <a:t>Thank you. Questions?</a:t>
+              <a:t>Real price history takes days to accumulate, which is why the demo uses seeded history.</a:t>
             </a:r>
             <a:endParaRPr lang="en-US" dirty="0"/>
           </a:p>
@@ -1730,6 +1731,94 @@
             <a:fld id="{F7021451-1387-4CA6-816F-3879F97B5CBC}" type="slidenum">
               <a:rPr lang="en-US"/>
               <a:t>10</a:t>
+            </a:fld>
+            <a:endParaRPr lang="en-US"/>
+          </a:p>
+        </p:txBody>
+      </p:sp>
+    </p:spTree>
+    <p:extLst>
+      <p:ext uri="{BB962C8B-B14F-4D97-AF65-F5344CB8AC3E}">
+        <p14:creationId xmlns:p14="http://schemas.microsoft.com/office/powerpoint/2010/main" val="1024086991"/>
+      </p:ext>
+    </p:extLst>
+  </p:cSld>
+  <p:clrMapOvr>
+    <a:masterClrMapping/>
+  </p:clrMapOvr>
+</p:notes>
+</file>
+
+<file path=ppt/notesSlides/notesSlide11.xml><?xml version="1.0" encoding="utf-8"?>
+<p:notes xmlns:a="http://schemas.openxmlformats.org/drawingml/2006/main" xmlns:r="http://schemas.openxmlformats.org/officeDocument/2006/relationships" xmlns:p="http://schemas.openxmlformats.org/presentationml/2006/main">
+  <p:cSld>
+    <p:spTree>
+      <p:nvGrpSpPr>
+        <p:cNvPr id="1" name=""/>
+        <p:cNvGrpSpPr/>
+        <p:nvPr/>
+      </p:nvGrpSpPr>
+      <p:grpSpPr>
+        <a:xfrm>
+          <a:off x="0" y="0"/>
+          <a:ext cx="0" cy="0"/>
+          <a:chOff x="0" y="0"/>
+          <a:chExt cx="0" cy="0"/>
+        </a:xfrm>
+      </p:grpSpPr>
+      <p:sp>
+        <p:nvSpPr>
+          <p:cNvPr id="2" name="Slide Image Placeholder 1"/>
+          <p:cNvSpPr>
+            <a:spLocks noGrp="1" noRot="1" noChangeAspect="1"/>
+          </p:cNvSpPr>
+          <p:nvPr>
+            <p:ph type="sldImg"/>
+          </p:nvPr>
+        </p:nvSpPr>
+        <p:spPr/>
+      </p:sp>
+      <p:sp>
+        <p:nvSpPr>
+          <p:cNvPr id="3" name="Notes Placeholder 2"/>
+          <p:cNvSpPr>
+            <a:spLocks noGrp="1"/>
+          </p:cNvSpPr>
+          <p:nvPr>
+            <p:ph type="body" idx="1"/>
+          </p:nvPr>
+        </p:nvSpPr>
+        <p:spPr/>
+        <p:txBody>
+          <a:bodyPr/>
+          <a:lstStyle/>
+          <a:p>
+            <a:r>
+              <a:rPr lang="en-US" dirty="0"/>
+              <a:t>Thank you. Questions?</a:t>
+            </a:r>
+            <a:endParaRPr lang="en-US" dirty="0"/>
+          </a:p>
+        </p:txBody>
+      </p:sp>
+      <p:sp>
+        <p:nvSpPr>
+          <p:cNvPr id="4" name="Slide Number Placeholder 3"/>
+          <p:cNvSpPr>
+            <a:spLocks noGrp="1"/>
+          </p:cNvSpPr>
+          <p:nvPr>
+            <p:ph type="sldNum" sz="quarter" idx="10"/>
+          </p:nvPr>
+        </p:nvSpPr>
+        <p:spPr/>
+        <p:txBody>
+          <a:bodyPr/>
+          <a:lstStyle/>
+          <a:p>
+            <a:fld id="{F7021451-1387-4CA6-816F-3879F97B5CBC}" type="slidenum">
+              <a:rPr lang="en-US"/>
+              <a:t>11</a:t>
             </a:fld>
             <a:endParaRPr lang="en-US"/>
           </a:p>
@@ -1970,7 +2059,7 @@
           <a:p>
             <a:r>
               <a:rPr lang="en-US" dirty="0"/>
-              <a:t>This is the real UI. Run npm run ui, open localhost:3000, click Scout deals.</a:t>
+              <a:t>Total budget 30,000 rupees for a podcast. Bar shows where it goes. The 1,712 left over buys a headphone upgrade that is at a 60-day low. Test data.</a:t>
             </a:r>
             <a:endParaRPr lang="en-US" dirty="0"/>
           </a:p>
@@ -2058,7 +2147,7 @@
           <a:p>
             <a:r>
               <a:rPr lang="en-US" dirty="0"/>
-              <a:t>Point at the red exclamation mark: the fake discount is caught live. The test-data run is instant, so the UI paces the lines so they can be read.</a:t>
+              <a:t>This is the real UI. Run npm run ui, open localhost:3000, click Scout deals.</a:t>
             </a:r>
             <a:endParaRPr lang="en-US" dirty="0"/>
           </a:p>
@@ -2146,7 +2235,7 @@
           <a:p>
             <a:r>
               <a:rPr lang="en-US" dirty="0"/>
-              <a:t>PreSonus AudioBox on test data. The red line is the 'original price' the store shows. The green line is what it actually sold for. It never came close, so the discount is fake.</a:t>
+              <a:t>Point at the red exclamation mark: the fake discount is caught live. The test-data run is instant, so the UI paces the lines so they can be read.</a:t>
             </a:r>
             <a:endParaRPr lang="en-US" dirty="0"/>
           </a:p>
@@ -2234,7 +2323,7 @@
           <a:p>
             <a:r>
               <a:rPr lang="en-US" dirty="0"/>
-              <a:t>This is what a price tracker cannot do: it compares against what the buyer actually asked for.</a:t>
+              <a:t>PreSonus AudioBox on test data. The red line is the 'original price' the store shows. The green line is what it actually sold for. It never came close, so the discount is fake.</a:t>
             </a:r>
             <a:endParaRPr lang="en-US" dirty="0"/>
           </a:p>
@@ -2322,7 +2411,7 @@
           <a:p>
             <a:r>
               <a:rPr lang="en-US" dirty="0"/>
-              <a:t>Be upfront: Gemini watch spec and discovery are written; deploy, Firestore and email sending are the next steps.</a:t>
+              <a:t>This is what a price tracker cannot do: it compares against what the buyer actually asked for.</a:t>
             </a:r>
             <a:endParaRPr lang="en-US" dirty="0"/>
           </a:p>
@@ -2410,7 +2499,7 @@
           <a:p>
             <a:r>
               <a:rPr lang="en-US" dirty="0"/>
-              <a:t>Real price history takes days to accumulate, which is why the demo uses seeded history.</a:t>
+              <a:t>Be upfront: Gemini watch spec and discovery are written; deploy, Firestore and email sending are the next steps.</a:t>
             </a:r>
             <a:endParaRPr lang="en-US" dirty="0"/>
           </a:p>
@@ -3067,16 +3156,16 @@
         <p:spPr>
           <a:xfrm>
             <a:off x="640080" y="2377440"/>
-            <a:ext cx="4937760" cy="457200"/>
-          </a:xfrm>
-          <a:prstGeom prst="rect">
-            <a:avLst/>
-          </a:prstGeom>
-          <a:noFill/>
-          <a:ln/>
-        </p:spPr>
-        <p:txBody>
-          <a:bodyPr wrap="square" lIns="0" tIns="0" rIns="0" bIns="0" rtlCol="0" anchor="ctr"/>
+            <a:ext cx="4937760" cy="777240"/>
+          </a:xfrm>
+          <a:prstGeom prst="rect">
+            <a:avLst/>
+          </a:prstGeom>
+          <a:noFill/>
+          <a:ln/>
+        </p:spPr>
+        <p:txBody>
+          <a:bodyPr wrap="square" lIns="0" tIns="0" rIns="0" bIns="0" rtlCol="0" anchor="t"/>
           <a:lstStyle/>
           <a:p>
             <a:pPr indent="0" marL="0">
@@ -3088,7 +3177,7 @@
                   <a:schemeClr val="accent5"/>
                 </a:solidFill>
               </a:rPr>
-              <a:t>Watches the need, not the product.</a:t>
+              <a:t>Your buying advisor. It watches the need, not the product.</a:t>
             </a:r>
             <a:endParaRPr lang="en-US" sz="2200" dirty="0"/>
           </a:p>
@@ -3102,7 +3191,7 @@
         </p:nvSpPr>
         <p:spPr>
           <a:xfrm>
-            <a:off x="640080" y="3017520"/>
+            <a:off x="640080" y="3383280"/>
             <a:ext cx="4937760" cy="365760"/>
           </a:xfrm>
           <a:prstGeom prst="rect">
@@ -3391,53 +3480,82 @@
       </p:grpSpPr>
       <p:sp>
         <p:nvSpPr>
-          <p:cNvPr id="2" name="Closing line 1"/>
-          <p:cNvSpPr txBox="1"/>
-          <p:nvPr/>
-        </p:nvSpPr>
-        <p:spPr>
-          <a:xfrm>
-            <a:off x="640080" y="1371600"/>
-            <a:ext cx="7863840" cy="822960"/>
-          </a:xfrm>
-          <a:prstGeom prst="rect">
-            <a:avLst/>
-          </a:prstGeom>
-          <a:noFill/>
-          <a:ln/>
-        </p:spPr>
-        <p:txBody>
-          <a:bodyPr wrap="square" lIns="0" tIns="0" rIns="0" bIns="0" rtlCol="0" anchor="ctr"/>
+          <p:cNvPr id="2" name="Text 0"/>
+          <p:cNvSpPr/>
+          <p:nvPr>
+            <p:ph idx="100" type="title" hasCustomPrompt="1"/>
+          </p:nvPr>
+        </p:nvSpPr>
+        <p:spPr>
+          <a:xfrm>
+            <a:off x="548640" y="365760"/>
+            <a:ext cx="8046720" cy="868680"/>
+          </a:xfrm>
+          <a:prstGeom prst="rect">
+            <a:avLst/>
+          </a:prstGeom>
+          <a:noFill/>
+          <a:ln/>
+        </p:spPr>
+        <p:txBody>
+          <a:bodyPr wrap="square" lIns="0" tIns="0" rIns="0" bIns="0" rtlCol="0" anchor="t"/>
           <a:lstStyle/>
           <a:p>
             <a:pPr indent="0" marL="0">
               <a:buNone/>
             </a:pPr>
             <a:r>
-              <a:rPr lang="en-US" sz="4000" dirty="0">
-                <a:solidFill>
-                  <a:schemeClr val="accent5"/>
+              <a:rPr lang="en-US" sz="3000" b="1" dirty="0">
+                <a:solidFill>
+                  <a:schemeClr val="tx1"/>
                 </a:solidFill>
                 <a:latin typeface="Cambria" pitchFamily="34" charset="0"/>
                 <a:ea typeface="Cambria" pitchFamily="34" charset="-122"/>
                 <a:cs typeface="Cambria" pitchFamily="34" charset="-120"/>
               </a:rPr>
-              <a:t>Trackers watch products.</a:t>
-            </a:r>
-            <a:endParaRPr lang="en-US" sz="4000" dirty="0"/>
-          </a:p>
-        </p:txBody>
-      </p:sp>
-      <p:sp>
-        <p:nvSpPr>
-          <p:cNvPr id="3" name="Closing line 2"/>
+              <a:t>Working today, and what comes next</a:t>
+            </a:r>
+            <a:endParaRPr lang="en-US" sz="3000" dirty="0"/>
+          </a:p>
+        </p:txBody>
+      </p:sp>
+      <p:sp>
+        <p:nvSpPr>
+          <p:cNvPr id="3" name="Today card"/>
+          <p:cNvSpPr/>
+          <p:nvPr/>
+        </p:nvSpPr>
+        <p:spPr>
+          <a:xfrm>
+            <a:off x="548640" y="1371600"/>
+            <a:ext cx="3931920" cy="3108960"/>
+          </a:xfrm>
+          <a:prstGeom prst="roundRect">
+            <a:avLst>
+              <a:gd name="adj" fmla="val 2353"/>
+            </a:avLst>
+          </a:prstGeom>
+          <a:solidFill>
+            <a:schemeClr val="bg2"/>
+          </a:solidFill>
+          <a:ln w="12700">
+            <a:solidFill>
+              <a:schemeClr val="bg2"/>
+            </a:solidFill>
+            <a:prstDash val="solid"/>
+          </a:ln>
+        </p:spPr>
+      </p:sp>
+      <p:sp>
+        <p:nvSpPr>
+          <p:cNvPr id="4" name="Today heading"/>
           <p:cNvSpPr txBox="1"/>
           <p:nvPr/>
         </p:nvSpPr>
         <p:spPr>
           <a:xfrm>
-            <a:off x="640080" y="2194560"/>
-            <a:ext cx="7863840" cy="822960"/>
+            <a:off x="822960" y="1554480"/>
+            <a:ext cx="3383280" cy="274320"/>
           </a:xfrm>
           <a:prstGeom prst="rect">
             <a:avLst/>
@@ -3453,30 +3571,157 @@
               <a:buNone/>
             </a:pPr>
             <a:r>
-              <a:rPr lang="en-US" sz="4000" b="1" dirty="0">
-                <a:solidFill>
-                  <a:schemeClr val="bg1"/>
-                </a:solidFill>
-                <a:latin typeface="Cambria" pitchFamily="34" charset="0"/>
-                <a:ea typeface="Cambria" pitchFamily="34" charset="-122"/>
-                <a:cs typeface="Cambria" pitchFamily="34" charset="-120"/>
-              </a:rPr>
-              <a:t>DealScout watches your need.</a:t>
-            </a:r>
-            <a:endParaRPr lang="en-US" sz="4000" dirty="0"/>
-          </a:p>
-        </p:txBody>
-      </p:sp>
-      <p:sp>
-        <p:nvSpPr>
-          <p:cNvPr id="4" name="Closing body"/>
+              <a:rPr lang="en-US" sz="1200" b="1" spc="200" kern="0" dirty="0">
+                <a:solidFill>
+                  <a:schemeClr val="accent1"/>
+                </a:solidFill>
+              </a:rPr>
+              <a:t>WORKING TODAY</a:t>
+            </a:r>
+            <a:endParaRPr lang="en-US" sz="1200" dirty="0"/>
+          </a:p>
+        </p:txBody>
+      </p:sp>
+      <p:sp>
+        <p:nvSpPr>
+          <p:cNvPr id="5" name="Today list"/>
           <p:cNvSpPr txBox="1"/>
           <p:nvPr/>
         </p:nvSpPr>
         <p:spPr>
           <a:xfrm>
-            <a:off x="640080" y="3291840"/>
-            <a:ext cx="7315200" cy="457200"/>
+            <a:off x="822960" y="1920240"/>
+            <a:ext cx="3383280" cy="2011680"/>
+          </a:xfrm>
+          <a:prstGeom prst="rect">
+            <a:avLst/>
+          </a:prstGeom>
+          <a:noFill/>
+          <a:ln/>
+        </p:spPr>
+        <p:txBody>
+          <a:bodyPr wrap="square" lIns="0" tIns="0" rIns="0" bIns="0" rtlCol="0" anchor="t"/>
+          <a:lstStyle/>
+          <a:p>
+            <a:pPr marL="342900" indent="-342900">
+              <a:spcAft>
+                <a:spcPts val="800"/>
+              </a:spcAft>
+              <a:buSzPct val="100000"/>
+              <a:buChar char="•"/>
+            </a:pPr>
+            <a:r>
+              <a:rPr lang="en-US" sz="1400" dirty="0">
+                <a:solidFill>
+                  <a:schemeClr val="tx1"/>
+                </a:solidFill>
+              </a:rPr>
+              <a:t>Fake-discount and verdict logic, 17 tests</a:t>
+            </a:r>
+            <a:endParaRPr lang="en-US" sz="1400" dirty="0"/>
+          </a:p>
+          <a:p>
+            <a:pPr marL="342900" indent="-342900">
+              <a:spcAft>
+                <a:spcPts val="800"/>
+              </a:spcAft>
+              <a:buSzPct val="100000"/>
+              <a:buChar char="•"/>
+            </a:pPr>
+            <a:r>
+              <a:rPr lang="en-US" sz="1400" dirty="0">
+                <a:solidFill>
+                  <a:schemeClr val="tx1"/>
+                </a:solidFill>
+              </a:rPr>
+              <a:t>Gemini watch spec from plain English</a:t>
+            </a:r>
+            <a:endParaRPr lang="en-US" sz="1400" dirty="0"/>
+          </a:p>
+          <a:p>
+            <a:pPr marL="342900" indent="-342900">
+              <a:spcAft>
+                <a:spcPts val="800"/>
+              </a:spcAft>
+              <a:buSzPct val="100000"/>
+              <a:buChar char="•"/>
+            </a:pPr>
+            <a:r>
+              <a:rPr lang="en-US" sz="1400" dirty="0">
+                <a:solidFill>
+                  <a:schemeClr val="tx1"/>
+                </a:solidFill>
+              </a:rPr>
+              <a:t>Kit mode: budget split, picks, leftover upgrade</a:t>
+            </a:r>
+            <a:endParaRPr lang="en-US" sz="1400" dirty="0"/>
+          </a:p>
+          <a:p>
+            <a:pPr marL="342900" indent="-342900">
+              <a:spcAft>
+                <a:spcPts val="800"/>
+              </a:spcAft>
+              <a:buSzPct val="100000"/>
+              <a:buChar char="•"/>
+            </a:pPr>
+            <a:r>
+              <a:rPr lang="en-US" sz="1400" dirty="0">
+                <a:solidFill>
+                  <a:schemeClr val="tx1"/>
+                </a:solidFill>
+              </a:rPr>
+              <a:t>Live agent trace and need-aware fit check</a:t>
+            </a:r>
+            <a:endParaRPr lang="en-US" sz="1400" dirty="0"/>
+          </a:p>
+          <a:p>
+            <a:pPr marL="342900" indent="-342900">
+              <a:spcAft>
+                <a:spcPts val="800"/>
+              </a:spcAft>
+              <a:buSzPct val="100000"/>
+              <a:buChar char="•"/>
+            </a:pPr>
+            <a:r>
+              <a:rPr lang="en-US" sz="1400" dirty="0">
+                <a:solidFill>
+                  <a:schemeClr val="tx1"/>
+                </a:solidFill>
+              </a:rPr>
+              <a:t>Google Search discovery (not yet run live)</a:t>
+            </a:r>
+            <a:endParaRPr lang="en-US" sz="1400" dirty="0"/>
+          </a:p>
+          <a:p>
+            <a:pPr marL="342900" indent="-342900">
+              <a:spcAft>
+                <a:spcPts val="800"/>
+              </a:spcAft>
+              <a:buSzPct val="100000"/>
+              <a:buChar char="•"/>
+            </a:pPr>
+            <a:r>
+              <a:rPr lang="en-US" sz="1400" dirty="0">
+                <a:solidFill>
+                  <a:schemeClr val="tx1"/>
+                </a:solidFill>
+              </a:rPr>
+              <a:t>Web UI, plus digest as text and HTML</a:t>
+            </a:r>
+            <a:endParaRPr lang="en-US" sz="1400" dirty="0"/>
+          </a:p>
+        </p:txBody>
+      </p:sp>
+      <p:sp>
+        <p:nvSpPr>
+          <p:cNvPr id="6" name="Test data note"/>
+          <p:cNvSpPr txBox="1"/>
+          <p:nvPr/>
+        </p:nvSpPr>
+        <p:spPr>
+          <a:xfrm>
+            <a:off x="822960" y="4023360"/>
+            <a:ext cx="3383280" cy="320040"/>
           </a:xfrm>
           <a:prstGeom prst="rect">
             <a:avLst/>
@@ -3492,14 +3737,171 @@
               <a:buNone/>
             </a:pPr>
             <a:r>
-              <a:rPr lang="en-US" sz="1600" dirty="0">
-                <a:solidFill>
-                  <a:schemeClr val="bg2"/>
-                </a:solidFill>
-              </a:rPr>
-              <a:t>Find the options you didn't know existed. Know whether the deal is real.</a:t>
-            </a:r>
-            <a:endParaRPr lang="en-US" sz="1600" dirty="0"/>
+              <a:rPr lang="en-US" sz="1200" i="1" dirty="0">
+                <a:solidFill>
+                  <a:schemeClr val="accent4"/>
+                </a:solidFill>
+              </a:rPr>
+              <a:t>Demo products and history are test data.</a:t>
+            </a:r>
+            <a:endParaRPr lang="en-US" sz="1200" dirty="0"/>
+          </a:p>
+        </p:txBody>
+      </p:sp>
+      <p:sp>
+        <p:nvSpPr>
+          <p:cNvPr id="7" name="Next card"/>
+          <p:cNvSpPr/>
+          <p:nvPr/>
+        </p:nvSpPr>
+        <p:spPr>
+          <a:xfrm>
+            <a:off x="4663440" y="1371600"/>
+            <a:ext cx="3931920" cy="3108960"/>
+          </a:xfrm>
+          <a:prstGeom prst="roundRect">
+            <a:avLst>
+              <a:gd name="adj" fmla="val 2353"/>
+            </a:avLst>
+          </a:prstGeom>
+          <a:solidFill>
+            <a:schemeClr val="tx1"/>
+          </a:solidFill>
+          <a:ln w="12700">
+            <a:solidFill>
+              <a:schemeClr val="tx1"/>
+            </a:solidFill>
+            <a:prstDash val="solid"/>
+          </a:ln>
+        </p:spPr>
+      </p:sp>
+      <p:sp>
+        <p:nvSpPr>
+          <p:cNvPr id="8" name="Next heading"/>
+          <p:cNvSpPr txBox="1"/>
+          <p:nvPr/>
+        </p:nvSpPr>
+        <p:spPr>
+          <a:xfrm>
+            <a:off x="4937760" y="1554480"/>
+            <a:ext cx="3383280" cy="274320"/>
+          </a:xfrm>
+          <a:prstGeom prst="rect">
+            <a:avLst/>
+          </a:prstGeom>
+          <a:noFill/>
+          <a:ln/>
+        </p:spPr>
+        <p:txBody>
+          <a:bodyPr wrap="square" lIns="0" tIns="0" rIns="0" bIns="0" rtlCol="0" anchor="ctr"/>
+          <a:lstStyle/>
+          <a:p>
+            <a:pPr indent="0" marL="0">
+              <a:buNone/>
+            </a:pPr>
+            <a:r>
+              <a:rPr lang="en-US" sz="1200" b="1" spc="200" kern="0" dirty="0">
+                <a:solidFill>
+                  <a:schemeClr val="accent6"/>
+                </a:solidFill>
+              </a:rPr>
+              <a:t>NEXT</a:t>
+            </a:r>
+            <a:endParaRPr lang="en-US" sz="1200" dirty="0"/>
+          </a:p>
+        </p:txBody>
+      </p:sp>
+      <p:sp>
+        <p:nvSpPr>
+          <p:cNvPr id="9" name="Next list"/>
+          <p:cNvSpPr txBox="1"/>
+          <p:nvPr/>
+        </p:nvSpPr>
+        <p:spPr>
+          <a:xfrm>
+            <a:off x="4937760" y="1920240"/>
+            <a:ext cx="3383280" cy="2286000"/>
+          </a:xfrm>
+          <a:prstGeom prst="rect">
+            <a:avLst/>
+          </a:prstGeom>
+          <a:noFill/>
+          <a:ln/>
+        </p:spPr>
+        <p:txBody>
+          <a:bodyPr wrap="square" lIns="0" tIns="0" rIns="0" bIns="0" rtlCol="0" anchor="t"/>
+          <a:lstStyle/>
+          <a:p>
+            <a:pPr marL="342900" indent="-342900">
+              <a:spcAft>
+                <a:spcPts val="800"/>
+              </a:spcAft>
+              <a:buSzPct val="100000"/>
+              <a:buChar char="•"/>
+            </a:pPr>
+            <a:r>
+              <a:rPr lang="en-US" sz="1400" dirty="0">
+                <a:solidFill>
+                  <a:schemeClr val="bg1"/>
+                </a:solidFill>
+              </a:rPr>
+              <a:t>Deploy on Cloud Run with a daily Scheduler job</a:t>
+            </a:r>
+            <a:endParaRPr lang="en-US" sz="1400" dirty="0"/>
+          </a:p>
+          <a:p>
+            <a:pPr marL="342900" indent="-342900">
+              <a:spcAft>
+                <a:spcPts val="800"/>
+              </a:spcAft>
+              <a:buSzPct val="100000"/>
+              <a:buChar char="•"/>
+            </a:pPr>
+            <a:r>
+              <a:rPr lang="en-US" sz="1400" dirty="0">
+                <a:solidFill>
+                  <a:schemeClr val="bg1"/>
+                </a:solidFill>
+              </a:rPr>
+              <a:t>Store real price history in Firestore</a:t>
+            </a:r>
+            <a:endParaRPr lang="en-US" sz="1400" dirty="0"/>
+          </a:p>
+          <a:p>
+            <a:pPr marL="342900" indent="-342900">
+              <a:spcAft>
+                <a:spcPts val="800"/>
+              </a:spcAft>
+              <a:buSzPct val="100000"/>
+              <a:buChar char="•"/>
+            </a:pPr>
+            <a:r>
+              <a:rPr lang="en-US" sz="1400" dirty="0">
+                <a:solidFill>
+                  <a:schemeClr val="bg1"/>
+                </a:solidFill>
+              </a:rPr>
+              <a:t>Send the digest by email</a:t>
+            </a:r>
+            <a:endParaRPr lang="en-US" sz="1400" dirty="0"/>
+          </a:p>
+          <a:p>
+            <a:pPr marL="342900" indent="-342900">
+              <a:spcAft>
+                <a:spcPts val="800"/>
+              </a:spcAft>
+              <a:buSzPct val="100000"/>
+              <a:buChar char="•"/>
+            </a:pPr>
+            <a:r>
+              <a:rPr lang="en-US" sz="1400" dirty="0">
+                <a:solidFill>
+                  <a:schemeClr val="bg1"/>
+                </a:solidFill>
+              </a:rPr>
+              <a:t>Retailer APIs, more categories</a:t>
+            </a:r>
+            <a:endParaRPr lang="en-US" sz="1400" dirty="0"/>
           </a:p>
         </p:txBody>
       </p:sp>
@@ -3533,7 +3935,7 @@
             <a:lvl1pPr>
               <a:defRPr sz="1000">
                 <a:solidFill>
-                  <a:schemeClr val="accent5"/>
+                  <a:schemeClr val="accent4"/>
                 </a:solidFill>
               </a:defRPr>
             </a:lvl1pPr>
@@ -3543,6 +3945,190 @@
             <a:fld id="{F7021451-1387-4CA6-816F-3879F97B5CBC}" type="slidenum">
               <a:rPr b="0" lang="en-US"/>
               <a:t>10</a:t>
+            </a:fld>
+            <a:endParaRPr lang="en-US"/>
+          </a:p>
+        </p:txBody>
+      </p:sp>
+    </p:spTree>
+  </p:cSld>
+  <p:clrMapOvr>
+    <a:masterClrMapping/>
+  </p:clrMapOvr>
+</p:sld>
+</file>
+
+<file path=ppt/slides/slide11.xml><?xml version="1.0" encoding="utf-8"?>
+<p:sld xmlns:a="http://schemas.openxmlformats.org/drawingml/2006/main" xmlns:r="http://schemas.openxmlformats.org/officeDocument/2006/relationships" xmlns:p="http://schemas.openxmlformats.org/presentationml/2006/main">
+  <p:cSld name="Slide 11">
+    <p:spTree>
+      <p:nvGrpSpPr>
+        <p:cNvPr id="1" name=""/>
+        <p:cNvGrpSpPr/>
+        <p:nvPr/>
+      </p:nvGrpSpPr>
+      <p:grpSpPr>
+        <a:xfrm>
+          <a:off x="0" y="0"/>
+          <a:ext cx="0" cy="0"/>
+          <a:chOff x="0" y="0"/>
+          <a:chExt cx="0" cy="0"/>
+        </a:xfrm>
+      </p:grpSpPr>
+      <p:sp>
+        <p:nvSpPr>
+          <p:cNvPr id="2" name="Closing line 1"/>
+          <p:cNvSpPr txBox="1"/>
+          <p:nvPr/>
+        </p:nvSpPr>
+        <p:spPr>
+          <a:xfrm>
+            <a:off x="640080" y="1371600"/>
+            <a:ext cx="7863840" cy="822960"/>
+          </a:xfrm>
+          <a:prstGeom prst="rect">
+            <a:avLst/>
+          </a:prstGeom>
+          <a:noFill/>
+          <a:ln/>
+        </p:spPr>
+        <p:txBody>
+          <a:bodyPr wrap="square" lIns="0" tIns="0" rIns="0" bIns="0" rtlCol="0" anchor="ctr"/>
+          <a:lstStyle/>
+          <a:p>
+            <a:pPr indent="0" marL="0">
+              <a:buNone/>
+            </a:pPr>
+            <a:r>
+              <a:rPr lang="en-US" sz="4000" dirty="0">
+                <a:solidFill>
+                  <a:schemeClr val="accent5"/>
+                </a:solidFill>
+                <a:latin typeface="Cambria" pitchFamily="34" charset="0"/>
+                <a:ea typeface="Cambria" pitchFamily="34" charset="-122"/>
+                <a:cs typeface="Cambria" pitchFamily="34" charset="-120"/>
+              </a:rPr>
+              <a:t>Trackers watch products.</a:t>
+            </a:r>
+            <a:endParaRPr lang="en-US" sz="4000" dirty="0"/>
+          </a:p>
+        </p:txBody>
+      </p:sp>
+      <p:sp>
+        <p:nvSpPr>
+          <p:cNvPr id="3" name="Closing line 2"/>
+          <p:cNvSpPr txBox="1"/>
+          <p:nvPr/>
+        </p:nvSpPr>
+        <p:spPr>
+          <a:xfrm>
+            <a:off x="640080" y="2194560"/>
+            <a:ext cx="7863840" cy="822960"/>
+          </a:xfrm>
+          <a:prstGeom prst="rect">
+            <a:avLst/>
+          </a:prstGeom>
+          <a:noFill/>
+          <a:ln/>
+        </p:spPr>
+        <p:txBody>
+          <a:bodyPr wrap="square" lIns="0" tIns="0" rIns="0" bIns="0" rtlCol="0" anchor="ctr"/>
+          <a:lstStyle/>
+          <a:p>
+            <a:pPr indent="0" marL="0">
+              <a:buNone/>
+            </a:pPr>
+            <a:r>
+              <a:rPr lang="en-US" sz="4000" b="1" dirty="0">
+                <a:solidFill>
+                  <a:schemeClr val="bg1"/>
+                </a:solidFill>
+                <a:latin typeface="Cambria" pitchFamily="34" charset="0"/>
+                <a:ea typeface="Cambria" pitchFamily="34" charset="-122"/>
+                <a:cs typeface="Cambria" pitchFamily="34" charset="-120"/>
+              </a:rPr>
+              <a:t>DealScout watches your need.</a:t>
+            </a:r>
+            <a:endParaRPr lang="en-US" sz="4000" dirty="0"/>
+          </a:p>
+        </p:txBody>
+      </p:sp>
+      <p:sp>
+        <p:nvSpPr>
+          <p:cNvPr id="4" name="Closing body"/>
+          <p:cNvSpPr txBox="1"/>
+          <p:nvPr/>
+        </p:nvSpPr>
+        <p:spPr>
+          <a:xfrm>
+            <a:off x="640080" y="3291840"/>
+            <a:ext cx="7315200" cy="457200"/>
+          </a:xfrm>
+          <a:prstGeom prst="rect">
+            <a:avLst/>
+          </a:prstGeom>
+          <a:noFill/>
+          <a:ln/>
+        </p:spPr>
+        <p:txBody>
+          <a:bodyPr wrap="square" lIns="0" tIns="0" rIns="0" bIns="0" rtlCol="0" anchor="ctr"/>
+          <a:lstStyle/>
+          <a:p>
+            <a:pPr indent="0" marL="0">
+              <a:buNone/>
+            </a:pPr>
+            <a:r>
+              <a:rPr lang="en-US" sz="1600" dirty="0">
+                <a:solidFill>
+                  <a:schemeClr val="bg2"/>
+                </a:solidFill>
+              </a:rPr>
+              <a:t>Tell it the goal and the budget. It plans the kit and says what to buy now and what to wait on.</a:t>
+            </a:r>
+            <a:endParaRPr lang="en-US" sz="1600" dirty="0"/>
+          </a:p>
+        </p:txBody>
+      </p:sp>
+      <p:sp>
+        <p:nvSpPr>
+          <p:cNvPr id="25" name="Slide Number Placeholder 0"/>
+          <p:cNvSpPr>
+            <a:spLocks noGrp="1"/>
+          </p:cNvSpPr>
+          <p:nvPr>
+            <p:ph type="sldNum" sz="quarter" idx="4294967295"/>
+          </p:nvPr>
+        </p:nvSpPr>
+        <p:spPr>
+          <a:xfrm>
+            <a:off x="8412480" y="4800600"/>
+            <a:ext cx="457200" cy="228600"/>
+          </a:xfrm>
+          <a:prstGeom prst="rect">
+            <a:avLst/>
+          </a:prstGeom>
+          <a:extLst>
+            <a:ext uri="{C572A759-6A51-4108-AA02-DFA0A04FC94B}">
+              <ma14:wrappingTextBoxFlag xmlns:ma14="http://schemas.microsoft.com/office/mac/drawingml/2011/main" val="0"/>
+            </a:ext>
+          </a:extLst>
+        </p:spPr>
+        <p:txBody>
+          <a:bodyPr/>
+          <a:lstStyle>
+            <a:lvl1pPr>
+              <a:defRPr sz="1000">
+                <a:solidFill>
+                  <a:schemeClr val="accent5"/>
+                </a:solidFill>
+              </a:defRPr>
+            </a:lvl1pPr>
+          </a:lstStyle>
+          <a:p>
+            <a:pPr algn="r"/>
+            <a:fld id="{F7021451-1387-4CA6-816F-3879F97B5CBC}" type="slidenum">
+              <a:rPr b="0" lang="en-US"/>
+              <a:t>11</a:t>
             </a:fld>
             <a:endParaRPr lang="en-US"/>
           </a:p>
@@ -4133,7 +4719,7 @@
                 <a:ea typeface="Cambria" pitchFamily="34" charset="-122"/>
                 <a:cs typeface="Cambria" pitchFamily="34" charset="-120"/>
               </a:rPr>
-              <a:t>Describe the need. DealScout does the watching.</a:t>
+              <a:t>Describe the goal. DealScout does the watching.</a:t>
             </a:r>
             <a:endParaRPr lang="en-US" sz="3000" dirty="0"/>
           </a:p>
@@ -4373,7 +4959,7 @@
                   <a:schemeClr val="tx1"/>
                 </a:solidFill>
               </a:rPr>
-              <a:t>Spec</a:t>
+              <a:t>Plan</a:t>
             </a:r>
             <a:endParaRPr lang="en-US" sz="1600" dirty="0"/>
           </a:p>
@@ -4409,7 +4995,7 @@
                   <a:schemeClr val="tx2"/>
                 </a:solidFill>
               </a:rPr>
-              <a:t>Gemini turns it into a watch spec</a:t>
+              <a:t>Gemini lists what you need and splits the budget</a:t>
             </a:r>
             <a:endParaRPr lang="en-US" sz="1200" dirty="0"/>
           </a:p>
@@ -4886,7 +5472,7 @@
                   <a:schemeClr val="bg1"/>
                 </a:solidFill>
               </a:rPr>
-              <a:t>"2-input USB audio interface with phantom power, under ₹15k"</a:t>
+              <a:t>"I'm starting a podcast and have ₹30,000 total"</a:t>
             </a:r>
             <a:endParaRPr lang="en-US" sz="1600" dirty="0"/>
           </a:p>
@@ -4997,7 +5583,7 @@
                 <a:ea typeface="Cambria" pitchFamily="34" charset="-122"/>
                 <a:cs typeface="Cambria" pitchFamily="34" charset="-120"/>
               </a:rPr>
-              <a:t>Describe the need, get a verdict on every match</a:t>
+              <a:t>From one goal to a whole kit</a:t>
             </a:r>
             <a:endParaRPr lang="en-US" sz="3000" dirty="0"/>
           </a:p>
@@ -5005,7 +5591,7 @@
       </p:sp>
       <p:pic>
         <p:nvPicPr>
-          <p:cNvPr id="3" name="UI screenshot" descr="/private/tmp/claude-502/-Users-meenu-Downloads-D2/12731e38-32f4-44ab-831f-f37e8cc97cf7/scratchpad/shots/overview.png">    </p:cNvPr>
+          <p:cNvPr id="3" name="Kit screenshot" descr="/private/tmp/claude-502/-Users-meenu-Downloads-D2/12731e38-32f4-44ab-831f-f37e8cc97cf7/scratchpad/shots/kit-head.png">    </p:cNvPr>
           <p:cNvPicPr>
             <a:picLocks noChangeAspect="1"/>
           </p:cNvPicPr>
@@ -5019,8 +5605,8 @@
         </p:blipFill>
         <p:spPr>
           <a:xfrm>
-            <a:off x="548640" y="1325880"/>
-            <a:ext cx="4480560" cy="3520440"/>
+            <a:off x="548640" y="1280160"/>
+            <a:ext cx="8046720" cy="2418588"/>
           </a:xfrm>
           <a:prstGeom prst="rect">
             <a:avLst/>
@@ -5029,14 +5615,14 @@
       </p:pic>
       <p:sp>
         <p:nvSpPr>
-          <p:cNvPr id="4" name="UI points"/>
+          <p:cNvPr id="4" name="Kit points"/>
           <p:cNvSpPr txBox="1"/>
           <p:nvPr/>
         </p:nvSpPr>
         <p:spPr>
           <a:xfrm>
-            <a:off x="5394960" y="1463040"/>
-            <a:ext cx="3200400" cy="2377440"/>
+            <a:off x="548640" y="3840480"/>
+            <a:ext cx="8046720" cy="1005840"/>
           </a:xfrm>
           <a:prstGeom prst="rect">
             <a:avLst/>
@@ -5050,110 +5636,56 @@
           <a:p>
             <a:pPr marL="342900" indent="-342900">
               <a:spcAft>
-                <a:spcPts val="1000"/>
+                <a:spcPts val="400"/>
               </a:spcAft>
               <a:buSzPct val="100000"/>
               <a:buChar char="•"/>
             </a:pPr>
             <a:r>
-              <a:rPr lang="en-US" sz="1600" dirty="0">
+              <a:rPr lang="en-US" sz="1500" dirty="0">
                 <a:solidFill>
                   <a:schemeClr val="tx1"/>
                 </a:solidFill>
               </a:rPr>
-              <a:t>Plain-English request and budget</a:t>
-            </a:r>
-            <a:endParaRPr lang="en-US" sz="1600" dirty="0"/>
+              <a:t>Gemini plans the shopping list and splits one budget across it</a:t>
+            </a:r>
+            <a:endParaRPr lang="en-US" sz="1500" dirty="0"/>
           </a:p>
           <a:p>
             <a:pPr marL="342900" indent="-342900">
               <a:spcAft>
-                <a:spcPts val="1000"/>
+                <a:spcPts val="400"/>
               </a:spcAft>
               <a:buSzPct val="100000"/>
               <a:buChar char="•"/>
             </a:pPr>
             <a:r>
-              <a:rPr lang="en-US" sz="1600" dirty="0">
+              <a:rPr lang="en-US" sz="1500" dirty="0">
                 <a:solidFill>
                   <a:schemeClr val="tx1"/>
                 </a:solidFill>
               </a:rPr>
-              <a:t>Gemini builds the watch spec: category, budget, must-haves</a:t>
-            </a:r>
-            <a:endParaRPr lang="en-US" sz="1600" dirty="0"/>
+              <a:t>Each item is scouted, fit-checked and screened for fake discounts</a:t>
+            </a:r>
+            <a:endParaRPr lang="en-US" sz="1500" dirty="0"/>
           </a:p>
           <a:p>
             <a:pPr marL="342900" indent="-342900">
               <a:spcAft>
-                <a:spcPts val="1000"/>
+                <a:spcPts val="400"/>
               </a:spcAft>
               <a:buSzPct val="100000"/>
               <a:buChar char="•"/>
             </a:pPr>
             <a:r>
-              <a:rPr lang="en-US" sz="1600" dirty="0">
+              <a:rPr lang="en-US" sz="1500" dirty="0">
                 <a:solidFill>
                   <a:schemeClr val="tx1"/>
                 </a:solidFill>
               </a:rPr>
-              <a:t>Every match gets Buy now or Wait, with reasons</a:t>
-            </a:r>
-            <a:endParaRPr lang="en-US" sz="1600" dirty="0"/>
-          </a:p>
-          <a:p>
-            <a:pPr marL="342900" indent="-342900">
-              <a:spcAft>
-                <a:spcPts val="1000"/>
-              </a:spcAft>
-              <a:buSzPct val="100000"/>
-              <a:buChar char="•"/>
-            </a:pPr>
-            <a:r>
-              <a:rPr lang="en-US" sz="1600" dirty="0">
-                <a:solidFill>
-                  <a:schemeClr val="tx1"/>
-                </a:solidFill>
-              </a:rPr>
-              <a:t>Fake discounts are counted and flagged</a:t>
-            </a:r>
-            <a:endParaRPr lang="en-US" sz="1600" dirty="0"/>
-          </a:p>
-        </p:txBody>
-      </p:sp>
-      <p:sp>
-        <p:nvSpPr>
-          <p:cNvPr id="5" name="UI caption"/>
-          <p:cNvSpPr txBox="1"/>
-          <p:nvPr/>
-        </p:nvSpPr>
-        <p:spPr>
-          <a:xfrm>
-            <a:off x="5394960" y="4343400"/>
-            <a:ext cx="3200400" cy="457200"/>
-          </a:xfrm>
-          <a:prstGeom prst="rect">
-            <a:avLst/>
-          </a:prstGeom>
-          <a:noFill/>
-          <a:ln/>
-        </p:spPr>
-        <p:txBody>
-          <a:bodyPr wrap="square" lIns="0" tIns="0" rIns="0" bIns="0" rtlCol="0" anchor="t"/>
-          <a:lstStyle/>
-          <a:p>
-            <a:pPr indent="0" marL="0">
-              <a:buNone/>
-            </a:pPr>
-            <a:r>
-              <a:rPr lang="en-US" sz="1100" i="1" dirty="0">
-                <a:solidFill>
-                  <a:schemeClr val="accent4"/>
-                </a:solidFill>
-              </a:rPr>
-              <a:t>Screenshot of the working prototype, on test data</a:t>
-            </a:r>
-            <a:endParaRPr lang="en-US" sz="1100" dirty="0"/>
+              <a:t>Money left over is offered as a real upgrade</a:t>
+            </a:r>
+            <a:endParaRPr lang="en-US" sz="1500" dirty="0"/>
           </a:p>
         </p:txBody>
       </p:sp>
@@ -5262,7 +5794,7 @@
                 <a:ea typeface="Cambria" pitchFamily="34" charset="-122"/>
                 <a:cs typeface="Cambria" pitchFamily="34" charset="-120"/>
               </a:rPr>
-              <a:t>Watch the agent work</a:t>
+              <a:t>One product: a verdict on every match</a:t>
             </a:r>
             <a:endParaRPr lang="en-US" sz="3000" dirty="0"/>
           </a:p>
@@ -5270,7 +5802,7 @@
       </p:sp>
       <p:pic>
         <p:nvPicPr>
-          <p:cNvPr id="3" name="Trace screenshot" descr="/private/tmp/claude-502/-Users-meenu-Downloads-D2/12731e38-32f4-44ab-831f-f37e8cc97cf7/scratchpad/shots/trace.png">    </p:cNvPr>
+          <p:cNvPr id="3" name="UI screenshot" descr="/private/tmp/claude-502/-Users-meenu-Downloads-D2/12731e38-32f4-44ab-831f-f37e8cc97cf7/scratchpad/shots/overview.png">    </p:cNvPr>
           <p:cNvPicPr>
             <a:picLocks noChangeAspect="1"/>
           </p:cNvPicPr>
@@ -5285,7 +5817,7 @@
         <p:spPr>
           <a:xfrm>
             <a:off x="548640" y="1325880"/>
-            <a:ext cx="8046720" cy="3235147"/>
+            <a:ext cx="4480560" cy="3520440"/>
           </a:xfrm>
           <a:prstGeom prst="rect">
             <a:avLst/>
@@ -5294,14 +5826,108 @@
       </p:pic>
       <p:sp>
         <p:nvSpPr>
-          <p:cNvPr id="4" name="Trace caption"/>
+          <p:cNvPr id="4" name="UI points"/>
           <p:cNvSpPr txBox="1"/>
           <p:nvPr/>
         </p:nvSpPr>
         <p:spPr>
           <a:xfrm>
-            <a:off x="548640" y="4572000"/>
-            <a:ext cx="8046720" cy="365760"/>
+            <a:off x="5394960" y="1463040"/>
+            <a:ext cx="3200400" cy="2377440"/>
+          </a:xfrm>
+          <a:prstGeom prst="rect">
+            <a:avLst/>
+          </a:prstGeom>
+          <a:noFill/>
+          <a:ln/>
+        </p:spPr>
+        <p:txBody>
+          <a:bodyPr wrap="square" lIns="0" tIns="0" rIns="0" bIns="0" rtlCol="0" anchor="t"/>
+          <a:lstStyle/>
+          <a:p>
+            <a:pPr marL="342900" indent="-342900">
+              <a:spcAft>
+                <a:spcPts val="1000"/>
+              </a:spcAft>
+              <a:buSzPct val="100000"/>
+              <a:buChar char="•"/>
+            </a:pPr>
+            <a:r>
+              <a:rPr lang="en-US" sz="1600" dirty="0">
+                <a:solidFill>
+                  <a:schemeClr val="tx1"/>
+                </a:solidFill>
+              </a:rPr>
+              <a:t>Plain-English request and budget</a:t>
+            </a:r>
+            <a:endParaRPr lang="en-US" sz="1600" dirty="0"/>
+          </a:p>
+          <a:p>
+            <a:pPr marL="342900" indent="-342900">
+              <a:spcAft>
+                <a:spcPts val="1000"/>
+              </a:spcAft>
+              <a:buSzPct val="100000"/>
+              <a:buChar char="•"/>
+            </a:pPr>
+            <a:r>
+              <a:rPr lang="en-US" sz="1600" dirty="0">
+                <a:solidFill>
+                  <a:schemeClr val="tx1"/>
+                </a:solidFill>
+              </a:rPr>
+              <a:t>Gemini builds the watch spec: category, budget, must-haves</a:t>
+            </a:r>
+            <a:endParaRPr lang="en-US" sz="1600" dirty="0"/>
+          </a:p>
+          <a:p>
+            <a:pPr marL="342900" indent="-342900">
+              <a:spcAft>
+                <a:spcPts val="1000"/>
+              </a:spcAft>
+              <a:buSzPct val="100000"/>
+              <a:buChar char="•"/>
+            </a:pPr>
+            <a:r>
+              <a:rPr lang="en-US" sz="1600" dirty="0">
+                <a:solidFill>
+                  <a:schemeClr val="tx1"/>
+                </a:solidFill>
+              </a:rPr>
+              <a:t>Every match gets Buy now or Wait, with reasons</a:t>
+            </a:r>
+            <a:endParaRPr lang="en-US" sz="1600" dirty="0"/>
+          </a:p>
+          <a:p>
+            <a:pPr marL="342900" indent="-342900">
+              <a:spcAft>
+                <a:spcPts val="1000"/>
+              </a:spcAft>
+              <a:buSzPct val="100000"/>
+              <a:buChar char="•"/>
+            </a:pPr>
+            <a:r>
+              <a:rPr lang="en-US" sz="1600" dirty="0">
+                <a:solidFill>
+                  <a:schemeClr val="tx1"/>
+                </a:solidFill>
+              </a:rPr>
+              <a:t>Fake discounts are counted and flagged</a:t>
+            </a:r>
+            <a:endParaRPr lang="en-US" sz="1600" dirty="0"/>
+          </a:p>
+        </p:txBody>
+      </p:sp>
+      <p:sp>
+        <p:nvSpPr>
+          <p:cNvPr id="5" name="UI caption"/>
+          <p:cNvSpPr txBox="1"/>
+          <p:nvPr/>
+        </p:nvSpPr>
+        <p:spPr>
+          <a:xfrm>
+            <a:off x="5394960" y="4343400"/>
+            <a:ext cx="3200400" cy="457200"/>
           </a:xfrm>
           <a:prstGeom prst="rect">
             <a:avLst/>
@@ -5317,14 +5943,14 @@
               <a:buNone/>
             </a:pPr>
             <a:r>
-              <a:rPr lang="en-US" sz="1400" dirty="0">
-                <a:solidFill>
-                  <a:schemeClr val="tx2"/>
-                </a:solidFill>
-              </a:rPr>
-              <a:t>Every line is a real step. It rules out products, checks price history and catches fake discounts as it goes.</a:t>
-            </a:r>
-            <a:endParaRPr lang="en-US" sz="1400" dirty="0"/>
+              <a:rPr lang="en-US" sz="1100" i="1" dirty="0">
+                <a:solidFill>
+                  <a:schemeClr val="accent4"/>
+                </a:solidFill>
+              </a:rPr>
+              <a:t>Screenshot of the working prototype, on test data</a:t>
+            </a:r>
+            <a:endParaRPr lang="en-US" sz="1100" dirty="0"/>
           </a:p>
         </p:txBody>
       </p:sp>
@@ -5433,250 +6059,69 @@
                 <a:ea typeface="Cambria" pitchFamily="34" charset="-122"/>
                 <a:cs typeface="Cambria" pitchFamily="34" charset="-120"/>
               </a:rPr>
-              <a:t>A 35% discount on a price that never moved</a:t>
+              <a:t>Watch the agent work</a:t>
             </a:r>
             <a:endParaRPr lang="en-US" sz="3000" dirty="0"/>
           </a:p>
         </p:txBody>
       </p:sp>
-      <p:graphicFrame>
-        <p:nvGraphicFramePr>
-          <p:cNvPr id="3" name="Chart 0" descr=""/>
-          <p:cNvGraphicFramePr/>
-          <p:nvPr/>
-        </p:nvGraphicFramePr>
-        <p:xfrm>
-          <a:off x="457200" y="1280160"/>
-          <a:ext cx="5394960" cy="3383280"/>
-        </p:xfrm>
-        <a:graphic xmlns:a="http://schemas.openxmlformats.org/drawingml/2006/main">
-          <a:graphicData uri="http://schemas.openxmlformats.org/drawingml/2006/chart">
-            <c:chart xmlns:c="http://schemas.openxmlformats.org/drawingml/2006/chart" r:id="rId1"/>
-          </a:graphicData>
-        </a:graphic>
-      </p:graphicFrame>
-      <p:sp>
-        <p:nvSpPr>
-          <p:cNvPr id="4" name="Fact label 1"/>
+      <p:pic>
+        <p:nvPicPr>
+          <p:cNvPr id="3" name="Trace screenshot" descr="/private/tmp/claude-502/-Users-meenu-Downloads-D2/12731e38-32f4-44ab-831f-f37e8cc97cf7/scratchpad/shots/trace.png">    </p:cNvPr>
+          <p:cNvPicPr>
+            <a:picLocks noChangeAspect="1"/>
+          </p:cNvPicPr>
+          <p:nvPr/>
+        </p:nvPicPr>
+        <p:blipFill>
+          <a:blip r:embed="rId1"/>
+          <a:stretch>
+            <a:fillRect/>
+          </a:stretch>
+        </p:blipFill>
+        <p:spPr>
+          <a:xfrm>
+            <a:off x="548640" y="1325880"/>
+            <a:ext cx="8046720" cy="3235147"/>
+          </a:xfrm>
+          <a:prstGeom prst="rect">
+            <a:avLst/>
+          </a:prstGeom>
+        </p:spPr>
+      </p:pic>
+      <p:sp>
+        <p:nvSpPr>
+          <p:cNvPr id="4" name="Trace caption"/>
           <p:cNvSpPr txBox="1"/>
           <p:nvPr/>
         </p:nvSpPr>
         <p:spPr>
           <a:xfrm>
-            <a:off x="6217920" y="1463040"/>
-            <a:ext cx="2377440" cy="228600"/>
-          </a:xfrm>
-          <a:prstGeom prst="rect">
-            <a:avLst/>
-          </a:prstGeom>
-          <a:noFill/>
-          <a:ln/>
-        </p:spPr>
-        <p:txBody>
-          <a:bodyPr wrap="square" lIns="0" tIns="0" rIns="0" bIns="0" rtlCol="0" anchor="ctr"/>
+            <a:off x="548640" y="4572000"/>
+            <a:ext cx="8046720" cy="365760"/>
+          </a:xfrm>
+          <a:prstGeom prst="rect">
+            <a:avLst/>
+          </a:prstGeom>
+          <a:noFill/>
+          <a:ln/>
+        </p:spPr>
+        <p:txBody>
+          <a:bodyPr wrap="square" lIns="0" tIns="0" rIns="0" bIns="0" rtlCol="0" anchor="t"/>
           <a:lstStyle/>
           <a:p>
             <a:pPr indent="0" marL="0">
               <a:buNone/>
             </a:pPr>
             <a:r>
-              <a:rPr lang="en-US" sz="1100" b="1" spc="200" kern="0" dirty="0">
-                <a:solidFill>
-                  <a:schemeClr val="accent4"/>
-                </a:solidFill>
-              </a:rPr>
-              <a:t>STORE CLAIMS</a:t>
-            </a:r>
-            <a:endParaRPr lang="en-US" sz="1100" dirty="0"/>
-          </a:p>
-        </p:txBody>
-      </p:sp>
-      <p:sp>
-        <p:nvSpPr>
-          <p:cNvPr id="5" name="Fact value 1"/>
-          <p:cNvSpPr txBox="1"/>
-          <p:nvPr/>
-        </p:nvSpPr>
-        <p:spPr>
-          <a:xfrm>
-            <a:off x="6217920" y="1719072"/>
-            <a:ext cx="2377440" cy="640080"/>
-          </a:xfrm>
-          <a:prstGeom prst="rect">
-            <a:avLst/>
-          </a:prstGeom>
-          <a:noFill/>
-          <a:ln/>
-        </p:spPr>
-        <p:txBody>
-          <a:bodyPr wrap="square" lIns="0" tIns="0" rIns="0" bIns="0" rtlCol="0" anchor="t"/>
-          <a:lstStyle/>
-          <a:p>
-            <a:pPr indent="0" marL="0">
-              <a:buNone/>
-            </a:pPr>
-            <a:r>
-              <a:rPr lang="en-US" sz="1800" b="1" dirty="0">
-                <a:solidFill>
-                  <a:schemeClr val="accent3"/>
-                </a:solidFill>
-                <a:latin typeface="Cambria" pitchFamily="34" charset="0"/>
-                <a:ea typeface="Cambria" pitchFamily="34" charset="-122"/>
-                <a:cs typeface="Cambria" pitchFamily="34" charset="-120"/>
-              </a:rPr>
-              <a:t>35% off ₹12,999</a:t>
-            </a:r>
-            <a:endParaRPr lang="en-US" sz="1800" dirty="0"/>
-          </a:p>
-        </p:txBody>
-      </p:sp>
-      <p:sp>
-        <p:nvSpPr>
-          <p:cNvPr id="6" name="Fact label 2"/>
-          <p:cNvSpPr txBox="1"/>
-          <p:nvPr/>
-        </p:nvSpPr>
-        <p:spPr>
-          <a:xfrm>
-            <a:off x="6217920" y="2514600"/>
-            <a:ext cx="2377440" cy="228600"/>
-          </a:xfrm>
-          <a:prstGeom prst="rect">
-            <a:avLst/>
-          </a:prstGeom>
-          <a:noFill/>
-          <a:ln/>
-        </p:spPr>
-        <p:txBody>
-          <a:bodyPr wrap="square" lIns="0" tIns="0" rIns="0" bIns="0" rtlCol="0" anchor="ctr"/>
-          <a:lstStyle/>
-          <a:p>
-            <a:pPr indent="0" marL="0">
-              <a:buNone/>
-            </a:pPr>
-            <a:r>
-              <a:rPr lang="en-US" sz="1100" b="1" spc="200" kern="0" dirty="0">
-                <a:solidFill>
-                  <a:schemeClr val="accent4"/>
-                </a:solidFill>
-              </a:rPr>
-              <a:t>REALITY</a:t>
-            </a:r>
-            <a:endParaRPr lang="en-US" sz="1100" dirty="0"/>
-          </a:p>
-        </p:txBody>
-      </p:sp>
-      <p:sp>
-        <p:nvSpPr>
-          <p:cNvPr id="7" name="Fact value 2"/>
-          <p:cNvSpPr txBox="1"/>
-          <p:nvPr/>
-        </p:nvSpPr>
-        <p:spPr>
-          <a:xfrm>
-            <a:off x="6217920" y="2770632"/>
-            <a:ext cx="2377440" cy="640080"/>
-          </a:xfrm>
-          <a:prstGeom prst="rect">
-            <a:avLst/>
-          </a:prstGeom>
-          <a:noFill/>
-          <a:ln/>
-        </p:spPr>
-        <p:txBody>
-          <a:bodyPr wrap="square" lIns="0" tIns="0" rIns="0" bIns="0" rtlCol="0" anchor="t"/>
-          <a:lstStyle/>
-          <a:p>
-            <a:pPr indent="0" marL="0">
-              <a:buNone/>
-            </a:pPr>
-            <a:r>
-              <a:rPr lang="en-US" sz="1800" b="1" dirty="0">
-                <a:solidFill>
-                  <a:schemeClr val="tx1"/>
-                </a:solidFill>
-                <a:latin typeface="Cambria" pitchFamily="34" charset="0"/>
-                <a:ea typeface="Cambria" pitchFamily="34" charset="-122"/>
-                <a:cs typeface="Cambria" pitchFamily="34" charset="-120"/>
-              </a:rPr>
-              <a:t>₹8,199 to ₹8,699 for 60 days</a:t>
-            </a:r>
-            <a:endParaRPr lang="en-US" sz="1800" dirty="0"/>
-          </a:p>
-        </p:txBody>
-      </p:sp>
-      <p:sp>
-        <p:nvSpPr>
-          <p:cNvPr id="8" name="Fact label 3"/>
-          <p:cNvSpPr txBox="1"/>
-          <p:nvPr/>
-        </p:nvSpPr>
-        <p:spPr>
-          <a:xfrm>
-            <a:off x="6217920" y="3566160"/>
-            <a:ext cx="2377440" cy="228600"/>
-          </a:xfrm>
-          <a:prstGeom prst="rect">
-            <a:avLst/>
-          </a:prstGeom>
-          <a:noFill/>
-          <a:ln/>
-        </p:spPr>
-        <p:txBody>
-          <a:bodyPr wrap="square" lIns="0" tIns="0" rIns="0" bIns="0" rtlCol="0" anchor="ctr"/>
-          <a:lstStyle/>
-          <a:p>
-            <a:pPr indent="0" marL="0">
-              <a:buNone/>
-            </a:pPr>
-            <a:r>
-              <a:rPr lang="en-US" sz="1100" b="1" spc="200" kern="0" dirty="0">
-                <a:solidFill>
-                  <a:schemeClr val="accent4"/>
-                </a:solidFill>
-              </a:rPr>
-              <a:t>DEALSCOUT SAYS</a:t>
-            </a:r>
-            <a:endParaRPr lang="en-US" sz="1100" dirty="0"/>
-          </a:p>
-        </p:txBody>
-      </p:sp>
-      <p:sp>
-        <p:nvSpPr>
-          <p:cNvPr id="9" name="Fact value 3"/>
-          <p:cNvSpPr txBox="1"/>
-          <p:nvPr/>
-        </p:nvSpPr>
-        <p:spPr>
-          <a:xfrm>
-            <a:off x="6217920" y="3822192"/>
-            <a:ext cx="2377440" cy="640080"/>
-          </a:xfrm>
-          <a:prstGeom prst="rect">
-            <a:avLst/>
-          </a:prstGeom>
-          <a:noFill/>
-          <a:ln/>
-        </p:spPr>
-        <p:txBody>
-          <a:bodyPr wrap="square" lIns="0" tIns="0" rIns="0" bIns="0" rtlCol="0" anchor="t"/>
-          <a:lstStyle/>
-          <a:p>
-            <a:pPr indent="0" marL="0">
-              <a:buNone/>
-            </a:pPr>
-            <a:r>
-              <a:rPr lang="en-US" sz="1800" b="1" dirty="0">
-                <a:solidFill>
-                  <a:schemeClr val="accent1"/>
-                </a:solidFill>
-                <a:latin typeface="Cambria" pitchFamily="34" charset="0"/>
-                <a:ea typeface="Cambria" pitchFamily="34" charset="-122"/>
-                <a:cs typeface="Cambria" pitchFamily="34" charset="-120"/>
-              </a:rPr>
-              <a:t>Wait. Not a real deal.</a:t>
-            </a:r>
-            <a:endParaRPr lang="en-US" sz="1800" dirty="0"/>
+              <a:rPr lang="en-US" sz="1400" dirty="0">
+                <a:solidFill>
+                  <a:schemeClr val="tx2"/>
+                </a:solidFill>
+              </a:rPr>
+              <a:t>Every line is a real step. It rules out products, checks price history and catches fake discounts as it goes.</a:t>
+            </a:r>
+            <a:endParaRPr lang="en-US" sz="1400" dirty="0"/>
           </a:p>
         </p:txBody>
       </p:sp>
@@ -5785,69 +6230,250 @@
                 <a:ea typeface="Cambria" pitchFamily="34" charset="-122"/>
                 <a:cs typeface="Cambria" pitchFamily="34" charset="-120"/>
               </a:rPr>
-              <a:t>It checks the fit, not only the price</a:t>
+              <a:t>A 35% discount on a price that never moved</a:t>
             </a:r>
             <a:endParaRPr lang="en-US" sz="3000" dirty="0"/>
           </a:p>
         </p:txBody>
       </p:sp>
-      <p:pic>
-        <p:nvPicPr>
-          <p:cNvPr id="3" name="Fit screenshot" descr="/private/tmp/claude-502/-Users-meenu-Downloads-D2/12731e38-32f4-44ab-831f-f37e8cc97cf7/scratchpad/shots/fit.png">    </p:cNvPr>
-          <p:cNvPicPr>
-            <a:picLocks noChangeAspect="1"/>
-          </p:cNvPicPr>
-          <p:nvPr/>
-        </p:nvPicPr>
-        <p:blipFill>
-          <a:blip r:embed="rId1"/>
-          <a:stretch>
-            <a:fillRect/>
-          </a:stretch>
-        </p:blipFill>
-        <p:spPr>
-          <a:xfrm>
-            <a:off x="548640" y="1325880"/>
-            <a:ext cx="8046720" cy="2697480"/>
-          </a:xfrm>
-          <a:prstGeom prst="rect">
-            <a:avLst/>
-          </a:prstGeom>
-        </p:spPr>
-      </p:pic>
-      <p:sp>
-        <p:nvSpPr>
-          <p:cNvPr id="4" name="Fit caption"/>
+      <p:graphicFrame>
+        <p:nvGraphicFramePr>
+          <p:cNvPr id="3" name="Chart 0" descr=""/>
+          <p:cNvGraphicFramePr/>
+          <p:nvPr/>
+        </p:nvGraphicFramePr>
+        <p:xfrm>
+          <a:off x="457200" y="1280160"/>
+          <a:ext cx="5394960" cy="3383280"/>
+        </p:xfrm>
+        <a:graphic xmlns:a="http://schemas.openxmlformats.org/drawingml/2006/main">
+          <a:graphicData uri="http://schemas.openxmlformats.org/drawingml/2006/chart">
+            <c:chart xmlns:c="http://schemas.openxmlformats.org/drawingml/2006/chart" r:id="rId1"/>
+          </a:graphicData>
+        </a:graphic>
+      </p:graphicFrame>
+      <p:sp>
+        <p:nvSpPr>
+          <p:cNvPr id="4" name="Fact label 1"/>
           <p:cNvSpPr txBox="1"/>
           <p:nvPr/>
         </p:nvSpPr>
         <p:spPr>
           <a:xfrm>
-            <a:off x="548640" y="4206240"/>
-            <a:ext cx="8046720" cy="548640"/>
-          </a:xfrm>
-          <a:prstGeom prst="rect">
-            <a:avLst/>
-          </a:prstGeom>
-          <a:noFill/>
-          <a:ln/>
-        </p:spPr>
-        <p:txBody>
-          <a:bodyPr wrap="square" lIns="0" tIns="0" rIns="0" bIns="0" rtlCol="0" anchor="t"/>
+            <a:off x="6217920" y="1463040"/>
+            <a:ext cx="2377440" cy="228600"/>
+          </a:xfrm>
+          <a:prstGeom prst="rect">
+            <a:avLst/>
+          </a:prstGeom>
+          <a:noFill/>
+          <a:ln/>
+        </p:spPr>
+        <p:txBody>
+          <a:bodyPr wrap="square" lIns="0" tIns="0" rIns="0" bIns="0" rtlCol="0" anchor="ctr"/>
           <a:lstStyle/>
           <a:p>
             <a:pPr indent="0" marL="0">
               <a:buNone/>
             </a:pPr>
             <a:r>
-              <a:rPr lang="en-US" sz="1600" dirty="0">
+              <a:rPr lang="en-US" sz="1100" b="1" spc="200" kern="0" dirty="0">
+                <a:solidFill>
+                  <a:schemeClr val="accent4"/>
+                </a:solidFill>
+              </a:rPr>
+              <a:t>STORE CLAIMS</a:t>
+            </a:r>
+            <a:endParaRPr lang="en-US" sz="1100" dirty="0"/>
+          </a:p>
+        </p:txBody>
+      </p:sp>
+      <p:sp>
+        <p:nvSpPr>
+          <p:cNvPr id="5" name="Fact value 1"/>
+          <p:cNvSpPr txBox="1"/>
+          <p:nvPr/>
+        </p:nvSpPr>
+        <p:spPr>
+          <a:xfrm>
+            <a:off x="6217920" y="1719072"/>
+            <a:ext cx="2377440" cy="640080"/>
+          </a:xfrm>
+          <a:prstGeom prst="rect">
+            <a:avLst/>
+          </a:prstGeom>
+          <a:noFill/>
+          <a:ln/>
+        </p:spPr>
+        <p:txBody>
+          <a:bodyPr wrap="square" lIns="0" tIns="0" rIns="0" bIns="0" rtlCol="0" anchor="t"/>
+          <a:lstStyle/>
+          <a:p>
+            <a:pPr indent="0" marL="0">
+              <a:buNone/>
+            </a:pPr>
+            <a:r>
+              <a:rPr lang="en-US" sz="1800" b="1" dirty="0">
+                <a:solidFill>
+                  <a:schemeClr val="accent3"/>
+                </a:solidFill>
+                <a:latin typeface="Cambria" pitchFamily="34" charset="0"/>
+                <a:ea typeface="Cambria" pitchFamily="34" charset="-122"/>
+                <a:cs typeface="Cambria" pitchFamily="34" charset="-120"/>
+              </a:rPr>
+              <a:t>35% off ₹12,999</a:t>
+            </a:r>
+            <a:endParaRPr lang="en-US" sz="1800" dirty="0"/>
+          </a:p>
+        </p:txBody>
+      </p:sp>
+      <p:sp>
+        <p:nvSpPr>
+          <p:cNvPr id="6" name="Fact label 2"/>
+          <p:cNvSpPr txBox="1"/>
+          <p:nvPr/>
+        </p:nvSpPr>
+        <p:spPr>
+          <a:xfrm>
+            <a:off x="6217920" y="2514600"/>
+            <a:ext cx="2377440" cy="228600"/>
+          </a:xfrm>
+          <a:prstGeom prst="rect">
+            <a:avLst/>
+          </a:prstGeom>
+          <a:noFill/>
+          <a:ln/>
+        </p:spPr>
+        <p:txBody>
+          <a:bodyPr wrap="square" lIns="0" tIns="0" rIns="0" bIns="0" rtlCol="0" anchor="ctr"/>
+          <a:lstStyle/>
+          <a:p>
+            <a:pPr indent="0" marL="0">
+              <a:buNone/>
+            </a:pPr>
+            <a:r>
+              <a:rPr lang="en-US" sz="1100" b="1" spc="200" kern="0" dirty="0">
+                <a:solidFill>
+                  <a:schemeClr val="accent4"/>
+                </a:solidFill>
+              </a:rPr>
+              <a:t>REALITY</a:t>
+            </a:r>
+            <a:endParaRPr lang="en-US" sz="1100" dirty="0"/>
+          </a:p>
+        </p:txBody>
+      </p:sp>
+      <p:sp>
+        <p:nvSpPr>
+          <p:cNvPr id="7" name="Fact value 2"/>
+          <p:cNvSpPr txBox="1"/>
+          <p:nvPr/>
+        </p:nvSpPr>
+        <p:spPr>
+          <a:xfrm>
+            <a:off x="6217920" y="2770632"/>
+            <a:ext cx="2377440" cy="640080"/>
+          </a:xfrm>
+          <a:prstGeom prst="rect">
+            <a:avLst/>
+          </a:prstGeom>
+          <a:noFill/>
+          <a:ln/>
+        </p:spPr>
+        <p:txBody>
+          <a:bodyPr wrap="square" lIns="0" tIns="0" rIns="0" bIns="0" rtlCol="0" anchor="t"/>
+          <a:lstStyle/>
+          <a:p>
+            <a:pPr indent="0" marL="0">
+              <a:buNone/>
+            </a:pPr>
+            <a:r>
+              <a:rPr lang="en-US" sz="1800" b="1" dirty="0">
                 <a:solidFill>
                   <a:schemeClr val="tx1"/>
                 </a:solidFill>
-              </a:rPr>
-              <a:t>Asked for 2 inputs, this one has 4. DealScout shows the extra cost against the cheapest model that already covers the need.</a:t>
-            </a:r>
-            <a:endParaRPr lang="en-US" sz="1600" dirty="0"/>
+                <a:latin typeface="Cambria" pitchFamily="34" charset="0"/>
+                <a:ea typeface="Cambria" pitchFamily="34" charset="-122"/>
+                <a:cs typeface="Cambria" pitchFamily="34" charset="-120"/>
+              </a:rPr>
+              <a:t>₹8,199 to ₹8,699 for 60 days</a:t>
+            </a:r>
+            <a:endParaRPr lang="en-US" sz="1800" dirty="0"/>
+          </a:p>
+        </p:txBody>
+      </p:sp>
+      <p:sp>
+        <p:nvSpPr>
+          <p:cNvPr id="8" name="Fact label 3"/>
+          <p:cNvSpPr txBox="1"/>
+          <p:nvPr/>
+        </p:nvSpPr>
+        <p:spPr>
+          <a:xfrm>
+            <a:off x="6217920" y="3566160"/>
+            <a:ext cx="2377440" cy="228600"/>
+          </a:xfrm>
+          <a:prstGeom prst="rect">
+            <a:avLst/>
+          </a:prstGeom>
+          <a:noFill/>
+          <a:ln/>
+        </p:spPr>
+        <p:txBody>
+          <a:bodyPr wrap="square" lIns="0" tIns="0" rIns="0" bIns="0" rtlCol="0" anchor="ctr"/>
+          <a:lstStyle/>
+          <a:p>
+            <a:pPr indent="0" marL="0">
+              <a:buNone/>
+            </a:pPr>
+            <a:r>
+              <a:rPr lang="en-US" sz="1100" b="1" spc="200" kern="0" dirty="0">
+                <a:solidFill>
+                  <a:schemeClr val="accent4"/>
+                </a:solidFill>
+              </a:rPr>
+              <a:t>DEALSCOUT SAYS</a:t>
+            </a:r>
+            <a:endParaRPr lang="en-US" sz="1100" dirty="0"/>
+          </a:p>
+        </p:txBody>
+      </p:sp>
+      <p:sp>
+        <p:nvSpPr>
+          <p:cNvPr id="9" name="Fact value 3"/>
+          <p:cNvSpPr txBox="1"/>
+          <p:nvPr/>
+        </p:nvSpPr>
+        <p:spPr>
+          <a:xfrm>
+            <a:off x="6217920" y="3822192"/>
+            <a:ext cx="2377440" cy="640080"/>
+          </a:xfrm>
+          <a:prstGeom prst="rect">
+            <a:avLst/>
+          </a:prstGeom>
+          <a:noFill/>
+          <a:ln/>
+        </p:spPr>
+        <p:txBody>
+          <a:bodyPr wrap="square" lIns="0" tIns="0" rIns="0" bIns="0" rtlCol="0" anchor="t"/>
+          <a:lstStyle/>
+          <a:p>
+            <a:pPr indent="0" marL="0">
+              <a:buNone/>
+            </a:pPr>
+            <a:r>
+              <a:rPr lang="en-US" sz="1800" b="1" dirty="0">
+                <a:solidFill>
+                  <a:schemeClr val="accent1"/>
+                </a:solidFill>
+                <a:latin typeface="Cambria" pitchFamily="34" charset="0"/>
+                <a:ea typeface="Cambria" pitchFamily="34" charset="-122"/>
+                <a:cs typeface="Cambria" pitchFamily="34" charset="-120"/>
+              </a:rPr>
+              <a:t>Wait. Not a real deal.</a:t>
+            </a:r>
+            <a:endParaRPr lang="en-US" sz="1800" dirty="0"/>
           </a:p>
         </p:txBody>
       </p:sp>
@@ -5956,900 +6582,69 @@
                 <a:ea typeface="Cambria" pitchFamily="34" charset="-122"/>
                 <a:cs typeface="Cambria" pitchFamily="34" charset="-120"/>
               </a:rPr>
-              <a:t>Built on Gemini and Google Cloud</a:t>
+              <a:t>It checks the fit, not only the price</a:t>
             </a:r>
             <a:endParaRPr lang="en-US" sz="3000" dirty="0"/>
           </a:p>
         </p:txBody>
       </p:sp>
-      <p:sp>
-        <p:nvSpPr>
-          <p:cNvPr id="3" name="Box Cloud Scheduler"/>
-          <p:cNvSpPr/>
-          <p:nvPr/>
-        </p:nvSpPr>
-        <p:spPr>
-          <a:xfrm>
-            <a:off x="548640" y="1600200"/>
-            <a:ext cx="1463040" cy="1828800"/>
-          </a:xfrm>
-          <a:prstGeom prst="roundRect">
-            <a:avLst>
-              <a:gd name="adj" fmla="val 5000"/>
-            </a:avLst>
-          </a:prstGeom>
-          <a:solidFill>
-            <a:schemeClr val="bg2"/>
-          </a:solidFill>
-          <a:ln w="12700">
-            <a:solidFill>
-              <a:schemeClr val="bg2"/>
-            </a:solidFill>
-            <a:prstDash val="solid"/>
-          </a:ln>
-        </p:spPr>
-      </p:sp>
-      <p:sp>
-        <p:nvSpPr>
-          <p:cNvPr id="4" name="Box title Cloud Scheduler"/>
+      <p:pic>
+        <p:nvPicPr>
+          <p:cNvPr id="3" name="Fit screenshot" descr="/private/tmp/claude-502/-Users-meenu-Downloads-D2/12731e38-32f4-44ab-831f-f37e8cc97cf7/scratchpad/shots/fit.png">    </p:cNvPr>
+          <p:cNvPicPr>
+            <a:picLocks noChangeAspect="1"/>
+          </p:cNvPicPr>
+          <p:nvPr/>
+        </p:nvPicPr>
+        <p:blipFill>
+          <a:blip r:embed="rId1"/>
+          <a:stretch>
+            <a:fillRect/>
+          </a:stretch>
+        </p:blipFill>
+        <p:spPr>
+          <a:xfrm>
+            <a:off x="548640" y="1325880"/>
+            <a:ext cx="8046720" cy="2697480"/>
+          </a:xfrm>
+          <a:prstGeom prst="rect">
+            <a:avLst/>
+          </a:prstGeom>
+        </p:spPr>
+      </p:pic>
+      <p:sp>
+        <p:nvSpPr>
+          <p:cNvPr id="4" name="Fit caption"/>
           <p:cNvSpPr txBox="1"/>
           <p:nvPr/>
         </p:nvSpPr>
         <p:spPr>
           <a:xfrm>
-            <a:off x="685800" y="1783080"/>
-            <a:ext cx="1188720" cy="320040"/>
-          </a:xfrm>
-          <a:prstGeom prst="rect">
-            <a:avLst/>
-          </a:prstGeom>
-          <a:noFill/>
-          <a:ln/>
-        </p:spPr>
-        <p:txBody>
-          <a:bodyPr wrap="square" lIns="0" tIns="0" rIns="0" bIns="0" rtlCol="0" anchor="ctr"/>
+            <a:off x="548640" y="4206240"/>
+            <a:ext cx="8046720" cy="548640"/>
+          </a:xfrm>
+          <a:prstGeom prst="rect">
+            <a:avLst/>
+          </a:prstGeom>
+          <a:noFill/>
+          <a:ln/>
+        </p:spPr>
+        <p:txBody>
+          <a:bodyPr wrap="square" lIns="0" tIns="0" rIns="0" bIns="0" rtlCol="0" anchor="t"/>
           <a:lstStyle/>
           <a:p>
             <a:pPr indent="0" marL="0">
               <a:buNone/>
             </a:pPr>
             <a:r>
-              <a:rPr lang="en-US" sz="1500" b="1" dirty="0">
+              <a:rPr lang="en-US" sz="1600" dirty="0">
                 <a:solidFill>
                   <a:schemeClr val="tx1"/>
                 </a:solidFill>
               </a:rPr>
-              <a:t>Cloud Scheduler</a:t>
-            </a:r>
-            <a:endParaRPr lang="en-US" sz="1500" dirty="0"/>
-          </a:p>
-        </p:txBody>
-      </p:sp>
-      <p:sp>
-        <p:nvSpPr>
-          <p:cNvPr id="5" name="Box body Cloud Scheduler"/>
-          <p:cNvSpPr txBox="1"/>
-          <p:nvPr/>
-        </p:nvSpPr>
-        <p:spPr>
-          <a:xfrm>
-            <a:off x="685800" y="2194560"/>
-            <a:ext cx="1188720" cy="777240"/>
-          </a:xfrm>
-          <a:prstGeom prst="rect">
-            <a:avLst/>
-          </a:prstGeom>
-          <a:noFill/>
-          <a:ln/>
-        </p:spPr>
-        <p:txBody>
-          <a:bodyPr wrap="square" lIns="0" tIns="0" rIns="0" bIns="0" rtlCol="0" anchor="t"/>
-          <a:lstStyle/>
-          <a:p>
-            <a:pPr indent="0" marL="0">
-              <a:buNone/>
-            </a:pPr>
-            <a:r>
-              <a:rPr lang="en-US" sz="1200" dirty="0">
-                <a:solidFill>
-                  <a:schemeClr val="tx2"/>
-                </a:solidFill>
-              </a:rPr>
-              <a:t>Triggers the daily run</a:t>
-            </a:r>
-            <a:endParaRPr lang="en-US" sz="1200" dirty="0"/>
-          </a:p>
-        </p:txBody>
-      </p:sp>
-      <p:sp>
-        <p:nvSpPr>
-          <p:cNvPr id="6" name="Box status Cloud Scheduler"/>
-          <p:cNvSpPr txBox="1"/>
-          <p:nvPr/>
-        </p:nvSpPr>
-        <p:spPr>
-          <a:xfrm>
-            <a:off x="685800" y="3063240"/>
-            <a:ext cx="1188720" cy="228600"/>
-          </a:xfrm>
-          <a:prstGeom prst="rect">
-            <a:avLst/>
-          </a:prstGeom>
-          <a:noFill/>
-          <a:ln/>
-        </p:spPr>
-        <p:txBody>
-          <a:bodyPr wrap="square" lIns="0" tIns="0" rIns="0" bIns="0" rtlCol="0" anchor="ctr"/>
-          <a:lstStyle/>
-          <a:p>
-            <a:pPr indent="0" marL="0">
-              <a:buNone/>
-            </a:pPr>
-            <a:r>
-              <a:rPr lang="en-US" sz="1100" b="1" spc="200" kern="0" dirty="0">
-                <a:solidFill>
-                  <a:schemeClr val="accent2"/>
-                </a:solidFill>
-              </a:rPr>
-              <a:t>NEXT</a:t>
-            </a:r>
-            <a:endParaRPr lang="en-US" sz="1100" dirty="0"/>
-          </a:p>
-        </p:txBody>
-      </p:sp>
-      <p:sp>
-        <p:nvSpPr>
-          <p:cNvPr id="7" name="Arrow 1"/>
-          <p:cNvSpPr txBox="1"/>
-          <p:nvPr/>
-        </p:nvSpPr>
-        <p:spPr>
-          <a:xfrm>
-            <a:off x="2011680" y="2240280"/>
-            <a:ext cx="164592" cy="365760"/>
-          </a:xfrm>
-          <a:prstGeom prst="rect">
-            <a:avLst/>
-          </a:prstGeom>
-          <a:noFill/>
-          <a:ln/>
-        </p:spPr>
-        <p:txBody>
-          <a:bodyPr wrap="square" lIns="0" tIns="0" rIns="0" bIns="0" rtlCol="0" anchor="ctr"/>
-          <a:lstStyle/>
-          <a:p>
-            <a:pPr algn="ctr" indent="0" marL="0">
-              <a:buNone/>
-            </a:pPr>
-            <a:r>
-              <a:rPr lang="en-US" sz="1800" dirty="0">
-                <a:solidFill>
-                  <a:schemeClr val="accent4"/>
-                </a:solidFill>
-              </a:rPr>
-              <a:t>→</a:t>
-            </a:r>
-            <a:endParaRPr lang="en-US" sz="1800" dirty="0"/>
-          </a:p>
-        </p:txBody>
-      </p:sp>
-      <p:sp>
-        <p:nvSpPr>
-          <p:cNvPr id="8" name="Box Cloud Run"/>
-          <p:cNvSpPr/>
-          <p:nvPr/>
-        </p:nvSpPr>
-        <p:spPr>
-          <a:xfrm>
-            <a:off x="2176272" y="1600200"/>
-            <a:ext cx="1463040" cy="1828800"/>
-          </a:xfrm>
-          <a:prstGeom prst="roundRect">
-            <a:avLst>
-              <a:gd name="adj" fmla="val 5000"/>
-            </a:avLst>
-          </a:prstGeom>
-          <a:solidFill>
-            <a:schemeClr val="bg2"/>
-          </a:solidFill>
-          <a:ln w="12700">
-            <a:solidFill>
-              <a:schemeClr val="bg2"/>
-            </a:solidFill>
-            <a:prstDash val="solid"/>
-          </a:ln>
-        </p:spPr>
-      </p:sp>
-      <p:sp>
-        <p:nvSpPr>
-          <p:cNvPr id="9" name="Box title Cloud Run"/>
-          <p:cNvSpPr txBox="1"/>
-          <p:nvPr/>
-        </p:nvSpPr>
-        <p:spPr>
-          <a:xfrm>
-            <a:off x="2313432" y="1783080"/>
-            <a:ext cx="1188720" cy="320040"/>
-          </a:xfrm>
-          <a:prstGeom prst="rect">
-            <a:avLst/>
-          </a:prstGeom>
-          <a:noFill/>
-          <a:ln/>
-        </p:spPr>
-        <p:txBody>
-          <a:bodyPr wrap="square" lIns="0" tIns="0" rIns="0" bIns="0" rtlCol="0" anchor="ctr"/>
-          <a:lstStyle/>
-          <a:p>
-            <a:pPr indent="0" marL="0">
-              <a:buNone/>
-            </a:pPr>
-            <a:r>
-              <a:rPr lang="en-US" sz="1500" b="1" dirty="0">
-                <a:solidFill>
-                  <a:schemeClr val="tx1"/>
-                </a:solidFill>
-              </a:rPr>
-              <a:t>Cloud Run</a:t>
-            </a:r>
-            <a:endParaRPr lang="en-US" sz="1500" dirty="0"/>
-          </a:p>
-        </p:txBody>
-      </p:sp>
-      <p:sp>
-        <p:nvSpPr>
-          <p:cNvPr id="10" name="Box body Cloud Run"/>
-          <p:cNvSpPr txBox="1"/>
-          <p:nvPr/>
-        </p:nvSpPr>
-        <p:spPr>
-          <a:xfrm>
-            <a:off x="2313432" y="2194560"/>
-            <a:ext cx="1188720" cy="777240"/>
-          </a:xfrm>
-          <a:prstGeom prst="rect">
-            <a:avLst/>
-          </a:prstGeom>
-          <a:noFill/>
-          <a:ln/>
-        </p:spPr>
-        <p:txBody>
-          <a:bodyPr wrap="square" lIns="0" tIns="0" rIns="0" bIns="0" rtlCol="0" anchor="t"/>
-          <a:lstStyle/>
-          <a:p>
-            <a:pPr indent="0" marL="0">
-              <a:buNone/>
-            </a:pPr>
-            <a:r>
-              <a:rPr lang="en-US" sz="1200" dirty="0">
-                <a:solidFill>
-                  <a:schemeClr val="tx2"/>
-                </a:solidFill>
-              </a:rPr>
-              <a:t>Runs the scout service</a:t>
-            </a:r>
-            <a:endParaRPr lang="en-US" sz="1200" dirty="0"/>
-          </a:p>
-        </p:txBody>
-      </p:sp>
-      <p:sp>
-        <p:nvSpPr>
-          <p:cNvPr id="11" name="Box status Cloud Run"/>
-          <p:cNvSpPr txBox="1"/>
-          <p:nvPr/>
-        </p:nvSpPr>
-        <p:spPr>
-          <a:xfrm>
-            <a:off x="2313432" y="3063240"/>
-            <a:ext cx="1188720" cy="228600"/>
-          </a:xfrm>
-          <a:prstGeom prst="rect">
-            <a:avLst/>
-          </a:prstGeom>
-          <a:noFill/>
-          <a:ln/>
-        </p:spPr>
-        <p:txBody>
-          <a:bodyPr wrap="square" lIns="0" tIns="0" rIns="0" bIns="0" rtlCol="0" anchor="ctr"/>
-          <a:lstStyle/>
-          <a:p>
-            <a:pPr indent="0" marL="0">
-              <a:buNone/>
-            </a:pPr>
-            <a:r>
-              <a:rPr lang="en-US" sz="1100" b="1" spc="200" kern="0" dirty="0">
-                <a:solidFill>
-                  <a:schemeClr val="accent2"/>
-                </a:solidFill>
-              </a:rPr>
-              <a:t>NEXT</a:t>
-            </a:r>
-            <a:endParaRPr lang="en-US" sz="1100" dirty="0"/>
-          </a:p>
-        </p:txBody>
-      </p:sp>
-      <p:sp>
-        <p:nvSpPr>
-          <p:cNvPr id="12" name="Arrow 2"/>
-          <p:cNvSpPr txBox="1"/>
-          <p:nvPr/>
-        </p:nvSpPr>
-        <p:spPr>
-          <a:xfrm>
-            <a:off x="3639312" y="2240280"/>
-            <a:ext cx="164592" cy="365760"/>
-          </a:xfrm>
-          <a:prstGeom prst="rect">
-            <a:avLst/>
-          </a:prstGeom>
-          <a:noFill/>
-          <a:ln/>
-        </p:spPr>
-        <p:txBody>
-          <a:bodyPr wrap="square" lIns="0" tIns="0" rIns="0" bIns="0" rtlCol="0" anchor="ctr"/>
-          <a:lstStyle/>
-          <a:p>
-            <a:pPr algn="ctr" indent="0" marL="0">
-              <a:buNone/>
-            </a:pPr>
-            <a:r>
-              <a:rPr lang="en-US" sz="1800" dirty="0">
-                <a:solidFill>
-                  <a:schemeClr val="accent4"/>
-                </a:solidFill>
-              </a:rPr>
-              <a:t>→</a:t>
-            </a:r>
-            <a:endParaRPr lang="en-US" sz="1800" dirty="0"/>
-          </a:p>
-        </p:txBody>
-      </p:sp>
-      <p:sp>
-        <p:nvSpPr>
-          <p:cNvPr id="13" name="Box Gemini"/>
-          <p:cNvSpPr/>
-          <p:nvPr/>
-        </p:nvSpPr>
-        <p:spPr>
-          <a:xfrm>
-            <a:off x="3803904" y="1600200"/>
-            <a:ext cx="1463040" cy="1828800"/>
-          </a:xfrm>
-          <a:prstGeom prst="roundRect">
-            <a:avLst>
-              <a:gd name="adj" fmla="val 5000"/>
-            </a:avLst>
-          </a:prstGeom>
-          <a:solidFill>
-            <a:schemeClr val="accent1"/>
-          </a:solidFill>
-          <a:ln w="12700">
-            <a:solidFill>
-              <a:schemeClr val="accent1"/>
-            </a:solidFill>
-            <a:prstDash val="solid"/>
-          </a:ln>
-        </p:spPr>
-      </p:sp>
-      <p:sp>
-        <p:nvSpPr>
-          <p:cNvPr id="14" name="Box title Gemini"/>
-          <p:cNvSpPr txBox="1"/>
-          <p:nvPr/>
-        </p:nvSpPr>
-        <p:spPr>
-          <a:xfrm>
-            <a:off x="3941064" y="1783080"/>
-            <a:ext cx="1188720" cy="320040"/>
-          </a:xfrm>
-          <a:prstGeom prst="rect">
-            <a:avLst/>
-          </a:prstGeom>
-          <a:noFill/>
-          <a:ln/>
-        </p:spPr>
-        <p:txBody>
-          <a:bodyPr wrap="square" lIns="0" tIns="0" rIns="0" bIns="0" rtlCol="0" anchor="ctr"/>
-          <a:lstStyle/>
-          <a:p>
-            <a:pPr indent="0" marL="0">
-              <a:buNone/>
-            </a:pPr>
-            <a:r>
-              <a:rPr lang="en-US" sz="1500" b="1" dirty="0">
-                <a:solidFill>
-                  <a:schemeClr val="bg1"/>
-                </a:solidFill>
-              </a:rPr>
-              <a:t>Gemini</a:t>
-            </a:r>
-            <a:endParaRPr lang="en-US" sz="1500" dirty="0"/>
-          </a:p>
-        </p:txBody>
-      </p:sp>
-      <p:sp>
-        <p:nvSpPr>
-          <p:cNvPr id="15" name="Box body Gemini"/>
-          <p:cNvSpPr txBox="1"/>
-          <p:nvPr/>
-        </p:nvSpPr>
-        <p:spPr>
-          <a:xfrm>
-            <a:off x="3941064" y="2194560"/>
-            <a:ext cx="1188720" cy="777240"/>
-          </a:xfrm>
-          <a:prstGeom prst="rect">
-            <a:avLst/>
-          </a:prstGeom>
-          <a:noFill/>
-          <a:ln/>
-        </p:spPr>
-        <p:txBody>
-          <a:bodyPr wrap="square" lIns="0" tIns="0" rIns="0" bIns="0" rtlCol="0" anchor="t"/>
-          <a:lstStyle/>
-          <a:p>
-            <a:pPr indent="0" marL="0">
-              <a:buNone/>
-            </a:pPr>
-            <a:r>
-              <a:rPr lang="en-US" sz="1200" dirty="0">
-                <a:solidFill>
-                  <a:schemeClr val="bg1"/>
-                </a:solidFill>
-              </a:rPr>
-              <a:t>Structured output + Google Search grounding</a:t>
-            </a:r>
-            <a:endParaRPr lang="en-US" sz="1200" dirty="0"/>
-          </a:p>
-        </p:txBody>
-      </p:sp>
-      <p:sp>
-        <p:nvSpPr>
-          <p:cNvPr id="16" name="Box status Gemini"/>
-          <p:cNvSpPr txBox="1"/>
-          <p:nvPr/>
-        </p:nvSpPr>
-        <p:spPr>
-          <a:xfrm>
-            <a:off x="3941064" y="3063240"/>
-            <a:ext cx="1188720" cy="228600"/>
-          </a:xfrm>
-          <a:prstGeom prst="rect">
-            <a:avLst/>
-          </a:prstGeom>
-          <a:noFill/>
-          <a:ln/>
-        </p:spPr>
-        <p:txBody>
-          <a:bodyPr wrap="square" lIns="0" tIns="0" rIns="0" bIns="0" rtlCol="0" anchor="ctr"/>
-          <a:lstStyle/>
-          <a:p>
-            <a:pPr indent="0" marL="0">
-              <a:buNone/>
-            </a:pPr>
-            <a:r>
-              <a:rPr lang="en-US" sz="1100" b="1" spc="200" kern="0" dirty="0">
-                <a:solidFill>
-                  <a:schemeClr val="accent6"/>
-                </a:solidFill>
-              </a:rPr>
-              <a:t>BUILT</a:t>
-            </a:r>
-            <a:endParaRPr lang="en-US" sz="1100" dirty="0"/>
-          </a:p>
-        </p:txBody>
-      </p:sp>
-      <p:sp>
-        <p:nvSpPr>
-          <p:cNvPr id="17" name="Arrow 3"/>
-          <p:cNvSpPr txBox="1"/>
-          <p:nvPr/>
-        </p:nvSpPr>
-        <p:spPr>
-          <a:xfrm>
-            <a:off x="5266944" y="2240280"/>
-            <a:ext cx="164592" cy="365760"/>
-          </a:xfrm>
-          <a:prstGeom prst="rect">
-            <a:avLst/>
-          </a:prstGeom>
-          <a:noFill/>
-          <a:ln/>
-        </p:spPr>
-        <p:txBody>
-          <a:bodyPr wrap="square" lIns="0" tIns="0" rIns="0" bIns="0" rtlCol="0" anchor="ctr"/>
-          <a:lstStyle/>
-          <a:p>
-            <a:pPr algn="ctr" indent="0" marL="0">
-              <a:buNone/>
-            </a:pPr>
-            <a:r>
-              <a:rPr lang="en-US" sz="1800" dirty="0">
-                <a:solidFill>
-                  <a:schemeClr val="accent4"/>
-                </a:solidFill>
-              </a:rPr>
-              <a:t>→</a:t>
-            </a:r>
-            <a:endParaRPr lang="en-US" sz="1800" dirty="0"/>
-          </a:p>
-        </p:txBody>
-      </p:sp>
-      <p:sp>
-        <p:nvSpPr>
-          <p:cNvPr id="18" name="Box Firestore"/>
-          <p:cNvSpPr/>
-          <p:nvPr/>
-        </p:nvSpPr>
-        <p:spPr>
-          <a:xfrm>
-            <a:off x="5431536" y="1600200"/>
-            <a:ext cx="1463040" cy="1828800"/>
-          </a:xfrm>
-          <a:prstGeom prst="roundRect">
-            <a:avLst>
-              <a:gd name="adj" fmla="val 5000"/>
-            </a:avLst>
-          </a:prstGeom>
-          <a:solidFill>
-            <a:schemeClr val="bg2"/>
-          </a:solidFill>
-          <a:ln w="12700">
-            <a:solidFill>
-              <a:schemeClr val="bg2"/>
-            </a:solidFill>
-            <a:prstDash val="solid"/>
-          </a:ln>
-        </p:spPr>
-      </p:sp>
-      <p:sp>
-        <p:nvSpPr>
-          <p:cNvPr id="19" name="Box title Firestore"/>
-          <p:cNvSpPr txBox="1"/>
-          <p:nvPr/>
-        </p:nvSpPr>
-        <p:spPr>
-          <a:xfrm>
-            <a:off x="5568696" y="1783080"/>
-            <a:ext cx="1188720" cy="320040"/>
-          </a:xfrm>
-          <a:prstGeom prst="rect">
-            <a:avLst/>
-          </a:prstGeom>
-          <a:noFill/>
-          <a:ln/>
-        </p:spPr>
-        <p:txBody>
-          <a:bodyPr wrap="square" lIns="0" tIns="0" rIns="0" bIns="0" rtlCol="0" anchor="ctr"/>
-          <a:lstStyle/>
-          <a:p>
-            <a:pPr indent="0" marL="0">
-              <a:buNone/>
-            </a:pPr>
-            <a:r>
-              <a:rPr lang="en-US" sz="1500" b="1" dirty="0">
-                <a:solidFill>
-                  <a:schemeClr val="tx1"/>
-                </a:solidFill>
-              </a:rPr>
-              <a:t>Firestore</a:t>
-            </a:r>
-            <a:endParaRPr lang="en-US" sz="1500" dirty="0"/>
-          </a:p>
-        </p:txBody>
-      </p:sp>
-      <p:sp>
-        <p:nvSpPr>
-          <p:cNvPr id="20" name="Box body Firestore"/>
-          <p:cNvSpPr txBox="1"/>
-          <p:nvPr/>
-        </p:nvSpPr>
-        <p:spPr>
-          <a:xfrm>
-            <a:off x="5568696" y="2194560"/>
-            <a:ext cx="1188720" cy="777240"/>
-          </a:xfrm>
-          <a:prstGeom prst="rect">
-            <a:avLst/>
-          </a:prstGeom>
-          <a:noFill/>
-          <a:ln/>
-        </p:spPr>
-        <p:txBody>
-          <a:bodyPr wrap="square" lIns="0" tIns="0" rIns="0" bIns="0" rtlCol="0" anchor="t"/>
-          <a:lstStyle/>
-          <a:p>
-            <a:pPr indent="0" marL="0">
-              <a:buNone/>
-            </a:pPr>
-            <a:r>
-              <a:rPr lang="en-US" sz="1200" dirty="0">
-                <a:solidFill>
-                  <a:schemeClr val="tx2"/>
-                </a:solidFill>
-              </a:rPr>
-              <a:t>Daily price history</a:t>
-            </a:r>
-            <a:endParaRPr lang="en-US" sz="1200" dirty="0"/>
-          </a:p>
-        </p:txBody>
-      </p:sp>
-      <p:sp>
-        <p:nvSpPr>
-          <p:cNvPr id="21" name="Box status Firestore"/>
-          <p:cNvSpPr txBox="1"/>
-          <p:nvPr/>
-        </p:nvSpPr>
-        <p:spPr>
-          <a:xfrm>
-            <a:off x="5568696" y="3063240"/>
-            <a:ext cx="1188720" cy="228600"/>
-          </a:xfrm>
-          <a:prstGeom prst="rect">
-            <a:avLst/>
-          </a:prstGeom>
-          <a:noFill/>
-          <a:ln/>
-        </p:spPr>
-        <p:txBody>
-          <a:bodyPr wrap="square" lIns="0" tIns="0" rIns="0" bIns="0" rtlCol="0" anchor="ctr"/>
-          <a:lstStyle/>
-          <a:p>
-            <a:pPr indent="0" marL="0">
-              <a:buNone/>
-            </a:pPr>
-            <a:r>
-              <a:rPr lang="en-US" sz="1100" b="1" spc="200" kern="0" dirty="0">
-                <a:solidFill>
-                  <a:schemeClr val="accent2"/>
-                </a:solidFill>
-              </a:rPr>
-              <a:t>NEXT</a:t>
-            </a:r>
-            <a:endParaRPr lang="en-US" sz="1100" dirty="0"/>
-          </a:p>
-        </p:txBody>
-      </p:sp>
-      <p:sp>
-        <p:nvSpPr>
-          <p:cNvPr id="22" name="Arrow 4"/>
-          <p:cNvSpPr txBox="1"/>
-          <p:nvPr/>
-        </p:nvSpPr>
-        <p:spPr>
-          <a:xfrm>
-            <a:off x="6894576" y="2240280"/>
-            <a:ext cx="164592" cy="365760"/>
-          </a:xfrm>
-          <a:prstGeom prst="rect">
-            <a:avLst/>
-          </a:prstGeom>
-          <a:noFill/>
-          <a:ln/>
-        </p:spPr>
-        <p:txBody>
-          <a:bodyPr wrap="square" lIns="0" tIns="0" rIns="0" bIns="0" rtlCol="0" anchor="ctr"/>
-          <a:lstStyle/>
-          <a:p>
-            <a:pPr algn="ctr" indent="0" marL="0">
-              <a:buNone/>
-            </a:pPr>
-            <a:r>
-              <a:rPr lang="en-US" sz="1800" dirty="0">
-                <a:solidFill>
-                  <a:schemeClr val="accent4"/>
-                </a:solidFill>
-              </a:rPr>
-              <a:t>→</a:t>
-            </a:r>
-            <a:endParaRPr lang="en-US" sz="1800" dirty="0"/>
-          </a:p>
-        </p:txBody>
-      </p:sp>
-      <p:sp>
-        <p:nvSpPr>
-          <p:cNvPr id="23" name="Box Email"/>
-          <p:cNvSpPr/>
-          <p:nvPr/>
-        </p:nvSpPr>
-        <p:spPr>
-          <a:xfrm>
-            <a:off x="7059168" y="1600200"/>
-            <a:ext cx="1463040" cy="1828800"/>
-          </a:xfrm>
-          <a:prstGeom prst="roundRect">
-            <a:avLst>
-              <a:gd name="adj" fmla="val 5000"/>
-            </a:avLst>
-          </a:prstGeom>
-          <a:solidFill>
-            <a:schemeClr val="bg2"/>
-          </a:solidFill>
-          <a:ln w="12700">
-            <a:solidFill>
-              <a:schemeClr val="bg2"/>
-            </a:solidFill>
-            <a:prstDash val="solid"/>
-          </a:ln>
-        </p:spPr>
-      </p:sp>
-      <p:sp>
-        <p:nvSpPr>
-          <p:cNvPr id="24" name="Box title Email"/>
-          <p:cNvSpPr txBox="1"/>
-          <p:nvPr/>
-        </p:nvSpPr>
-        <p:spPr>
-          <a:xfrm>
-            <a:off x="7196328" y="1783080"/>
-            <a:ext cx="1188720" cy="320040"/>
-          </a:xfrm>
-          <a:prstGeom prst="rect">
-            <a:avLst/>
-          </a:prstGeom>
-          <a:noFill/>
-          <a:ln/>
-        </p:spPr>
-        <p:txBody>
-          <a:bodyPr wrap="square" lIns="0" tIns="0" rIns="0" bIns="0" rtlCol="0" anchor="ctr"/>
-          <a:lstStyle/>
-          <a:p>
-            <a:pPr indent="0" marL="0">
-              <a:buNone/>
-            </a:pPr>
-            <a:r>
-              <a:rPr lang="en-US" sz="1500" b="1" dirty="0">
-                <a:solidFill>
-                  <a:schemeClr val="tx1"/>
-                </a:solidFill>
-              </a:rPr>
-              <a:t>Email</a:t>
-            </a:r>
-            <a:endParaRPr lang="en-US" sz="1500" dirty="0"/>
-          </a:p>
-        </p:txBody>
-      </p:sp>
-      <p:sp>
-        <p:nvSpPr>
-          <p:cNvPr id="25" name="Box body Email"/>
-          <p:cNvSpPr txBox="1"/>
-          <p:nvPr/>
-        </p:nvSpPr>
-        <p:spPr>
-          <a:xfrm>
-            <a:off x="7196328" y="2194560"/>
-            <a:ext cx="1188720" cy="777240"/>
-          </a:xfrm>
-          <a:prstGeom prst="rect">
-            <a:avLst/>
-          </a:prstGeom>
-          <a:noFill/>
-          <a:ln/>
-        </p:spPr>
-        <p:txBody>
-          <a:bodyPr wrap="square" lIns="0" tIns="0" rIns="0" bIns="0" rtlCol="0" anchor="t"/>
-          <a:lstStyle/>
-          <a:p>
-            <a:pPr indent="0" marL="0">
-              <a:buNone/>
-            </a:pPr>
-            <a:r>
-              <a:rPr lang="en-US" sz="1200" dirty="0">
-                <a:solidFill>
-                  <a:schemeClr val="tx2"/>
-                </a:solidFill>
-              </a:rPr>
-              <a:t>Firebase email digest</a:t>
-            </a:r>
-            <a:endParaRPr lang="en-US" sz="1200" dirty="0"/>
-          </a:p>
-        </p:txBody>
-      </p:sp>
-      <p:sp>
-        <p:nvSpPr>
-          <p:cNvPr id="26" name="Box status Email"/>
-          <p:cNvSpPr txBox="1"/>
-          <p:nvPr/>
-        </p:nvSpPr>
-        <p:spPr>
-          <a:xfrm>
-            <a:off x="7196328" y="3063240"/>
-            <a:ext cx="1188720" cy="228600"/>
-          </a:xfrm>
-          <a:prstGeom prst="rect">
-            <a:avLst/>
-          </a:prstGeom>
-          <a:noFill/>
-          <a:ln/>
-        </p:spPr>
-        <p:txBody>
-          <a:bodyPr wrap="square" lIns="0" tIns="0" rIns="0" bIns="0" rtlCol="0" anchor="ctr"/>
-          <a:lstStyle/>
-          <a:p>
-            <a:pPr indent="0" marL="0">
-              <a:buNone/>
-            </a:pPr>
-            <a:r>
-              <a:rPr lang="en-US" sz="1100" b="1" spc="200" kern="0" dirty="0">
-                <a:solidFill>
-                  <a:schemeClr val="accent2"/>
-                </a:solidFill>
-              </a:rPr>
-              <a:t>NEXT</a:t>
-            </a:r>
-            <a:endParaRPr lang="en-US" sz="1100" dirty="0"/>
-          </a:p>
-        </p:txBody>
-      </p:sp>
-      <p:sp>
-        <p:nvSpPr>
-          <p:cNvPr id="27" name="Interface note"/>
-          <p:cNvSpPr txBox="1"/>
-          <p:nvPr/>
-        </p:nvSpPr>
-        <p:spPr>
-          <a:xfrm>
-            <a:off x="548640" y="3794760"/>
-            <a:ext cx="8046720" cy="365760"/>
-          </a:xfrm>
-          <a:prstGeom prst="rect">
-            <a:avLst/>
-          </a:prstGeom>
-          <a:noFill/>
-          <a:ln/>
-        </p:spPr>
-        <p:txBody>
-          <a:bodyPr wrap="square" lIns="0" tIns="0" rIns="0" bIns="0" rtlCol="0" anchor="ctr"/>
-          <a:lstStyle/>
-          <a:p>
-            <a:pPr indent="0" marL="0">
-              <a:buNone/>
-            </a:pPr>
-            <a:r>
-              <a:rPr lang="en-US" sz="1600" b="1" dirty="0">
-                <a:solidFill>
-                  <a:schemeClr val="tx1"/>
-                </a:solidFill>
-              </a:rPr>
-              <a:t>One PriceSource interface: Google Search today, retailer APIs as we scale.</a:t>
+              <a:t>Asked for 2 inputs, this one has 4. DealScout shows the extra cost against the cheapest model that already covers the need.</a:t>
             </a:r>
             <a:endParaRPr lang="en-US" sz="1600" dirty="0"/>
-          </a:p>
-        </p:txBody>
-      </p:sp>
-      <p:sp>
-        <p:nvSpPr>
-          <p:cNvPr id="28" name="Prototype note"/>
-          <p:cNvSpPr txBox="1"/>
-          <p:nvPr/>
-        </p:nvSpPr>
-        <p:spPr>
-          <a:xfrm>
-            <a:off x="548640" y="4206240"/>
-            <a:ext cx="8046720" cy="320040"/>
-          </a:xfrm>
-          <a:prstGeom prst="rect">
-            <a:avLst/>
-          </a:prstGeom>
-          <a:noFill/>
-          <a:ln/>
-        </p:spPr>
-        <p:txBody>
-          <a:bodyPr wrap="square" lIns="0" tIns="0" rIns="0" bIns="0" rtlCol="0" anchor="ctr"/>
-          <a:lstStyle/>
-          <a:p>
-            <a:pPr indent="0" marL="0">
-              <a:buNone/>
-            </a:pPr>
-            <a:r>
-              <a:rPr lang="en-US" sz="1300" dirty="0">
-                <a:solidFill>
-                  <a:schemeClr val="accent4"/>
-                </a:solidFill>
-              </a:rPr>
-              <a:t>In the prototype, prices are saved to a local file and the digest is written as HTML.</a:t>
-            </a:r>
-            <a:endParaRPr lang="en-US" sz="1300" dirty="0"/>
           </a:p>
         </p:txBody>
       </p:sp>
@@ -6958,7 +6753,7 @@
                 <a:ea typeface="Cambria" pitchFamily="34" charset="-122"/>
                 <a:cs typeface="Cambria" pitchFamily="34" charset="-120"/>
               </a:rPr>
-              <a:t>Working today, and what comes next</a:t>
+              <a:t>Built on Gemini and Google Cloud</a:t>
             </a:r>
             <a:endParaRPr lang="en-US" sz="3000" dirty="0"/>
           </a:p>
@@ -6966,18 +6761,18 @@
       </p:sp>
       <p:sp>
         <p:nvSpPr>
-          <p:cNvPr id="3" name="Today card"/>
+          <p:cNvPr id="3" name="Box Cloud Scheduler"/>
           <p:cNvSpPr/>
           <p:nvPr/>
         </p:nvSpPr>
         <p:spPr>
           <a:xfrm>
-            <a:off x="548640" y="1371600"/>
-            <a:ext cx="3931920" cy="3108960"/>
+            <a:off x="548640" y="1600200"/>
+            <a:ext cx="1463040" cy="1828800"/>
           </a:xfrm>
           <a:prstGeom prst="roundRect">
             <a:avLst>
-              <a:gd name="adj" fmla="val 2353"/>
+              <a:gd name="adj" fmla="val 5000"/>
             </a:avLst>
           </a:prstGeom>
           <a:solidFill>
@@ -6993,14 +6788,14 @@
       </p:sp>
       <p:sp>
         <p:nvSpPr>
-          <p:cNvPr id="4" name="Today heading"/>
+          <p:cNvPr id="4" name="Box title Cloud Scheduler"/>
           <p:cNvSpPr txBox="1"/>
           <p:nvPr/>
         </p:nvSpPr>
         <p:spPr>
           <a:xfrm>
-            <a:off x="822960" y="1554480"/>
-            <a:ext cx="3383280" cy="274320"/>
+            <a:off x="685800" y="1783080"/>
+            <a:ext cx="1188720" cy="320040"/>
           </a:xfrm>
           <a:prstGeom prst="rect">
             <a:avLst/>
@@ -7016,27 +6811,27 @@
               <a:buNone/>
             </a:pPr>
             <a:r>
-              <a:rPr lang="en-US" sz="1200" b="1" spc="200" kern="0" dirty="0">
-                <a:solidFill>
-                  <a:schemeClr val="accent1"/>
-                </a:solidFill>
-              </a:rPr>
-              <a:t>WORKING TODAY</a:t>
-            </a:r>
-            <a:endParaRPr lang="en-US" sz="1200" dirty="0"/>
-          </a:p>
-        </p:txBody>
-      </p:sp>
-      <p:sp>
-        <p:nvSpPr>
-          <p:cNvPr id="5" name="Today list"/>
+              <a:rPr lang="en-US" sz="1500" b="1" dirty="0">
+                <a:solidFill>
+                  <a:schemeClr val="tx1"/>
+                </a:solidFill>
+              </a:rPr>
+              <a:t>Cloud Scheduler</a:t>
+            </a:r>
+            <a:endParaRPr lang="en-US" sz="1500" dirty="0"/>
+          </a:p>
+        </p:txBody>
+      </p:sp>
+      <p:sp>
+        <p:nvSpPr>
+          <p:cNvPr id="5" name="Box body Cloud Scheduler"/>
           <p:cNvSpPr txBox="1"/>
           <p:nvPr/>
         </p:nvSpPr>
         <p:spPr>
           <a:xfrm>
-            <a:off x="822960" y="1920240"/>
-            <a:ext cx="3383280" cy="2011680"/>
+            <a:off x="685800" y="2194560"/>
+            <a:ext cx="1188720" cy="777240"/>
           </a:xfrm>
           <a:prstGeom prst="rect">
             <a:avLst/>
@@ -7046,157 +6841,117 @@
         </p:spPr>
         <p:txBody>
           <a:bodyPr wrap="square" lIns="0" tIns="0" rIns="0" bIns="0" rtlCol="0" anchor="t"/>
-          <a:lstStyle/>
-          <a:p>
-            <a:pPr marL="342900" indent="-342900">
-              <a:spcAft>
-                <a:spcPts val="800"/>
-              </a:spcAft>
-              <a:buSzPct val="100000"/>
-              <a:buChar char="•"/>
-            </a:pPr>
-            <a:r>
-              <a:rPr lang="en-US" sz="1400" dirty="0">
-                <a:solidFill>
-                  <a:schemeClr val="tx1"/>
-                </a:solidFill>
-              </a:rPr>
-              <a:t>Fake-discount and verdict logic, 15 tests</a:t>
-            </a:r>
-            <a:endParaRPr lang="en-US" sz="1400" dirty="0"/>
-          </a:p>
-          <a:p>
-            <a:pPr marL="342900" indent="-342900">
-              <a:spcAft>
-                <a:spcPts val="800"/>
-              </a:spcAft>
-              <a:buSzPct val="100000"/>
-              <a:buChar char="•"/>
-            </a:pPr>
-            <a:r>
-              <a:rPr lang="en-US" sz="1400" dirty="0">
-                <a:solidFill>
-                  <a:schemeClr val="tx1"/>
-                </a:solidFill>
-              </a:rPr>
-              <a:t>Gemini watch spec from plain English</a:t>
-            </a:r>
-            <a:endParaRPr lang="en-US" sz="1400" dirty="0"/>
-          </a:p>
-          <a:p>
-            <a:pPr marL="342900" indent="-342900">
-              <a:spcAft>
-                <a:spcPts val="800"/>
-              </a:spcAft>
-              <a:buSzPct val="100000"/>
-              <a:buChar char="•"/>
-            </a:pPr>
-            <a:r>
-              <a:rPr lang="en-US" sz="1400" dirty="0">
-                <a:solidFill>
-                  <a:schemeClr val="tx1"/>
-                </a:solidFill>
-              </a:rPr>
-              <a:t>Live agent trace and need-aware fit check</a:t>
-            </a:r>
-            <a:endParaRPr lang="en-US" sz="1400" dirty="0"/>
-          </a:p>
-          <a:p>
-            <a:pPr marL="342900" indent="-342900">
-              <a:spcAft>
-                <a:spcPts val="800"/>
-              </a:spcAft>
-              <a:buSzPct val="100000"/>
-              <a:buChar char="•"/>
-            </a:pPr>
-            <a:r>
-              <a:rPr lang="en-US" sz="1400" dirty="0">
-                <a:solidFill>
-                  <a:schemeClr val="tx1"/>
-                </a:solidFill>
-              </a:rPr>
-              <a:t>Google Search discovery (not yet run live)</a:t>
-            </a:r>
-            <a:endParaRPr lang="en-US" sz="1400" dirty="0"/>
-          </a:p>
-          <a:p>
-            <a:pPr marL="342900" indent="-342900">
-              <a:spcAft>
-                <a:spcPts val="800"/>
-              </a:spcAft>
-              <a:buSzPct val="100000"/>
-              <a:buChar char="•"/>
-            </a:pPr>
-            <a:r>
-              <a:rPr lang="en-US" sz="1400" dirty="0">
-                <a:solidFill>
-                  <a:schemeClr val="tx1"/>
-                </a:solidFill>
-              </a:rPr>
-              <a:t>Web UI, plus digest as text and HTML</a:t>
-            </a:r>
-            <a:endParaRPr lang="en-US" sz="1400" dirty="0"/>
-          </a:p>
-        </p:txBody>
-      </p:sp>
-      <p:sp>
-        <p:nvSpPr>
-          <p:cNvPr id="6" name="Test data note"/>
-          <p:cNvSpPr txBox="1"/>
-          <p:nvPr/>
-        </p:nvSpPr>
-        <p:spPr>
-          <a:xfrm>
-            <a:off x="822960" y="4023360"/>
-            <a:ext cx="3383280" cy="320040"/>
-          </a:xfrm>
-          <a:prstGeom prst="rect">
-            <a:avLst/>
-          </a:prstGeom>
-          <a:noFill/>
-          <a:ln/>
-        </p:spPr>
-        <p:txBody>
-          <a:bodyPr wrap="square" lIns="0" tIns="0" rIns="0" bIns="0" rtlCol="0" anchor="ctr"/>
           <a:lstStyle/>
           <a:p>
             <a:pPr indent="0" marL="0">
               <a:buNone/>
             </a:pPr>
             <a:r>
-              <a:rPr lang="en-US" sz="1200" i="1" dirty="0">
+              <a:rPr lang="en-US" sz="1200" dirty="0">
+                <a:solidFill>
+                  <a:schemeClr val="tx2"/>
+                </a:solidFill>
+              </a:rPr>
+              <a:t>Triggers the daily run</a:t>
+            </a:r>
+            <a:endParaRPr lang="en-US" sz="1200" dirty="0"/>
+          </a:p>
+        </p:txBody>
+      </p:sp>
+      <p:sp>
+        <p:nvSpPr>
+          <p:cNvPr id="6" name="Box status Cloud Scheduler"/>
+          <p:cNvSpPr txBox="1"/>
+          <p:nvPr/>
+        </p:nvSpPr>
+        <p:spPr>
+          <a:xfrm>
+            <a:off x="685800" y="3063240"/>
+            <a:ext cx="1188720" cy="228600"/>
+          </a:xfrm>
+          <a:prstGeom prst="rect">
+            <a:avLst/>
+          </a:prstGeom>
+          <a:noFill/>
+          <a:ln/>
+        </p:spPr>
+        <p:txBody>
+          <a:bodyPr wrap="square" lIns="0" tIns="0" rIns="0" bIns="0" rtlCol="0" anchor="ctr"/>
+          <a:lstStyle/>
+          <a:p>
+            <a:pPr indent="0" marL="0">
+              <a:buNone/>
+            </a:pPr>
+            <a:r>
+              <a:rPr lang="en-US" sz="1100" b="1" spc="200" kern="0" dirty="0">
+                <a:solidFill>
+                  <a:schemeClr val="accent2"/>
+                </a:solidFill>
+              </a:rPr>
+              <a:t>NEXT</a:t>
+            </a:r>
+            <a:endParaRPr lang="en-US" sz="1100" dirty="0"/>
+          </a:p>
+        </p:txBody>
+      </p:sp>
+      <p:sp>
+        <p:nvSpPr>
+          <p:cNvPr id="7" name="Arrow 1"/>
+          <p:cNvSpPr txBox="1"/>
+          <p:nvPr/>
+        </p:nvSpPr>
+        <p:spPr>
+          <a:xfrm>
+            <a:off x="2011680" y="2240280"/>
+            <a:ext cx="164592" cy="365760"/>
+          </a:xfrm>
+          <a:prstGeom prst="rect">
+            <a:avLst/>
+          </a:prstGeom>
+          <a:noFill/>
+          <a:ln/>
+        </p:spPr>
+        <p:txBody>
+          <a:bodyPr wrap="square" lIns="0" tIns="0" rIns="0" bIns="0" rtlCol="0" anchor="ctr"/>
+          <a:lstStyle/>
+          <a:p>
+            <a:pPr algn="ctr" indent="0" marL="0">
+              <a:buNone/>
+            </a:pPr>
+            <a:r>
+              <a:rPr lang="en-US" sz="1800" dirty="0">
                 <a:solidFill>
                   <a:schemeClr val="accent4"/>
                 </a:solidFill>
               </a:rPr>
-              <a:t>Demo products and history are test data.</a:t>
-            </a:r>
-            <a:endParaRPr lang="en-US" sz="1200" dirty="0"/>
-          </a:p>
-        </p:txBody>
-      </p:sp>
-      <p:sp>
-        <p:nvSpPr>
-          <p:cNvPr id="7" name="Next card"/>
+              <a:t>→</a:t>
+            </a:r>
+            <a:endParaRPr lang="en-US" sz="1800" dirty="0"/>
+          </a:p>
+        </p:txBody>
+      </p:sp>
+      <p:sp>
+        <p:nvSpPr>
+          <p:cNvPr id="8" name="Box Cloud Run"/>
           <p:cNvSpPr/>
           <p:nvPr/>
         </p:nvSpPr>
         <p:spPr>
           <a:xfrm>
-            <a:off x="4663440" y="1371600"/>
-            <a:ext cx="3931920" cy="3108960"/>
+            <a:off x="2176272" y="1600200"/>
+            <a:ext cx="1463040" cy="1828800"/>
           </a:xfrm>
           <a:prstGeom prst="roundRect">
             <a:avLst>
-              <a:gd name="adj" fmla="val 2353"/>
+              <a:gd name="adj" fmla="val 5000"/>
             </a:avLst>
           </a:prstGeom>
           <a:solidFill>
-            <a:schemeClr val="tx1"/>
+            <a:schemeClr val="bg2"/>
           </a:solidFill>
           <a:ln w="12700">
             <a:solidFill>
-              <a:schemeClr val="tx1"/>
+              <a:schemeClr val="bg2"/>
             </a:solidFill>
             <a:prstDash val="solid"/>
           </a:ln>
@@ -7204,14 +6959,14 @@
       </p:sp>
       <p:sp>
         <p:nvSpPr>
-          <p:cNvPr id="8" name="Next heading"/>
+          <p:cNvPr id="9" name="Box title Cloud Run"/>
           <p:cNvSpPr txBox="1"/>
           <p:nvPr/>
         </p:nvSpPr>
         <p:spPr>
           <a:xfrm>
-            <a:off x="4937760" y="1554480"/>
-            <a:ext cx="3383280" cy="274320"/>
+            <a:off x="2313432" y="1783080"/>
+            <a:ext cx="1188720" cy="320040"/>
           </a:xfrm>
           <a:prstGeom prst="rect">
             <a:avLst/>
@@ -7227,108 +6982,671 @@
               <a:buNone/>
             </a:pPr>
             <a:r>
-              <a:rPr lang="en-US" sz="1200" b="1" spc="200" kern="0" dirty="0">
+              <a:rPr lang="en-US" sz="1500" b="1" dirty="0">
+                <a:solidFill>
+                  <a:schemeClr val="tx1"/>
+                </a:solidFill>
+              </a:rPr>
+              <a:t>Cloud Run</a:t>
+            </a:r>
+            <a:endParaRPr lang="en-US" sz="1500" dirty="0"/>
+          </a:p>
+        </p:txBody>
+      </p:sp>
+      <p:sp>
+        <p:nvSpPr>
+          <p:cNvPr id="10" name="Box body Cloud Run"/>
+          <p:cNvSpPr txBox="1"/>
+          <p:nvPr/>
+        </p:nvSpPr>
+        <p:spPr>
+          <a:xfrm>
+            <a:off x="2313432" y="2194560"/>
+            <a:ext cx="1188720" cy="777240"/>
+          </a:xfrm>
+          <a:prstGeom prst="rect">
+            <a:avLst/>
+          </a:prstGeom>
+          <a:noFill/>
+          <a:ln/>
+        </p:spPr>
+        <p:txBody>
+          <a:bodyPr wrap="square" lIns="0" tIns="0" rIns="0" bIns="0" rtlCol="0" anchor="t"/>
+          <a:lstStyle/>
+          <a:p>
+            <a:pPr indent="0" marL="0">
+              <a:buNone/>
+            </a:pPr>
+            <a:r>
+              <a:rPr lang="en-US" sz="1200" dirty="0">
+                <a:solidFill>
+                  <a:schemeClr val="tx2"/>
+                </a:solidFill>
+              </a:rPr>
+              <a:t>Runs the scout service</a:t>
+            </a:r>
+            <a:endParaRPr lang="en-US" sz="1200" dirty="0"/>
+          </a:p>
+        </p:txBody>
+      </p:sp>
+      <p:sp>
+        <p:nvSpPr>
+          <p:cNvPr id="11" name="Box status Cloud Run"/>
+          <p:cNvSpPr txBox="1"/>
+          <p:nvPr/>
+        </p:nvSpPr>
+        <p:spPr>
+          <a:xfrm>
+            <a:off x="2313432" y="3063240"/>
+            <a:ext cx="1188720" cy="228600"/>
+          </a:xfrm>
+          <a:prstGeom prst="rect">
+            <a:avLst/>
+          </a:prstGeom>
+          <a:noFill/>
+          <a:ln/>
+        </p:spPr>
+        <p:txBody>
+          <a:bodyPr wrap="square" lIns="0" tIns="0" rIns="0" bIns="0" rtlCol="0" anchor="ctr"/>
+          <a:lstStyle/>
+          <a:p>
+            <a:pPr indent="0" marL="0">
+              <a:buNone/>
+            </a:pPr>
+            <a:r>
+              <a:rPr lang="en-US" sz="1100" b="1" spc="200" kern="0" dirty="0">
+                <a:solidFill>
+                  <a:schemeClr val="accent2"/>
+                </a:solidFill>
+              </a:rPr>
+              <a:t>NEXT</a:t>
+            </a:r>
+            <a:endParaRPr lang="en-US" sz="1100" dirty="0"/>
+          </a:p>
+        </p:txBody>
+      </p:sp>
+      <p:sp>
+        <p:nvSpPr>
+          <p:cNvPr id="12" name="Arrow 2"/>
+          <p:cNvSpPr txBox="1"/>
+          <p:nvPr/>
+        </p:nvSpPr>
+        <p:spPr>
+          <a:xfrm>
+            <a:off x="3639312" y="2240280"/>
+            <a:ext cx="164592" cy="365760"/>
+          </a:xfrm>
+          <a:prstGeom prst="rect">
+            <a:avLst/>
+          </a:prstGeom>
+          <a:noFill/>
+          <a:ln/>
+        </p:spPr>
+        <p:txBody>
+          <a:bodyPr wrap="square" lIns="0" tIns="0" rIns="0" bIns="0" rtlCol="0" anchor="ctr"/>
+          <a:lstStyle/>
+          <a:p>
+            <a:pPr algn="ctr" indent="0" marL="0">
+              <a:buNone/>
+            </a:pPr>
+            <a:r>
+              <a:rPr lang="en-US" sz="1800" dirty="0">
+                <a:solidFill>
+                  <a:schemeClr val="accent4"/>
+                </a:solidFill>
+              </a:rPr>
+              <a:t>→</a:t>
+            </a:r>
+            <a:endParaRPr lang="en-US" sz="1800" dirty="0"/>
+          </a:p>
+        </p:txBody>
+      </p:sp>
+      <p:sp>
+        <p:nvSpPr>
+          <p:cNvPr id="13" name="Box Gemini"/>
+          <p:cNvSpPr/>
+          <p:nvPr/>
+        </p:nvSpPr>
+        <p:spPr>
+          <a:xfrm>
+            <a:off x="3803904" y="1600200"/>
+            <a:ext cx="1463040" cy="1828800"/>
+          </a:xfrm>
+          <a:prstGeom prst="roundRect">
+            <a:avLst>
+              <a:gd name="adj" fmla="val 5000"/>
+            </a:avLst>
+          </a:prstGeom>
+          <a:solidFill>
+            <a:schemeClr val="accent1"/>
+          </a:solidFill>
+          <a:ln w="12700">
+            <a:solidFill>
+              <a:schemeClr val="accent1"/>
+            </a:solidFill>
+            <a:prstDash val="solid"/>
+          </a:ln>
+        </p:spPr>
+      </p:sp>
+      <p:sp>
+        <p:nvSpPr>
+          <p:cNvPr id="14" name="Box title Gemini"/>
+          <p:cNvSpPr txBox="1"/>
+          <p:nvPr/>
+        </p:nvSpPr>
+        <p:spPr>
+          <a:xfrm>
+            <a:off x="3941064" y="1783080"/>
+            <a:ext cx="1188720" cy="320040"/>
+          </a:xfrm>
+          <a:prstGeom prst="rect">
+            <a:avLst/>
+          </a:prstGeom>
+          <a:noFill/>
+          <a:ln/>
+        </p:spPr>
+        <p:txBody>
+          <a:bodyPr wrap="square" lIns="0" tIns="0" rIns="0" bIns="0" rtlCol="0" anchor="ctr"/>
+          <a:lstStyle/>
+          <a:p>
+            <a:pPr indent="0" marL="0">
+              <a:buNone/>
+            </a:pPr>
+            <a:r>
+              <a:rPr lang="en-US" sz="1500" b="1" dirty="0">
+                <a:solidFill>
+                  <a:schemeClr val="bg1"/>
+                </a:solidFill>
+              </a:rPr>
+              <a:t>Gemini</a:t>
+            </a:r>
+            <a:endParaRPr lang="en-US" sz="1500" dirty="0"/>
+          </a:p>
+        </p:txBody>
+      </p:sp>
+      <p:sp>
+        <p:nvSpPr>
+          <p:cNvPr id="15" name="Box body Gemini"/>
+          <p:cNvSpPr txBox="1"/>
+          <p:nvPr/>
+        </p:nvSpPr>
+        <p:spPr>
+          <a:xfrm>
+            <a:off x="3941064" y="2194560"/>
+            <a:ext cx="1188720" cy="777240"/>
+          </a:xfrm>
+          <a:prstGeom prst="rect">
+            <a:avLst/>
+          </a:prstGeom>
+          <a:noFill/>
+          <a:ln/>
+        </p:spPr>
+        <p:txBody>
+          <a:bodyPr wrap="square" lIns="0" tIns="0" rIns="0" bIns="0" rtlCol="0" anchor="t"/>
+          <a:lstStyle/>
+          <a:p>
+            <a:pPr indent="0" marL="0">
+              <a:buNone/>
+            </a:pPr>
+            <a:r>
+              <a:rPr lang="en-US" sz="1200" dirty="0">
+                <a:solidFill>
+                  <a:schemeClr val="bg1"/>
+                </a:solidFill>
+              </a:rPr>
+              <a:t>Structured output + Google Search grounding</a:t>
+            </a:r>
+            <a:endParaRPr lang="en-US" sz="1200" dirty="0"/>
+          </a:p>
+        </p:txBody>
+      </p:sp>
+      <p:sp>
+        <p:nvSpPr>
+          <p:cNvPr id="16" name="Box status Gemini"/>
+          <p:cNvSpPr txBox="1"/>
+          <p:nvPr/>
+        </p:nvSpPr>
+        <p:spPr>
+          <a:xfrm>
+            <a:off x="3941064" y="3063240"/>
+            <a:ext cx="1188720" cy="228600"/>
+          </a:xfrm>
+          <a:prstGeom prst="rect">
+            <a:avLst/>
+          </a:prstGeom>
+          <a:noFill/>
+          <a:ln/>
+        </p:spPr>
+        <p:txBody>
+          <a:bodyPr wrap="square" lIns="0" tIns="0" rIns="0" bIns="0" rtlCol="0" anchor="ctr"/>
+          <a:lstStyle/>
+          <a:p>
+            <a:pPr indent="0" marL="0">
+              <a:buNone/>
+            </a:pPr>
+            <a:r>
+              <a:rPr lang="en-US" sz="1100" b="1" spc="200" kern="0" dirty="0">
                 <a:solidFill>
                   <a:schemeClr val="accent6"/>
                 </a:solidFill>
               </a:rPr>
+              <a:t>BUILT</a:t>
+            </a:r>
+            <a:endParaRPr lang="en-US" sz="1100" dirty="0"/>
+          </a:p>
+        </p:txBody>
+      </p:sp>
+      <p:sp>
+        <p:nvSpPr>
+          <p:cNvPr id="17" name="Arrow 3"/>
+          <p:cNvSpPr txBox="1"/>
+          <p:nvPr/>
+        </p:nvSpPr>
+        <p:spPr>
+          <a:xfrm>
+            <a:off x="5266944" y="2240280"/>
+            <a:ext cx="164592" cy="365760"/>
+          </a:xfrm>
+          <a:prstGeom prst="rect">
+            <a:avLst/>
+          </a:prstGeom>
+          <a:noFill/>
+          <a:ln/>
+        </p:spPr>
+        <p:txBody>
+          <a:bodyPr wrap="square" lIns="0" tIns="0" rIns="0" bIns="0" rtlCol="0" anchor="ctr"/>
+          <a:lstStyle/>
+          <a:p>
+            <a:pPr algn="ctr" indent="0" marL="0">
+              <a:buNone/>
+            </a:pPr>
+            <a:r>
+              <a:rPr lang="en-US" sz="1800" dirty="0">
+                <a:solidFill>
+                  <a:schemeClr val="accent4"/>
+                </a:solidFill>
+              </a:rPr>
+              <a:t>→</a:t>
+            </a:r>
+            <a:endParaRPr lang="en-US" sz="1800" dirty="0"/>
+          </a:p>
+        </p:txBody>
+      </p:sp>
+      <p:sp>
+        <p:nvSpPr>
+          <p:cNvPr id="18" name="Box Firestore"/>
+          <p:cNvSpPr/>
+          <p:nvPr/>
+        </p:nvSpPr>
+        <p:spPr>
+          <a:xfrm>
+            <a:off x="5431536" y="1600200"/>
+            <a:ext cx="1463040" cy="1828800"/>
+          </a:xfrm>
+          <a:prstGeom prst="roundRect">
+            <a:avLst>
+              <a:gd name="adj" fmla="val 5000"/>
+            </a:avLst>
+          </a:prstGeom>
+          <a:solidFill>
+            <a:schemeClr val="bg2"/>
+          </a:solidFill>
+          <a:ln w="12700">
+            <a:solidFill>
+              <a:schemeClr val="bg2"/>
+            </a:solidFill>
+            <a:prstDash val="solid"/>
+          </a:ln>
+        </p:spPr>
+      </p:sp>
+      <p:sp>
+        <p:nvSpPr>
+          <p:cNvPr id="19" name="Box title Firestore"/>
+          <p:cNvSpPr txBox="1"/>
+          <p:nvPr/>
+        </p:nvSpPr>
+        <p:spPr>
+          <a:xfrm>
+            <a:off x="5568696" y="1783080"/>
+            <a:ext cx="1188720" cy="320040"/>
+          </a:xfrm>
+          <a:prstGeom prst="rect">
+            <a:avLst/>
+          </a:prstGeom>
+          <a:noFill/>
+          <a:ln/>
+        </p:spPr>
+        <p:txBody>
+          <a:bodyPr wrap="square" lIns="0" tIns="0" rIns="0" bIns="0" rtlCol="0" anchor="ctr"/>
+          <a:lstStyle/>
+          <a:p>
+            <a:pPr indent="0" marL="0">
+              <a:buNone/>
+            </a:pPr>
+            <a:r>
+              <a:rPr lang="en-US" sz="1500" b="1" dirty="0">
+                <a:solidFill>
+                  <a:schemeClr val="tx1"/>
+                </a:solidFill>
+              </a:rPr>
+              <a:t>Firestore</a:t>
+            </a:r>
+            <a:endParaRPr lang="en-US" sz="1500" dirty="0"/>
+          </a:p>
+        </p:txBody>
+      </p:sp>
+      <p:sp>
+        <p:nvSpPr>
+          <p:cNvPr id="20" name="Box body Firestore"/>
+          <p:cNvSpPr txBox="1"/>
+          <p:nvPr/>
+        </p:nvSpPr>
+        <p:spPr>
+          <a:xfrm>
+            <a:off x="5568696" y="2194560"/>
+            <a:ext cx="1188720" cy="777240"/>
+          </a:xfrm>
+          <a:prstGeom prst="rect">
+            <a:avLst/>
+          </a:prstGeom>
+          <a:noFill/>
+          <a:ln/>
+        </p:spPr>
+        <p:txBody>
+          <a:bodyPr wrap="square" lIns="0" tIns="0" rIns="0" bIns="0" rtlCol="0" anchor="t"/>
+          <a:lstStyle/>
+          <a:p>
+            <a:pPr indent="0" marL="0">
+              <a:buNone/>
+            </a:pPr>
+            <a:r>
+              <a:rPr lang="en-US" sz="1200" dirty="0">
+                <a:solidFill>
+                  <a:schemeClr val="tx2"/>
+                </a:solidFill>
+              </a:rPr>
+              <a:t>Daily price history</a:t>
+            </a:r>
+            <a:endParaRPr lang="en-US" sz="1200" dirty="0"/>
+          </a:p>
+        </p:txBody>
+      </p:sp>
+      <p:sp>
+        <p:nvSpPr>
+          <p:cNvPr id="21" name="Box status Firestore"/>
+          <p:cNvSpPr txBox="1"/>
+          <p:nvPr/>
+        </p:nvSpPr>
+        <p:spPr>
+          <a:xfrm>
+            <a:off x="5568696" y="3063240"/>
+            <a:ext cx="1188720" cy="228600"/>
+          </a:xfrm>
+          <a:prstGeom prst="rect">
+            <a:avLst/>
+          </a:prstGeom>
+          <a:noFill/>
+          <a:ln/>
+        </p:spPr>
+        <p:txBody>
+          <a:bodyPr wrap="square" lIns="0" tIns="0" rIns="0" bIns="0" rtlCol="0" anchor="ctr"/>
+          <a:lstStyle/>
+          <a:p>
+            <a:pPr indent="0" marL="0">
+              <a:buNone/>
+            </a:pPr>
+            <a:r>
+              <a:rPr lang="en-US" sz="1100" b="1" spc="200" kern="0" dirty="0">
+                <a:solidFill>
+                  <a:schemeClr val="accent2"/>
+                </a:solidFill>
+              </a:rPr>
               <a:t>NEXT</a:t>
             </a:r>
+            <a:endParaRPr lang="en-US" sz="1100" dirty="0"/>
+          </a:p>
+        </p:txBody>
+      </p:sp>
+      <p:sp>
+        <p:nvSpPr>
+          <p:cNvPr id="22" name="Arrow 4"/>
+          <p:cNvSpPr txBox="1"/>
+          <p:nvPr/>
+        </p:nvSpPr>
+        <p:spPr>
+          <a:xfrm>
+            <a:off x="6894576" y="2240280"/>
+            <a:ext cx="164592" cy="365760"/>
+          </a:xfrm>
+          <a:prstGeom prst="rect">
+            <a:avLst/>
+          </a:prstGeom>
+          <a:noFill/>
+          <a:ln/>
+        </p:spPr>
+        <p:txBody>
+          <a:bodyPr wrap="square" lIns="0" tIns="0" rIns="0" bIns="0" rtlCol="0" anchor="ctr"/>
+          <a:lstStyle/>
+          <a:p>
+            <a:pPr algn="ctr" indent="0" marL="0">
+              <a:buNone/>
+            </a:pPr>
+            <a:r>
+              <a:rPr lang="en-US" sz="1800" dirty="0">
+                <a:solidFill>
+                  <a:schemeClr val="accent4"/>
+                </a:solidFill>
+              </a:rPr>
+              <a:t>→</a:t>
+            </a:r>
+            <a:endParaRPr lang="en-US" sz="1800" dirty="0"/>
+          </a:p>
+        </p:txBody>
+      </p:sp>
+      <p:sp>
+        <p:nvSpPr>
+          <p:cNvPr id="23" name="Box Email"/>
+          <p:cNvSpPr/>
+          <p:nvPr/>
+        </p:nvSpPr>
+        <p:spPr>
+          <a:xfrm>
+            <a:off x="7059168" y="1600200"/>
+            <a:ext cx="1463040" cy="1828800"/>
+          </a:xfrm>
+          <a:prstGeom prst="roundRect">
+            <a:avLst>
+              <a:gd name="adj" fmla="val 5000"/>
+            </a:avLst>
+          </a:prstGeom>
+          <a:solidFill>
+            <a:schemeClr val="bg2"/>
+          </a:solidFill>
+          <a:ln w="12700">
+            <a:solidFill>
+              <a:schemeClr val="bg2"/>
+            </a:solidFill>
+            <a:prstDash val="solid"/>
+          </a:ln>
+        </p:spPr>
+      </p:sp>
+      <p:sp>
+        <p:nvSpPr>
+          <p:cNvPr id="24" name="Box title Email"/>
+          <p:cNvSpPr txBox="1"/>
+          <p:nvPr/>
+        </p:nvSpPr>
+        <p:spPr>
+          <a:xfrm>
+            <a:off x="7196328" y="1783080"/>
+            <a:ext cx="1188720" cy="320040"/>
+          </a:xfrm>
+          <a:prstGeom prst="rect">
+            <a:avLst/>
+          </a:prstGeom>
+          <a:noFill/>
+          <a:ln/>
+        </p:spPr>
+        <p:txBody>
+          <a:bodyPr wrap="square" lIns="0" tIns="0" rIns="0" bIns="0" rtlCol="0" anchor="ctr"/>
+          <a:lstStyle/>
+          <a:p>
+            <a:pPr indent="0" marL="0">
+              <a:buNone/>
+            </a:pPr>
+            <a:r>
+              <a:rPr lang="en-US" sz="1500" b="1" dirty="0">
+                <a:solidFill>
+                  <a:schemeClr val="tx1"/>
+                </a:solidFill>
+              </a:rPr>
+              <a:t>Email</a:t>
+            </a:r>
+            <a:endParaRPr lang="en-US" sz="1500" dirty="0"/>
+          </a:p>
+        </p:txBody>
+      </p:sp>
+      <p:sp>
+        <p:nvSpPr>
+          <p:cNvPr id="25" name="Box body Email"/>
+          <p:cNvSpPr txBox="1"/>
+          <p:nvPr/>
+        </p:nvSpPr>
+        <p:spPr>
+          <a:xfrm>
+            <a:off x="7196328" y="2194560"/>
+            <a:ext cx="1188720" cy="777240"/>
+          </a:xfrm>
+          <a:prstGeom prst="rect">
+            <a:avLst/>
+          </a:prstGeom>
+          <a:noFill/>
+          <a:ln/>
+        </p:spPr>
+        <p:txBody>
+          <a:bodyPr wrap="square" lIns="0" tIns="0" rIns="0" bIns="0" rtlCol="0" anchor="t"/>
+          <a:lstStyle/>
+          <a:p>
+            <a:pPr indent="0" marL="0">
+              <a:buNone/>
+            </a:pPr>
+            <a:r>
+              <a:rPr lang="en-US" sz="1200" dirty="0">
+                <a:solidFill>
+                  <a:schemeClr val="tx2"/>
+                </a:solidFill>
+              </a:rPr>
+              <a:t>Firebase email digest</a:t>
+            </a:r>
             <a:endParaRPr lang="en-US" sz="1200" dirty="0"/>
           </a:p>
         </p:txBody>
       </p:sp>
       <p:sp>
         <p:nvSpPr>
-          <p:cNvPr id="9" name="Next list"/>
+          <p:cNvPr id="26" name="Box status Email"/>
           <p:cNvSpPr txBox="1"/>
           <p:nvPr/>
         </p:nvSpPr>
         <p:spPr>
           <a:xfrm>
-            <a:off x="4937760" y="1920240"/>
-            <a:ext cx="3383280" cy="2286000"/>
-          </a:xfrm>
-          <a:prstGeom prst="rect">
-            <a:avLst/>
-          </a:prstGeom>
-          <a:noFill/>
-          <a:ln/>
-        </p:spPr>
-        <p:txBody>
-          <a:bodyPr wrap="square" lIns="0" tIns="0" rIns="0" bIns="0" rtlCol="0" anchor="t"/>
-          <a:lstStyle/>
-          <a:p>
-            <a:pPr marL="342900" indent="-342900">
-              <a:spcAft>
-                <a:spcPts val="800"/>
-              </a:spcAft>
-              <a:buSzPct val="100000"/>
-              <a:buChar char="•"/>
-            </a:pPr>
-            <a:r>
-              <a:rPr lang="en-US" sz="1400" dirty="0">
-                <a:solidFill>
-                  <a:schemeClr val="bg1"/>
-                </a:solidFill>
-              </a:rPr>
-              <a:t>Deploy on Cloud Run with a daily Scheduler job</a:t>
-            </a:r>
-            <a:endParaRPr lang="en-US" sz="1400" dirty="0"/>
-          </a:p>
-          <a:p>
-            <a:pPr marL="342900" indent="-342900">
-              <a:spcAft>
-                <a:spcPts val="800"/>
-              </a:spcAft>
-              <a:buSzPct val="100000"/>
-              <a:buChar char="•"/>
-            </a:pPr>
-            <a:r>
-              <a:rPr lang="en-US" sz="1400" dirty="0">
-                <a:solidFill>
-                  <a:schemeClr val="bg1"/>
-                </a:solidFill>
-              </a:rPr>
-              <a:t>Store real price history in Firestore</a:t>
-            </a:r>
-            <a:endParaRPr lang="en-US" sz="1400" dirty="0"/>
-          </a:p>
-          <a:p>
-            <a:pPr marL="342900" indent="-342900">
-              <a:spcAft>
-                <a:spcPts val="800"/>
-              </a:spcAft>
-              <a:buSzPct val="100000"/>
-              <a:buChar char="•"/>
-            </a:pPr>
-            <a:r>
-              <a:rPr lang="en-US" sz="1400" dirty="0">
-                <a:solidFill>
-                  <a:schemeClr val="bg1"/>
-                </a:solidFill>
-              </a:rPr>
-              <a:t>Send the digest by email</a:t>
-            </a:r>
-            <a:endParaRPr lang="en-US" sz="1400" dirty="0"/>
-          </a:p>
-          <a:p>
-            <a:pPr marL="342900" indent="-342900">
-              <a:spcAft>
-                <a:spcPts val="800"/>
-              </a:spcAft>
-              <a:buSzPct val="100000"/>
-              <a:buChar char="•"/>
-            </a:pPr>
-            <a:r>
-              <a:rPr lang="en-US" sz="1400" dirty="0">
-                <a:solidFill>
-                  <a:schemeClr val="bg1"/>
-                </a:solidFill>
-              </a:rPr>
-              <a:t>Retailer APIs, more categories</a:t>
-            </a:r>
-            <a:endParaRPr lang="en-US" sz="1400" dirty="0"/>
+            <a:off x="7196328" y="3063240"/>
+            <a:ext cx="1188720" cy="228600"/>
+          </a:xfrm>
+          <a:prstGeom prst="rect">
+            <a:avLst/>
+          </a:prstGeom>
+          <a:noFill/>
+          <a:ln/>
+        </p:spPr>
+        <p:txBody>
+          <a:bodyPr wrap="square" lIns="0" tIns="0" rIns="0" bIns="0" rtlCol="0" anchor="ctr"/>
+          <a:lstStyle/>
+          <a:p>
+            <a:pPr indent="0" marL="0">
+              <a:buNone/>
+            </a:pPr>
+            <a:r>
+              <a:rPr lang="en-US" sz="1100" b="1" spc="200" kern="0" dirty="0">
+                <a:solidFill>
+                  <a:schemeClr val="accent2"/>
+                </a:solidFill>
+              </a:rPr>
+              <a:t>NEXT</a:t>
+            </a:r>
+            <a:endParaRPr lang="en-US" sz="1100" dirty="0"/>
+          </a:p>
+        </p:txBody>
+      </p:sp>
+      <p:sp>
+        <p:nvSpPr>
+          <p:cNvPr id="27" name="Interface note"/>
+          <p:cNvSpPr txBox="1"/>
+          <p:nvPr/>
+        </p:nvSpPr>
+        <p:spPr>
+          <a:xfrm>
+            <a:off x="548640" y="3794760"/>
+            <a:ext cx="8046720" cy="365760"/>
+          </a:xfrm>
+          <a:prstGeom prst="rect">
+            <a:avLst/>
+          </a:prstGeom>
+          <a:noFill/>
+          <a:ln/>
+        </p:spPr>
+        <p:txBody>
+          <a:bodyPr wrap="square" lIns="0" tIns="0" rIns="0" bIns="0" rtlCol="0" anchor="ctr"/>
+          <a:lstStyle/>
+          <a:p>
+            <a:pPr indent="0" marL="0">
+              <a:buNone/>
+            </a:pPr>
+            <a:r>
+              <a:rPr lang="en-US" sz="1600" b="1" dirty="0">
+                <a:solidFill>
+                  <a:schemeClr val="tx1"/>
+                </a:solidFill>
+              </a:rPr>
+              <a:t>One PriceSource interface: Google Search today, retailer APIs as we scale.</a:t>
+            </a:r>
+            <a:endParaRPr lang="en-US" sz="1600" dirty="0"/>
+          </a:p>
+        </p:txBody>
+      </p:sp>
+      <p:sp>
+        <p:nvSpPr>
+          <p:cNvPr id="28" name="Prototype note"/>
+          <p:cNvSpPr txBox="1"/>
+          <p:nvPr/>
+        </p:nvSpPr>
+        <p:spPr>
+          <a:xfrm>
+            <a:off x="548640" y="4206240"/>
+            <a:ext cx="8046720" cy="320040"/>
+          </a:xfrm>
+          <a:prstGeom prst="rect">
+            <a:avLst/>
+          </a:prstGeom>
+          <a:noFill/>
+          <a:ln/>
+        </p:spPr>
+        <p:txBody>
+          <a:bodyPr wrap="square" lIns="0" tIns="0" rIns="0" bIns="0" rtlCol="0" anchor="ctr"/>
+          <a:lstStyle/>
+          <a:p>
+            <a:pPr indent="0" marL="0">
+              <a:buNone/>
+            </a:pPr>
+            <a:r>
+              <a:rPr lang="en-US" sz="1300" dirty="0">
+                <a:solidFill>
+                  <a:schemeClr val="accent4"/>
+                </a:solidFill>
+              </a:rPr>
+              <a:t>In the prototype, prices are saved to a local file and the digest is written as HTML.</a:t>
+            </a:r>
+            <a:endParaRPr lang="en-US" sz="1300" dirty="0"/>
           </a:p>
         </p:txBody>
       </p:sp>

</xml_diff>